<commit_message>
deck: stop bouncing between why and what
The three opening slides ran problem, product, background — so a reader met
the app, then got pulled back to market conditions before meeting it
properly again on the next six slides. Two entries into the same section.

"Why now" moves ahead of "what joining them buys". The case closes on the
regulatory timing and does not reopen; the slide after it is the first one
about the app, and everything from there — signup, features, triage — stays
on that side.

Co-Authored-By: Claude Opus 5 <noreply@anthropic.com>
</commit_message>
<xml_diff>
--- a/PharmaCare_紹介資料.pptx
+++ b/PharmaCare_紹介資料.pptx
@@ -16822,7 +16822,7 @@
                 <a:ea typeface="Yu Gothic" pitchFamily="34" charset="-122"/>
                 <a:cs typeface="Yu Gothic" pitchFamily="34" charset="-120"/>
               </a:rPr>
-              <a:t>つなぐと、その人に合わせられる</a:t>
+              <a:t>なぜ、今つくるのか</a:t>
             </a:r>
             <a:endParaRPr lang="en-US" sz="3600" dirty="0"/>
           </a:p>
@@ -16861,7 +16861,7 @@
                 <a:ea typeface="Yu Gothic" pitchFamily="34" charset="-122"/>
                 <a:cs typeface="Yu Gothic" pitchFamily="34" charset="-120"/>
               </a:rPr>
-              <a:t>同じ画面に薬と体調があるから、一般論ではなく目の前の人の話にできる</a:t>
+              <a:t>制度の流れが、施設と薬局を近づけている</a:t>
             </a:r>
             <a:endParaRPr lang="en-US" sz="1600" dirty="0"/>
           </a:p>
@@ -16875,12 +16875,547 @@
         </p:nvSpPr>
         <p:spPr>
           <a:xfrm>
-            <a:off x="731520" y="1920240"/>
-            <a:ext cx="3413455" cy="2651760"/>
+            <a:off x="731520" y="1874520"/>
+            <a:ext cx="475488" cy="475488"/>
+          </a:xfrm>
+          <a:prstGeom prst="ellipse">
+            <a:avLst/>
+          </a:prstGeom>
+          <a:solidFill>
+            <a:srgbClr val="3E8E84"/>
+          </a:solidFill>
+          <a:ln w="12700">
+            <a:solidFill>
+              <a:srgbClr val="3E8E84"/>
+            </a:solidFill>
+            <a:prstDash val="solid"/>
+          </a:ln>
+        </p:spPr>
+      </p:sp>
+      <p:sp>
+        <p:nvSpPr>
+          <p:cNvPr id="5" name="Text 3"/>
+          <p:cNvSpPr/>
+          <p:nvPr/>
+        </p:nvSpPr>
+        <p:spPr>
+          <a:xfrm>
+            <a:off x="731520" y="1874520"/>
+            <a:ext cx="475488" cy="475488"/>
+          </a:xfrm>
+          <a:prstGeom prst="rect">
+            <a:avLst/>
+          </a:prstGeom>
+          <a:noFill/>
+          <a:ln/>
+        </p:spPr>
+        <p:txBody>
+          <a:bodyPr wrap="square" lIns="0" tIns="0" rIns="0" bIns="0" rtlCol="0" anchor="ctr"/>
+          <a:lstStyle/>
+          <a:p>
+            <a:pPr algn="ctr" indent="0" marL="0">
+              <a:buNone/>
+            </a:pPr>
+            <a:r>
+              <a:rPr lang="en-US" sz="1500" b="1" dirty="0">
+                <a:solidFill>
+                  <a:srgbClr val="FFFFFF"/>
+                </a:solidFill>
+                <a:latin typeface="Yu Gothic" pitchFamily="34" charset="0"/>
+                <a:ea typeface="Yu Gothic" pitchFamily="34" charset="-122"/>
+                <a:cs typeface="Yu Gothic" pitchFamily="34" charset="-120"/>
+              </a:rPr>
+              <a:t>1</a:t>
+            </a:r>
+            <a:endParaRPr lang="en-US" sz="1500" dirty="0"/>
+          </a:p>
+        </p:txBody>
+      </p:sp>
+      <p:sp>
+        <p:nvSpPr>
+          <p:cNvPr id="6" name="Text 4"/>
+          <p:cNvSpPr/>
+          <p:nvPr/>
+        </p:nvSpPr>
+        <p:spPr>
+          <a:xfrm>
+            <a:off x="1417320" y="1828800"/>
+            <a:ext cx="9966960" cy="411480"/>
+          </a:xfrm>
+          <a:prstGeom prst="rect">
+            <a:avLst/>
+          </a:prstGeom>
+          <a:noFill/>
+          <a:ln/>
+        </p:spPr>
+        <p:txBody>
+          <a:bodyPr wrap="square" lIns="0" tIns="0" rIns="0" bIns="0" rtlCol="0" anchor="ctr"/>
+          <a:lstStyle/>
+          <a:p>
+            <a:pPr indent="0" marL="0">
+              <a:buNone/>
+            </a:pPr>
+            <a:r>
+              <a:rPr lang="en-US" sz="1800" b="1" dirty="0">
+                <a:solidFill>
+                  <a:srgbClr val="14504B"/>
+                </a:solidFill>
+                <a:latin typeface="Yu Gothic" pitchFamily="34" charset="0"/>
+                <a:ea typeface="Yu Gothic" pitchFamily="34" charset="-122"/>
+                <a:cs typeface="Yu Gothic" pitchFamily="34" charset="-120"/>
+              </a:rPr>
+              <a:t>在宅・施設への訪問が国の方向</a:t>
+            </a:r>
+            <a:endParaRPr lang="en-US" sz="1800" dirty="0"/>
+          </a:p>
+        </p:txBody>
+      </p:sp>
+      <p:sp>
+        <p:nvSpPr>
+          <p:cNvPr id="7" name="Text 5"/>
+          <p:cNvSpPr/>
+          <p:nvPr/>
+        </p:nvSpPr>
+        <p:spPr>
+          <a:xfrm>
+            <a:off x="1417320" y="2240280"/>
+            <a:ext cx="9966960" cy="822960"/>
+          </a:xfrm>
+          <a:prstGeom prst="rect">
+            <a:avLst/>
+          </a:prstGeom>
+          <a:noFill/>
+          <a:ln/>
+        </p:spPr>
+        <p:txBody>
+          <a:bodyPr wrap="square" lIns="0" tIns="0" rIns="0" bIns="0" rtlCol="0" anchor="ctr"/>
+          <a:lstStyle/>
+          <a:p>
+            <a:pPr indent="0" marL="0">
+              <a:lnSpc>
+                <a:spcPct val="120000"/>
+              </a:lnSpc>
+              <a:buNone/>
+            </a:pPr>
+            <a:r>
+              <a:rPr lang="en-US" sz="1350" dirty="0">
+                <a:solidFill>
+                  <a:srgbClr val="16211F"/>
+                </a:solidFill>
+                <a:latin typeface="Yu Gothic" pitchFamily="34" charset="0"/>
+                <a:ea typeface="Yu Gothic" pitchFamily="34" charset="-122"/>
+                <a:cs typeface="Yu Gothic" pitchFamily="34" charset="-120"/>
+              </a:rPr>
+              <a:t>薬剤師の役割は「薬を渡す」から「渡したあとを見る」へ移っている。</a:t>
+            </a:r>
+            <a:endParaRPr lang="en-US" sz="1350" dirty="0"/>
+          </a:p>
+          <a:p>
+            <a:pPr indent="0" marL="0">
+              <a:lnSpc>
+                <a:spcPct val="120000"/>
+              </a:lnSpc>
+              <a:buNone/>
+            </a:pPr>
+            <a:r>
+              <a:rPr lang="en-US" sz="1350" dirty="0">
+                <a:solidFill>
+                  <a:srgbClr val="16211F"/>
+                </a:solidFill>
+                <a:latin typeface="Yu Gothic" pitchFamily="34" charset="0"/>
+                <a:ea typeface="Yu Gothic" pitchFamily="34" charset="-122"/>
+                <a:cs typeface="Yu Gothic" pitchFamily="34" charset="-120"/>
+              </a:rPr>
+              <a:t>施設に足を運ぶ機会は今後さらに増える。</a:t>
+            </a:r>
+            <a:endParaRPr lang="en-US" sz="1350" dirty="0"/>
+          </a:p>
+        </p:txBody>
+      </p:sp>
+      <p:sp>
+        <p:nvSpPr>
+          <p:cNvPr id="8" name="Shape 6"/>
+          <p:cNvSpPr/>
+          <p:nvPr/>
+        </p:nvSpPr>
+        <p:spPr>
+          <a:xfrm>
+            <a:off x="731520" y="3172968"/>
+            <a:ext cx="475488" cy="475488"/>
+          </a:xfrm>
+          <a:prstGeom prst="ellipse">
+            <a:avLst/>
+          </a:prstGeom>
+          <a:solidFill>
+            <a:srgbClr val="3E8E84"/>
+          </a:solidFill>
+          <a:ln w="12700">
+            <a:solidFill>
+              <a:srgbClr val="3E8E84"/>
+            </a:solidFill>
+            <a:prstDash val="solid"/>
+          </a:ln>
+        </p:spPr>
+      </p:sp>
+      <p:sp>
+        <p:nvSpPr>
+          <p:cNvPr id="9" name="Text 7"/>
+          <p:cNvSpPr/>
+          <p:nvPr/>
+        </p:nvSpPr>
+        <p:spPr>
+          <a:xfrm>
+            <a:off x="731520" y="3172968"/>
+            <a:ext cx="475488" cy="475488"/>
+          </a:xfrm>
+          <a:prstGeom prst="rect">
+            <a:avLst/>
+          </a:prstGeom>
+          <a:noFill/>
+          <a:ln/>
+        </p:spPr>
+        <p:txBody>
+          <a:bodyPr wrap="square" lIns="0" tIns="0" rIns="0" bIns="0" rtlCol="0" anchor="ctr"/>
+          <a:lstStyle/>
+          <a:p>
+            <a:pPr algn="ctr" indent="0" marL="0">
+              <a:buNone/>
+            </a:pPr>
+            <a:r>
+              <a:rPr lang="en-US" sz="1500" b="1" dirty="0">
+                <a:solidFill>
+                  <a:srgbClr val="FFFFFF"/>
+                </a:solidFill>
+                <a:latin typeface="Yu Gothic" pitchFamily="34" charset="0"/>
+                <a:ea typeface="Yu Gothic" pitchFamily="34" charset="-122"/>
+                <a:cs typeface="Yu Gothic" pitchFamily="34" charset="-120"/>
+              </a:rPr>
+              <a:t>2</a:t>
+            </a:r>
+            <a:endParaRPr lang="en-US" sz="1500" dirty="0"/>
+          </a:p>
+        </p:txBody>
+      </p:sp>
+      <p:sp>
+        <p:nvSpPr>
+          <p:cNvPr id="10" name="Text 8"/>
+          <p:cNvSpPr/>
+          <p:nvPr/>
+        </p:nvSpPr>
+        <p:spPr>
+          <a:xfrm>
+            <a:off x="1417320" y="3127248"/>
+            <a:ext cx="9966960" cy="411480"/>
+          </a:xfrm>
+          <a:prstGeom prst="rect">
+            <a:avLst/>
+          </a:prstGeom>
+          <a:noFill/>
+          <a:ln/>
+        </p:spPr>
+        <p:txBody>
+          <a:bodyPr wrap="square" lIns="0" tIns="0" rIns="0" bIns="0" rtlCol="0" anchor="ctr"/>
+          <a:lstStyle/>
+          <a:p>
+            <a:pPr indent="0" marL="0">
+              <a:buNone/>
+            </a:pPr>
+            <a:r>
+              <a:rPr lang="en-US" sz="1800" b="1" dirty="0">
+                <a:solidFill>
+                  <a:srgbClr val="14504B"/>
+                </a:solidFill>
+                <a:latin typeface="Yu Gothic" pitchFamily="34" charset="0"/>
+                <a:ea typeface="Yu Gothic" pitchFamily="34" charset="-122"/>
+                <a:cs typeface="Yu Gothic" pitchFamily="34" charset="-120"/>
+              </a:rPr>
+              <a:t>門前から面へ</a:t>
+            </a:r>
+            <a:endParaRPr lang="en-US" sz="1800" dirty="0"/>
+          </a:p>
+        </p:txBody>
+      </p:sp>
+      <p:sp>
+        <p:nvSpPr>
+          <p:cNvPr id="11" name="Text 9"/>
+          <p:cNvSpPr/>
+          <p:nvPr/>
+        </p:nvSpPr>
+        <p:spPr>
+          <a:xfrm>
+            <a:off x="1417320" y="3538728"/>
+            <a:ext cx="9966960" cy="822960"/>
+          </a:xfrm>
+          <a:prstGeom prst="rect">
+            <a:avLst/>
+          </a:prstGeom>
+          <a:noFill/>
+          <a:ln/>
+        </p:spPr>
+        <p:txBody>
+          <a:bodyPr wrap="square" lIns="0" tIns="0" rIns="0" bIns="0" rtlCol="0" anchor="ctr"/>
+          <a:lstStyle/>
+          <a:p>
+            <a:pPr indent="0" marL="0">
+              <a:lnSpc>
+                <a:spcPct val="120000"/>
+              </a:lnSpc>
+              <a:buNone/>
+            </a:pPr>
+            <a:r>
+              <a:rPr lang="en-US" sz="1350" dirty="0">
+                <a:solidFill>
+                  <a:srgbClr val="16211F"/>
+                </a:solidFill>
+                <a:latin typeface="Yu Gothic" pitchFamily="34" charset="0"/>
+                <a:ea typeface="Yu Gothic" pitchFamily="34" charset="-122"/>
+                <a:cs typeface="Yu Gothic" pitchFamily="34" charset="-120"/>
+              </a:rPr>
+              <a:t>特定の病院の前に構える薬局から、地域のどの処方箋も受ける薬局へ。</a:t>
+            </a:r>
+            <a:endParaRPr lang="en-US" sz="1350" dirty="0"/>
+          </a:p>
+          <a:p>
+            <a:pPr indent="0" marL="0">
+              <a:lnSpc>
+                <a:spcPct val="120000"/>
+              </a:lnSpc>
+              <a:buNone/>
+            </a:pPr>
+            <a:r>
+              <a:rPr lang="en-US" sz="1350" dirty="0">
+                <a:solidFill>
+                  <a:srgbClr val="16211F"/>
+                </a:solidFill>
+                <a:latin typeface="Yu Gothic" pitchFamily="34" charset="0"/>
+                <a:ea typeface="Yu Gothic" pitchFamily="34" charset="-122"/>
+                <a:cs typeface="Yu Gothic" pitchFamily="34" charset="-120"/>
+              </a:rPr>
+              <a:t>処方元に電話すれば済んでいたことが、済まなくなる。</a:t>
+            </a:r>
+            <a:endParaRPr lang="en-US" sz="1350" dirty="0"/>
+          </a:p>
+          <a:p>
+            <a:pPr indent="0" marL="0">
+              <a:lnSpc>
+                <a:spcPct val="120000"/>
+              </a:lnSpc>
+              <a:buNone/>
+            </a:pPr>
+            <a:r>
+              <a:rPr lang="en-US" sz="1350" dirty="0">
+                <a:solidFill>
+                  <a:srgbClr val="16211F"/>
+                </a:solidFill>
+                <a:latin typeface="Yu Gothic" pitchFamily="34" charset="0"/>
+                <a:ea typeface="Yu Gothic" pitchFamily="34" charset="-122"/>
+                <a:cs typeface="Yu Gothic" pitchFamily="34" charset="-120"/>
+              </a:rPr>
+              <a:t>患者の薬を薬局側で一元的に把握する必要が出てくる。</a:t>
+            </a:r>
+            <a:endParaRPr lang="en-US" sz="1350" dirty="0"/>
+          </a:p>
+        </p:txBody>
+      </p:sp>
+      <p:sp>
+        <p:nvSpPr>
+          <p:cNvPr id="12" name="Shape 10"/>
+          <p:cNvSpPr/>
+          <p:nvPr/>
+        </p:nvSpPr>
+        <p:spPr>
+          <a:xfrm>
+            <a:off x="731520" y="4471416"/>
+            <a:ext cx="475488" cy="475488"/>
+          </a:xfrm>
+          <a:prstGeom prst="ellipse">
+            <a:avLst/>
+          </a:prstGeom>
+          <a:solidFill>
+            <a:srgbClr val="3E8E84"/>
+          </a:solidFill>
+          <a:ln w="12700">
+            <a:solidFill>
+              <a:srgbClr val="3E8E84"/>
+            </a:solidFill>
+            <a:prstDash val="solid"/>
+          </a:ln>
+        </p:spPr>
+      </p:sp>
+      <p:sp>
+        <p:nvSpPr>
+          <p:cNvPr id="13" name="Text 11"/>
+          <p:cNvSpPr/>
+          <p:nvPr/>
+        </p:nvSpPr>
+        <p:spPr>
+          <a:xfrm>
+            <a:off x="731520" y="4471416"/>
+            <a:ext cx="475488" cy="475488"/>
+          </a:xfrm>
+          <a:prstGeom prst="rect">
+            <a:avLst/>
+          </a:prstGeom>
+          <a:noFill/>
+          <a:ln/>
+        </p:spPr>
+        <p:txBody>
+          <a:bodyPr wrap="square" lIns="0" tIns="0" rIns="0" bIns="0" rtlCol="0" anchor="ctr"/>
+          <a:lstStyle/>
+          <a:p>
+            <a:pPr algn="ctr" indent="0" marL="0">
+              <a:buNone/>
+            </a:pPr>
+            <a:r>
+              <a:rPr lang="en-US" sz="1500" b="1" dirty="0">
+                <a:solidFill>
+                  <a:srgbClr val="FFFFFF"/>
+                </a:solidFill>
+                <a:latin typeface="Yu Gothic" pitchFamily="34" charset="0"/>
+                <a:ea typeface="Yu Gothic" pitchFamily="34" charset="-122"/>
+                <a:cs typeface="Yu Gothic" pitchFamily="34" charset="-120"/>
+              </a:rPr>
+              <a:t>3</a:t>
+            </a:r>
+            <a:endParaRPr lang="en-US" sz="1500" dirty="0"/>
+          </a:p>
+        </p:txBody>
+      </p:sp>
+      <p:sp>
+        <p:nvSpPr>
+          <p:cNvPr id="14" name="Text 12"/>
+          <p:cNvSpPr/>
+          <p:nvPr/>
+        </p:nvSpPr>
+        <p:spPr>
+          <a:xfrm>
+            <a:off x="1417320" y="4425696"/>
+            <a:ext cx="9966960" cy="411480"/>
+          </a:xfrm>
+          <a:prstGeom prst="rect">
+            <a:avLst/>
+          </a:prstGeom>
+          <a:noFill/>
+          <a:ln/>
+        </p:spPr>
+        <p:txBody>
+          <a:bodyPr wrap="square" lIns="0" tIns="0" rIns="0" bIns="0" rtlCol="0" anchor="ctr"/>
+          <a:lstStyle/>
+          <a:p>
+            <a:pPr indent="0" marL="0">
+              <a:buNone/>
+            </a:pPr>
+            <a:r>
+              <a:rPr lang="en-US" sz="1800" b="1" dirty="0">
+                <a:solidFill>
+                  <a:srgbClr val="14504B"/>
+                </a:solidFill>
+                <a:latin typeface="Yu Gothic" pitchFamily="34" charset="0"/>
+                <a:ea typeface="Yu Gothic" pitchFamily="34" charset="-122"/>
+                <a:cs typeface="Yu Gothic" pitchFamily="34" charset="-120"/>
+              </a:rPr>
+              <a:t>服薬期間中のフォローアップは、すでに義務</a:t>
+            </a:r>
+            <a:endParaRPr lang="en-US" sz="1800" dirty="0"/>
+          </a:p>
+        </p:txBody>
+      </p:sp>
+      <p:sp>
+        <p:nvSpPr>
+          <p:cNvPr id="15" name="Text 13"/>
+          <p:cNvSpPr/>
+          <p:nvPr/>
+        </p:nvSpPr>
+        <p:spPr>
+          <a:xfrm>
+            <a:off x="1417320" y="4837176"/>
+            <a:ext cx="9966960" cy="822960"/>
+          </a:xfrm>
+          <a:prstGeom prst="rect">
+            <a:avLst/>
+          </a:prstGeom>
+          <a:noFill/>
+          <a:ln/>
+        </p:spPr>
+        <p:txBody>
+          <a:bodyPr wrap="square" lIns="0" tIns="0" rIns="0" bIns="0" rtlCol="0" anchor="ctr"/>
+          <a:lstStyle/>
+          <a:p>
+            <a:pPr indent="0" marL="0">
+              <a:lnSpc>
+                <a:spcPct val="120000"/>
+              </a:lnSpc>
+              <a:buNone/>
+            </a:pPr>
+            <a:r>
+              <a:rPr lang="en-US" sz="1350" dirty="0">
+                <a:solidFill>
+                  <a:srgbClr val="16211F"/>
+                </a:solidFill>
+                <a:latin typeface="Yu Gothic" pitchFamily="34" charset="0"/>
+                <a:ea typeface="Yu Gothic" pitchFamily="34" charset="-122"/>
+                <a:cs typeface="Yu Gothic" pitchFamily="34" charset="-120"/>
+              </a:rPr>
+              <a:t>2020年9月施行の改正薬機法・薬剤師法で、渡したあとの服薬状況を</a:t>
+            </a:r>
+            <a:endParaRPr lang="en-US" sz="1350" dirty="0"/>
+          </a:p>
+          <a:p>
+            <a:pPr indent="0" marL="0">
+              <a:lnSpc>
+                <a:spcPct val="120000"/>
+              </a:lnSpc>
+              <a:buNone/>
+            </a:pPr>
+            <a:r>
+              <a:rPr lang="en-US" sz="1350" dirty="0">
+                <a:solidFill>
+                  <a:srgbClr val="16211F"/>
+                </a:solidFill>
+                <a:latin typeface="Yu Gothic" pitchFamily="34" charset="0"/>
+                <a:ea typeface="Yu Gothic" pitchFamily="34" charset="-122"/>
+                <a:cs typeface="Yu Gothic" pitchFamily="34" charset="-120"/>
+              </a:rPr>
+              <a:t>継続的に把握することが薬剤師の責務になった。</a:t>
+            </a:r>
+            <a:endParaRPr lang="en-US" sz="1350" dirty="0"/>
+          </a:p>
+          <a:p>
+            <a:pPr indent="0" marL="0">
+              <a:lnSpc>
+                <a:spcPct val="120000"/>
+              </a:lnSpc>
+              <a:buNone/>
+            </a:pPr>
+            <a:r>
+              <a:rPr lang="en-US" sz="1350" dirty="0">
+                <a:solidFill>
+                  <a:srgbClr val="16211F"/>
+                </a:solidFill>
+                <a:latin typeface="Yu Gothic" pitchFamily="34" charset="0"/>
+                <a:ea typeface="Yu Gothic" pitchFamily="34" charset="-122"/>
+                <a:cs typeface="Yu Gothic" pitchFamily="34" charset="-120"/>
+              </a:rPr>
+              <a:t>ただし現場の手段は電話が中心で、続けるのが難しい。</a:t>
+            </a:r>
+            <a:endParaRPr lang="en-US" sz="1350" dirty="0"/>
+          </a:p>
+        </p:txBody>
+      </p:sp>
+      <p:sp>
+        <p:nvSpPr>
+          <p:cNvPr id="16" name="Shape 14"/>
+          <p:cNvSpPr/>
+          <p:nvPr/>
+        </p:nvSpPr>
+        <p:spPr>
+          <a:xfrm>
+            <a:off x="731520" y="5760720"/>
+            <a:ext cx="10698480" cy="777240"/>
           </a:xfrm>
           <a:prstGeom prst="roundRect">
             <a:avLst>
-              <a:gd name="adj" fmla="val 2759"/>
+              <a:gd name="adj" fmla="val 9412"/>
             </a:avLst>
           </a:prstGeom>
           <a:solidFill>
@@ -16896,847 +17431,40 @@
       </p:sp>
       <p:sp>
         <p:nvSpPr>
-          <p:cNvPr id="5" name="Shape 3"/>
-          <p:cNvSpPr/>
-          <p:nvPr/>
-        </p:nvSpPr>
-        <p:spPr>
-          <a:xfrm>
-            <a:off x="1005840" y="2148840"/>
-            <a:ext cx="457200" cy="457200"/>
-          </a:xfrm>
-          <a:prstGeom prst="ellipse">
-            <a:avLst/>
-          </a:prstGeom>
-          <a:solidFill>
-            <a:srgbClr val="14504B"/>
-          </a:solidFill>
-          <a:ln w="12700">
-            <a:solidFill>
-              <a:srgbClr val="14504B"/>
-            </a:solidFill>
-            <a:prstDash val="solid"/>
-          </a:ln>
-        </p:spPr>
-      </p:sp>
-      <p:sp>
-        <p:nvSpPr>
-          <p:cNvPr id="6" name="Text 4"/>
-          <p:cNvSpPr/>
-          <p:nvPr/>
-        </p:nvSpPr>
-        <p:spPr>
-          <a:xfrm>
-            <a:off x="1005840" y="2148840"/>
-            <a:ext cx="457200" cy="457200"/>
-          </a:xfrm>
-          <a:prstGeom prst="rect">
-            <a:avLst/>
-          </a:prstGeom>
-          <a:noFill/>
-          <a:ln/>
-        </p:spPr>
-        <p:txBody>
-          <a:bodyPr wrap="square" lIns="0" tIns="0" rIns="0" bIns="0" rtlCol="0" anchor="ctr"/>
-          <a:lstStyle/>
-          <a:p>
-            <a:pPr algn="ctr" indent="0" marL="0">
+          <p:cNvPr id="17" name="Text 15"/>
+          <p:cNvSpPr/>
+          <p:nvPr/>
+        </p:nvSpPr>
+        <p:spPr>
+          <a:xfrm>
+            <a:off x="1051560" y="5760720"/>
+            <a:ext cx="10058400" cy="777240"/>
+          </a:xfrm>
+          <a:prstGeom prst="rect">
+            <a:avLst/>
+          </a:prstGeom>
+          <a:noFill/>
+          <a:ln/>
+        </p:spPr>
+        <p:txBody>
+          <a:bodyPr wrap="square" lIns="0" tIns="0" rIns="0" bIns="0" rtlCol="0" anchor="ctr"/>
+          <a:lstStyle/>
+          <a:p>
+            <a:pPr indent="0" marL="0">
               <a:buNone/>
             </a:pPr>
             <a:r>
               <a:rPr lang="en-US" sz="1500" b="1" dirty="0">
                 <a:solidFill>
-                  <a:srgbClr val="FFFFFF"/>
-                </a:solidFill>
-                <a:latin typeface="Yu Gothic" pitchFamily="34" charset="0"/>
-                <a:ea typeface="Yu Gothic" pitchFamily="34" charset="-122"/>
-                <a:cs typeface="Yu Gothic" pitchFamily="34" charset="-120"/>
-              </a:rPr>
-              <a:t>1</a:t>
+                  <a:srgbClr val="14504B"/>
+                </a:solidFill>
+                <a:latin typeface="Yu Gothic" pitchFamily="34" charset="0"/>
+                <a:ea typeface="Yu Gothic" pitchFamily="34" charset="-122"/>
+                <a:cs typeface="Yu Gothic" pitchFamily="34" charset="-120"/>
+              </a:rPr>
+              <a:t>義務だから電話をかけるのではなく、続けられる形にする。それが結果として、選ばれる薬局につながる</a:t>
             </a:r>
             <a:endParaRPr lang="en-US" sz="1500" dirty="0"/>
-          </a:p>
-        </p:txBody>
-      </p:sp>
-      <p:sp>
-        <p:nvSpPr>
-          <p:cNvPr id="7" name="Text 5"/>
-          <p:cNvSpPr/>
-          <p:nvPr/>
-        </p:nvSpPr>
-        <p:spPr>
-          <a:xfrm>
-            <a:off x="1600200" y="2176272"/>
-            <a:ext cx="2316175" cy="411480"/>
-          </a:xfrm>
-          <a:prstGeom prst="rect">
-            <a:avLst/>
-          </a:prstGeom>
-          <a:noFill/>
-          <a:ln/>
-        </p:spPr>
-        <p:txBody>
-          <a:bodyPr wrap="square" lIns="0" tIns="0" rIns="0" bIns="0" rtlCol="0" anchor="ctr"/>
-          <a:lstStyle/>
-          <a:p>
-            <a:pPr indent="0" marL="0">
-              <a:buNone/>
-            </a:pPr>
-            <a:r>
-              <a:rPr lang="en-US" sz="1700" b="1" dirty="0">
-                <a:solidFill>
-                  <a:srgbClr val="14504B"/>
-                </a:solidFill>
-                <a:latin typeface="Yu Gothic" pitchFamily="34" charset="0"/>
-                <a:ea typeface="Yu Gothic" pitchFamily="34" charset="-122"/>
-                <a:cs typeface="Yu Gothic" pitchFamily="34" charset="-120"/>
-              </a:rPr>
-              <a:t>施設が記録する</a:t>
-            </a:r>
-            <a:endParaRPr lang="en-US" sz="1700" dirty="0"/>
-          </a:p>
-        </p:txBody>
-      </p:sp>
-      <p:sp>
-        <p:nvSpPr>
-          <p:cNvPr id="8" name="Text 6"/>
-          <p:cNvSpPr/>
-          <p:nvPr/>
-        </p:nvSpPr>
-        <p:spPr>
-          <a:xfrm>
-            <a:off x="1005840" y="2724912"/>
-            <a:ext cx="2956255" cy="1554480"/>
-          </a:xfrm>
-          <a:prstGeom prst="rect">
-            <a:avLst/>
-          </a:prstGeom>
-          <a:noFill/>
-          <a:ln/>
-        </p:spPr>
-        <p:txBody>
-          <a:bodyPr wrap="square" lIns="0" tIns="0" rIns="0" bIns="0" rtlCol="0" anchor="ctr"/>
-          <a:lstStyle/>
-          <a:p>
-            <a:pPr indent="0" marL="0">
-              <a:lnSpc>
-                <a:spcPct val="125000"/>
-              </a:lnSpc>
-              <a:buNone/>
-            </a:pPr>
-            <a:r>
-              <a:rPr lang="en-US" sz="1350" dirty="0">
-                <a:solidFill>
-                  <a:srgbClr val="16211F"/>
-                </a:solidFill>
-                <a:latin typeface="Yu Gothic" pitchFamily="34" charset="0"/>
-                <a:ea typeface="Yu Gothic" pitchFamily="34" charset="-122"/>
-                <a:cs typeface="Yu Gothic" pitchFamily="34" charset="-120"/>
-              </a:rPr>
-              <a:t>服薬の実施、血圧・体温・SpO₂。</a:t>
-            </a:r>
-            <a:endParaRPr lang="en-US" sz="1350" dirty="0"/>
-          </a:p>
-          <a:p>
-            <a:pPr indent="0" marL="0">
-              <a:lnSpc>
-                <a:spcPct val="125000"/>
-              </a:lnSpc>
-              <a:buNone/>
-            </a:pPr>
-            <a:r>
-              <a:rPr lang="en-US" sz="1350" dirty="0">
-                <a:solidFill>
-                  <a:srgbClr val="16211F"/>
-                </a:solidFill>
-                <a:latin typeface="Yu Gothic" pitchFamily="34" charset="0"/>
-                <a:ea typeface="Yu Gothic" pitchFamily="34" charset="-122"/>
-                <a:cs typeface="Yu Gothic" pitchFamily="34" charset="-120"/>
-              </a:rPr>
-              <a:t>いつも職員がつけている記録を、</a:t>
-            </a:r>
-            <a:endParaRPr lang="en-US" sz="1350" dirty="0"/>
-          </a:p>
-          <a:p>
-            <a:pPr indent="0" marL="0">
-              <a:lnSpc>
-                <a:spcPct val="125000"/>
-              </a:lnSpc>
-              <a:buNone/>
-            </a:pPr>
-            <a:r>
-              <a:rPr lang="en-US" sz="1350" dirty="0">
-                <a:solidFill>
-                  <a:srgbClr val="16211F"/>
-                </a:solidFill>
-                <a:latin typeface="Yu Gothic" pitchFamily="34" charset="0"/>
-                <a:ea typeface="Yu Gothic" pitchFamily="34" charset="-122"/>
-                <a:cs typeface="Yu Gothic" pitchFamily="34" charset="-120"/>
-              </a:rPr>
-              <a:t>そのまま入れる。</a:t>
-            </a:r>
-            <a:endParaRPr lang="en-US" sz="1350" dirty="0"/>
-          </a:p>
-        </p:txBody>
-      </p:sp>
-      <p:sp>
-        <p:nvSpPr>
-          <p:cNvPr id="9" name="Shape 7"/>
-          <p:cNvSpPr/>
-          <p:nvPr/>
-        </p:nvSpPr>
-        <p:spPr>
-          <a:xfrm>
-            <a:off x="4163263" y="3154680"/>
-            <a:ext cx="182880" cy="237744"/>
-          </a:xfrm>
-          <a:prstGeom prst="rightArrow">
-            <a:avLst/>
-          </a:prstGeom>
-          <a:solidFill>
-            <a:srgbClr val="A8CFC9"/>
-          </a:solidFill>
-          <a:ln w="12700">
-            <a:solidFill>
-              <a:srgbClr val="A8CFC9"/>
-            </a:solidFill>
-            <a:prstDash val="solid"/>
-          </a:ln>
-        </p:spPr>
-      </p:sp>
-      <p:sp>
-        <p:nvSpPr>
-          <p:cNvPr id="10" name="Shape 8"/>
-          <p:cNvSpPr/>
-          <p:nvPr/>
-        </p:nvSpPr>
-        <p:spPr>
-          <a:xfrm>
-            <a:off x="4373575" y="1920240"/>
-            <a:ext cx="3413455" cy="2651760"/>
-          </a:xfrm>
-          <a:prstGeom prst="roundRect">
-            <a:avLst>
-              <a:gd name="adj" fmla="val 2759"/>
-            </a:avLst>
-          </a:prstGeom>
-          <a:solidFill>
-            <a:srgbClr val="F1F6F5"/>
-          </a:solidFill>
-          <a:ln w="12700">
-            <a:solidFill>
-              <a:srgbClr val="F1F6F5"/>
-            </a:solidFill>
-            <a:prstDash val="solid"/>
-          </a:ln>
-        </p:spPr>
-      </p:sp>
-      <p:sp>
-        <p:nvSpPr>
-          <p:cNvPr id="11" name="Shape 9"/>
-          <p:cNvSpPr/>
-          <p:nvPr/>
-        </p:nvSpPr>
-        <p:spPr>
-          <a:xfrm>
-            <a:off x="4647895" y="2148840"/>
-            <a:ext cx="457200" cy="457200"/>
-          </a:xfrm>
-          <a:prstGeom prst="ellipse">
-            <a:avLst/>
-          </a:prstGeom>
-          <a:solidFill>
-            <a:srgbClr val="14504B"/>
-          </a:solidFill>
-          <a:ln w="12700">
-            <a:solidFill>
-              <a:srgbClr val="14504B"/>
-            </a:solidFill>
-            <a:prstDash val="solid"/>
-          </a:ln>
-        </p:spPr>
-      </p:sp>
-      <p:sp>
-        <p:nvSpPr>
-          <p:cNvPr id="12" name="Text 10"/>
-          <p:cNvSpPr/>
-          <p:nvPr/>
-        </p:nvSpPr>
-        <p:spPr>
-          <a:xfrm>
-            <a:off x="4647895" y="2148840"/>
-            <a:ext cx="457200" cy="457200"/>
-          </a:xfrm>
-          <a:prstGeom prst="rect">
-            <a:avLst/>
-          </a:prstGeom>
-          <a:noFill/>
-          <a:ln/>
-        </p:spPr>
-        <p:txBody>
-          <a:bodyPr wrap="square" lIns="0" tIns="0" rIns="0" bIns="0" rtlCol="0" anchor="ctr"/>
-          <a:lstStyle/>
-          <a:p>
-            <a:pPr algn="ctr" indent="0" marL="0">
-              <a:buNone/>
-            </a:pPr>
-            <a:r>
-              <a:rPr lang="en-US" sz="1500" b="1" dirty="0">
-                <a:solidFill>
-                  <a:srgbClr val="FFFFFF"/>
-                </a:solidFill>
-                <a:latin typeface="Yu Gothic" pitchFamily="34" charset="0"/>
-                <a:ea typeface="Yu Gothic" pitchFamily="34" charset="-122"/>
-                <a:cs typeface="Yu Gothic" pitchFamily="34" charset="-120"/>
-              </a:rPr>
-              <a:t>2</a:t>
-            </a:r>
-            <a:endParaRPr lang="en-US" sz="1500" dirty="0"/>
-          </a:p>
-        </p:txBody>
-      </p:sp>
-      <p:sp>
-        <p:nvSpPr>
-          <p:cNvPr id="13" name="Text 11"/>
-          <p:cNvSpPr/>
-          <p:nvPr/>
-        </p:nvSpPr>
-        <p:spPr>
-          <a:xfrm>
-            <a:off x="5242255" y="2176272"/>
-            <a:ext cx="2316175" cy="411480"/>
-          </a:xfrm>
-          <a:prstGeom prst="rect">
-            <a:avLst/>
-          </a:prstGeom>
-          <a:noFill/>
-          <a:ln/>
-        </p:spPr>
-        <p:txBody>
-          <a:bodyPr wrap="square" lIns="0" tIns="0" rIns="0" bIns="0" rtlCol="0" anchor="ctr"/>
-          <a:lstStyle/>
-          <a:p>
-            <a:pPr indent="0" marL="0">
-              <a:buNone/>
-            </a:pPr>
-            <a:r>
-              <a:rPr lang="en-US" sz="1700" b="1" dirty="0">
-                <a:solidFill>
-                  <a:srgbClr val="14504B"/>
-                </a:solidFill>
-                <a:latin typeface="Yu Gothic" pitchFamily="34" charset="0"/>
-                <a:ea typeface="Yu Gothic" pitchFamily="34" charset="-122"/>
-                <a:cs typeface="Yu Gothic" pitchFamily="34" charset="-120"/>
-              </a:rPr>
-              <a:t>薬剤師に相談する</a:t>
-            </a:r>
-            <a:endParaRPr lang="en-US" sz="1700" dirty="0"/>
-          </a:p>
-        </p:txBody>
-      </p:sp>
-      <p:sp>
-        <p:nvSpPr>
-          <p:cNvPr id="14" name="Text 12"/>
-          <p:cNvSpPr/>
-          <p:nvPr/>
-        </p:nvSpPr>
-        <p:spPr>
-          <a:xfrm>
-            <a:off x="4647895" y="2724912"/>
-            <a:ext cx="2956255" cy="1554480"/>
-          </a:xfrm>
-          <a:prstGeom prst="rect">
-            <a:avLst/>
-          </a:prstGeom>
-          <a:noFill/>
-          <a:ln/>
-        </p:spPr>
-        <p:txBody>
-          <a:bodyPr wrap="square" lIns="0" tIns="0" rIns="0" bIns="0" rtlCol="0" anchor="ctr"/>
-          <a:lstStyle/>
-          <a:p>
-            <a:pPr indent="0" marL="0">
-              <a:lnSpc>
-                <a:spcPct val="125000"/>
-              </a:lnSpc>
-              <a:buNone/>
-            </a:pPr>
-            <a:r>
-              <a:rPr lang="en-US" sz="1350" dirty="0">
-                <a:solidFill>
-                  <a:srgbClr val="16211F"/>
-                </a:solidFill>
-                <a:latin typeface="Yu Gothic" pitchFamily="34" charset="0"/>
-                <a:ea typeface="Yu Gothic" pitchFamily="34" charset="-122"/>
-                <a:cs typeface="Yu Gothic" pitchFamily="34" charset="-120"/>
-              </a:rPr>
-              <a:t>電話と違い、何の薬の話かを</a:t>
-            </a:r>
-            <a:endParaRPr lang="en-US" sz="1350" dirty="0"/>
-          </a:p>
-          <a:p>
-            <a:pPr indent="0" marL="0">
-              <a:lnSpc>
-                <a:spcPct val="125000"/>
-              </a:lnSpc>
-              <a:buNone/>
-            </a:pPr>
-            <a:r>
-              <a:rPr lang="en-US" sz="1350" dirty="0">
-                <a:solidFill>
-                  <a:srgbClr val="16211F"/>
-                </a:solidFill>
-                <a:latin typeface="Yu Gothic" pitchFamily="34" charset="0"/>
-                <a:ea typeface="Yu Gothic" pitchFamily="34" charset="-122"/>
-                <a:cs typeface="Yu Gothic" pitchFamily="34" charset="-120"/>
-              </a:rPr>
-              <a:t>説明し直さなくていい。</a:t>
-            </a:r>
-            <a:endParaRPr lang="en-US" sz="1350" dirty="0"/>
-          </a:p>
-          <a:p>
-            <a:pPr indent="0" marL="0">
-              <a:lnSpc>
-                <a:spcPct val="125000"/>
-              </a:lnSpc>
-              <a:buNone/>
-            </a:pPr>
-            <a:r>
-              <a:rPr lang="en-US" sz="1350" dirty="0">
-                <a:solidFill>
-                  <a:srgbClr val="16211F"/>
-                </a:solidFill>
-                <a:latin typeface="Yu Gothic" pitchFamily="34" charset="0"/>
-                <a:ea typeface="Yu Gothic" pitchFamily="34" charset="-122"/>
-                <a:cs typeface="Yu Gothic" pitchFamily="34" charset="-120"/>
-              </a:rPr>
-              <a:t>やり取りは記録として残る。</a:t>
-            </a:r>
-            <a:endParaRPr lang="en-US" sz="1350" dirty="0"/>
-          </a:p>
-        </p:txBody>
-      </p:sp>
-      <p:sp>
-        <p:nvSpPr>
-          <p:cNvPr id="15" name="Shape 13"/>
-          <p:cNvSpPr/>
-          <p:nvPr/>
-        </p:nvSpPr>
-        <p:spPr>
-          <a:xfrm>
-            <a:off x="7805318" y="3154680"/>
-            <a:ext cx="182880" cy="237744"/>
-          </a:xfrm>
-          <a:prstGeom prst="rightArrow">
-            <a:avLst/>
-          </a:prstGeom>
-          <a:solidFill>
-            <a:srgbClr val="A8CFC9"/>
-          </a:solidFill>
-          <a:ln w="12700">
-            <a:solidFill>
-              <a:srgbClr val="A8CFC9"/>
-            </a:solidFill>
-            <a:prstDash val="solid"/>
-          </a:ln>
-        </p:spPr>
-      </p:sp>
-      <p:sp>
-        <p:nvSpPr>
-          <p:cNvPr id="16" name="Shape 14"/>
-          <p:cNvSpPr/>
-          <p:nvPr/>
-        </p:nvSpPr>
-        <p:spPr>
-          <a:xfrm>
-            <a:off x="8015630" y="1920240"/>
-            <a:ext cx="3413455" cy="2651760"/>
-          </a:xfrm>
-          <a:prstGeom prst="roundRect">
-            <a:avLst>
-              <a:gd name="adj" fmla="val 2759"/>
-            </a:avLst>
-          </a:prstGeom>
-          <a:solidFill>
-            <a:srgbClr val="F1F6F5"/>
-          </a:solidFill>
-          <a:ln w="12700">
-            <a:solidFill>
-              <a:srgbClr val="F1F6F5"/>
-            </a:solidFill>
-            <a:prstDash val="solid"/>
-          </a:ln>
-        </p:spPr>
-      </p:sp>
-      <p:sp>
-        <p:nvSpPr>
-          <p:cNvPr id="17" name="Shape 15"/>
-          <p:cNvSpPr/>
-          <p:nvPr/>
-        </p:nvSpPr>
-        <p:spPr>
-          <a:xfrm>
-            <a:off x="8289950" y="2148840"/>
-            <a:ext cx="457200" cy="457200"/>
-          </a:xfrm>
-          <a:prstGeom prst="ellipse">
-            <a:avLst/>
-          </a:prstGeom>
-          <a:solidFill>
-            <a:srgbClr val="14504B"/>
-          </a:solidFill>
-          <a:ln w="12700">
-            <a:solidFill>
-              <a:srgbClr val="14504B"/>
-            </a:solidFill>
-            <a:prstDash val="solid"/>
-          </a:ln>
-        </p:spPr>
-      </p:sp>
-      <p:sp>
-        <p:nvSpPr>
-          <p:cNvPr id="18" name="Text 16"/>
-          <p:cNvSpPr/>
-          <p:nvPr/>
-        </p:nvSpPr>
-        <p:spPr>
-          <a:xfrm>
-            <a:off x="8289950" y="2148840"/>
-            <a:ext cx="457200" cy="457200"/>
-          </a:xfrm>
-          <a:prstGeom prst="rect">
-            <a:avLst/>
-          </a:prstGeom>
-          <a:noFill/>
-          <a:ln/>
-        </p:spPr>
-        <p:txBody>
-          <a:bodyPr wrap="square" lIns="0" tIns="0" rIns="0" bIns="0" rtlCol="0" anchor="ctr"/>
-          <a:lstStyle/>
-          <a:p>
-            <a:pPr algn="ctr" indent="0" marL="0">
-              <a:buNone/>
-            </a:pPr>
-            <a:r>
-              <a:rPr lang="en-US" sz="1500" b="1" dirty="0">
-                <a:solidFill>
-                  <a:srgbClr val="FFFFFF"/>
-                </a:solidFill>
-                <a:latin typeface="Yu Gothic" pitchFamily="34" charset="0"/>
-                <a:ea typeface="Yu Gothic" pitchFamily="34" charset="-122"/>
-                <a:cs typeface="Yu Gothic" pitchFamily="34" charset="-120"/>
-              </a:rPr>
-              <a:t>3</a:t>
-            </a:r>
-            <a:endParaRPr lang="en-US" sz="1500" dirty="0"/>
-          </a:p>
-        </p:txBody>
-      </p:sp>
-      <p:sp>
-        <p:nvSpPr>
-          <p:cNvPr id="19" name="Text 17"/>
-          <p:cNvSpPr/>
-          <p:nvPr/>
-        </p:nvSpPr>
-        <p:spPr>
-          <a:xfrm>
-            <a:off x="8884310" y="2176272"/>
-            <a:ext cx="2316175" cy="411480"/>
-          </a:xfrm>
-          <a:prstGeom prst="rect">
-            <a:avLst/>
-          </a:prstGeom>
-          <a:noFill/>
-          <a:ln/>
-        </p:spPr>
-        <p:txBody>
-          <a:bodyPr wrap="square" lIns="0" tIns="0" rIns="0" bIns="0" rtlCol="0" anchor="ctr"/>
-          <a:lstStyle/>
-          <a:p>
-            <a:pPr indent="0" marL="0">
-              <a:buNone/>
-            </a:pPr>
-            <a:r>
-              <a:rPr lang="en-US" sz="1700" b="1" dirty="0">
-                <a:solidFill>
-                  <a:srgbClr val="14504B"/>
-                </a:solidFill>
-                <a:latin typeface="Yu Gothic" pitchFamily="34" charset="0"/>
-                <a:ea typeface="Yu Gothic" pitchFamily="34" charset="-122"/>
-                <a:cs typeface="Yu Gothic" pitchFamily="34" charset="-120"/>
-              </a:rPr>
-              <a:t>その人に合わせて返す</a:t>
-            </a:r>
-            <a:endParaRPr lang="en-US" sz="1700" dirty="0"/>
-          </a:p>
-        </p:txBody>
-      </p:sp>
-      <p:sp>
-        <p:nvSpPr>
-          <p:cNvPr id="20" name="Text 18"/>
-          <p:cNvSpPr/>
-          <p:nvPr/>
-        </p:nvSpPr>
-        <p:spPr>
-          <a:xfrm>
-            <a:off x="8289950" y="2724912"/>
-            <a:ext cx="2956255" cy="1554480"/>
-          </a:xfrm>
-          <a:prstGeom prst="rect">
-            <a:avLst/>
-          </a:prstGeom>
-          <a:noFill/>
-          <a:ln/>
-        </p:spPr>
-        <p:txBody>
-          <a:bodyPr wrap="square" lIns="0" tIns="0" rIns="0" bIns="0" rtlCol="0" anchor="ctr"/>
-          <a:lstStyle/>
-          <a:p>
-            <a:pPr indent="0" marL="0">
-              <a:lnSpc>
-                <a:spcPct val="125000"/>
-              </a:lnSpc>
-              <a:buNone/>
-            </a:pPr>
-            <a:r>
-              <a:rPr lang="en-US" sz="1350" dirty="0">
-                <a:solidFill>
-                  <a:srgbClr val="16211F"/>
-                </a:solidFill>
-                <a:latin typeface="Yu Gothic" pitchFamily="34" charset="0"/>
-                <a:ea typeface="Yu Gothic" pitchFamily="34" charset="-122"/>
-                <a:cs typeface="Yu Gothic" pitchFamily="34" charset="-120"/>
-              </a:rPr>
-              <a:t>腎機能・肝機能・年齢を見て</a:t>
-            </a:r>
-            <a:endParaRPr lang="en-US" sz="1350" dirty="0"/>
-          </a:p>
-          <a:p>
-            <a:pPr indent="0" marL="0">
-              <a:lnSpc>
-                <a:spcPct val="125000"/>
-              </a:lnSpc>
-              <a:buNone/>
-            </a:pPr>
-            <a:r>
-              <a:rPr lang="en-US" sz="1350" dirty="0">
-                <a:solidFill>
-                  <a:srgbClr val="16211F"/>
-                </a:solidFill>
-                <a:latin typeface="Yu Gothic" pitchFamily="34" charset="0"/>
-                <a:ea typeface="Yu Gothic" pitchFamily="34" charset="-122"/>
-                <a:cs typeface="Yu Gothic" pitchFamily="34" charset="-120"/>
-              </a:rPr>
-              <a:t>注意点を出し分ける。</a:t>
-            </a:r>
-            <a:endParaRPr lang="en-US" sz="1350" dirty="0"/>
-          </a:p>
-          <a:p>
-            <a:pPr indent="0" marL="0">
-              <a:lnSpc>
-                <a:spcPct val="125000"/>
-              </a:lnSpc>
-              <a:buNone/>
-            </a:pPr>
-            <a:r>
-              <a:rPr lang="en-US" sz="1350" dirty="0">
-                <a:solidFill>
-                  <a:srgbClr val="16211F"/>
-                </a:solidFill>
-                <a:latin typeface="Yu Gothic" pitchFamily="34" charset="0"/>
-                <a:ea typeface="Yu Gothic" pitchFamily="34" charset="-122"/>
-                <a:cs typeface="Yu Gothic" pitchFamily="34" charset="-120"/>
-              </a:rPr>
-              <a:t>症状からは、受診かOTCかの</a:t>
-            </a:r>
-            <a:endParaRPr lang="en-US" sz="1350" dirty="0"/>
-          </a:p>
-          <a:p>
-            <a:pPr indent="0" marL="0">
-              <a:lnSpc>
-                <a:spcPct val="125000"/>
-              </a:lnSpc>
-              <a:buNone/>
-            </a:pPr>
-            <a:r>
-              <a:rPr lang="en-US" sz="1350" dirty="0">
-                <a:solidFill>
-                  <a:srgbClr val="16211F"/>
-                </a:solidFill>
-                <a:latin typeface="Yu Gothic" pitchFamily="34" charset="0"/>
-                <a:ea typeface="Yu Gothic" pitchFamily="34" charset="-122"/>
-                <a:cs typeface="Yu Gothic" pitchFamily="34" charset="-120"/>
-              </a:rPr>
-              <a:t>目安を出す。</a:t>
-            </a:r>
-            <a:endParaRPr lang="en-US" sz="1350" dirty="0"/>
-          </a:p>
-        </p:txBody>
-      </p:sp>
-      <p:sp>
-        <p:nvSpPr>
-          <p:cNvPr id="21" name="Text 19"/>
-          <p:cNvSpPr/>
-          <p:nvPr/>
-        </p:nvSpPr>
-        <p:spPr>
-          <a:xfrm>
-            <a:off x="731520" y="4846320"/>
-            <a:ext cx="10698480" cy="365760"/>
-          </a:xfrm>
-          <a:prstGeom prst="rect">
-            <a:avLst/>
-          </a:prstGeom>
-          <a:noFill/>
-          <a:ln/>
-        </p:spPr>
-        <p:txBody>
-          <a:bodyPr wrap="square" lIns="0" tIns="0" rIns="0" bIns="0" rtlCol="0" anchor="ctr"/>
-          <a:lstStyle/>
-          <a:p>
-            <a:pPr indent="0" marL="0">
-              <a:buNone/>
-            </a:pPr>
-            <a:r>
-              <a:rPr lang="en-US" sz="1300" b="1" dirty="0">
-                <a:solidFill>
-                  <a:srgbClr val="1F6F78"/>
-                </a:solidFill>
-                <a:latin typeface="Yu Gothic" pitchFamily="34" charset="0"/>
-                <a:ea typeface="Yu Gothic" pitchFamily="34" charset="-122"/>
-                <a:cs typeface="Yu Gothic" pitchFamily="34" charset="-120"/>
-              </a:rPr>
-              <a:t>ここが既存サービスとの違い</a:t>
-            </a:r>
-            <a:endParaRPr lang="en-US" sz="1300" dirty="0"/>
-          </a:p>
-        </p:txBody>
-      </p:sp>
-      <p:sp>
-        <p:nvSpPr>
-          <p:cNvPr id="22" name="Shape 20"/>
-          <p:cNvSpPr/>
-          <p:nvPr/>
-        </p:nvSpPr>
-        <p:spPr>
-          <a:xfrm>
-            <a:off x="731520" y="5321808"/>
-            <a:ext cx="36576" cy="384048"/>
-          </a:xfrm>
-          <a:prstGeom prst="rect">
-            <a:avLst/>
-          </a:prstGeom>
-          <a:solidFill>
-            <a:srgbClr val="D98A2B"/>
-          </a:solidFill>
-          <a:ln w="12700">
-            <a:solidFill>
-              <a:srgbClr val="D98A2B"/>
-            </a:solidFill>
-            <a:prstDash val="solid"/>
-          </a:ln>
-        </p:spPr>
-      </p:sp>
-      <p:sp>
-        <p:nvSpPr>
-          <p:cNvPr id="23" name="Text 21"/>
-          <p:cNvSpPr/>
-          <p:nvPr/>
-        </p:nvSpPr>
-        <p:spPr>
-          <a:xfrm>
-            <a:off x="960120" y="5285232"/>
-            <a:ext cx="10424160" cy="457200"/>
-          </a:xfrm>
-          <a:prstGeom prst="rect">
-            <a:avLst/>
-          </a:prstGeom>
-          <a:noFill/>
-          <a:ln/>
-        </p:spPr>
-        <p:txBody>
-          <a:bodyPr wrap="square" lIns="0" tIns="0" rIns="0" bIns="0" rtlCol="0" anchor="ctr"/>
-          <a:lstStyle/>
-          <a:p>
-            <a:pPr indent="0" marL="0">
-              <a:buNone/>
-            </a:pPr>
-            <a:r>
-              <a:rPr lang="en-US" sz="1400" dirty="0">
-                <a:solidFill>
-                  <a:srgbClr val="16211F"/>
-                </a:solidFill>
-                <a:latin typeface="Yu Gothic" pitchFamily="34" charset="0"/>
-                <a:ea typeface="Yu Gothic" pitchFamily="34" charset="-122"/>
-                <a:cs typeface="Yu Gothic" pitchFamily="34" charset="-120"/>
-              </a:rPr>
-              <a:t>バイタルが薬の話とつながっている — 「血圧が下がってきたので降圧薬を見直しては」という会話が、数字を見ながらできる</a:t>
-            </a:r>
-            <a:endParaRPr lang="en-US" sz="1400" dirty="0"/>
-          </a:p>
-        </p:txBody>
-      </p:sp>
-      <p:sp>
-        <p:nvSpPr>
-          <p:cNvPr id="24" name="Shape 22"/>
-          <p:cNvSpPr/>
-          <p:nvPr/>
-        </p:nvSpPr>
-        <p:spPr>
-          <a:xfrm>
-            <a:off x="731520" y="5870448"/>
-            <a:ext cx="36576" cy="384048"/>
-          </a:xfrm>
-          <a:prstGeom prst="rect">
-            <a:avLst/>
-          </a:prstGeom>
-          <a:solidFill>
-            <a:srgbClr val="D98A2B"/>
-          </a:solidFill>
-          <a:ln w="12700">
-            <a:solidFill>
-              <a:srgbClr val="D98A2B"/>
-            </a:solidFill>
-            <a:prstDash val="solid"/>
-          </a:ln>
-        </p:spPr>
-      </p:sp>
-      <p:sp>
-        <p:nvSpPr>
-          <p:cNvPr id="25" name="Text 23"/>
-          <p:cNvSpPr/>
-          <p:nvPr/>
-        </p:nvSpPr>
-        <p:spPr>
-          <a:xfrm>
-            <a:off x="960120" y="5833872"/>
-            <a:ext cx="10424160" cy="457200"/>
-          </a:xfrm>
-          <a:prstGeom prst="rect">
-            <a:avLst/>
-          </a:prstGeom>
-          <a:noFill/>
-          <a:ln/>
-        </p:spPr>
-        <p:txBody>
-          <a:bodyPr wrap="square" lIns="0" tIns="0" rIns="0" bIns="0" rtlCol="0" anchor="ctr"/>
-          <a:lstStyle/>
-          <a:p>
-            <a:pPr indent="0" marL="0">
-              <a:buNone/>
-            </a:pPr>
-            <a:r>
-              <a:rPr lang="en-US" sz="1400" dirty="0">
-                <a:solidFill>
-                  <a:srgbClr val="16211F"/>
-                </a:solidFill>
-                <a:latin typeface="Yu Gothic" pitchFamily="34" charset="0"/>
-                <a:ea typeface="Yu Gothic" pitchFamily="34" charset="-122"/>
-                <a:cs typeface="Yu Gothic" pitchFamily="34" charset="-120"/>
-              </a:rPr>
-              <a:t>症状が出たときの入口がある — 受診すべきか、市販薬で様子を見てよいかの目安を、危険な兆候の有無から出す</a:t>
-            </a:r>
-            <a:endParaRPr lang="en-US" sz="1400" dirty="0"/>
           </a:p>
         </p:txBody>
       </p:sp>
@@ -17805,7 +17533,7 @@
                 <a:ea typeface="Yu Gothic" pitchFamily="34" charset="-122"/>
                 <a:cs typeface="Yu Gothic" pitchFamily="34" charset="-120"/>
               </a:rPr>
-              <a:t>なぜ、今つくるのか</a:t>
+              <a:t>つなぐと、その人に合わせられる</a:t>
             </a:r>
             <a:endParaRPr lang="en-US" sz="3600" dirty="0"/>
           </a:p>
@@ -17844,7 +17572,7 @@
                 <a:ea typeface="Yu Gothic" pitchFamily="34" charset="-122"/>
                 <a:cs typeface="Yu Gothic" pitchFamily="34" charset="-120"/>
               </a:rPr>
-              <a:t>制度の流れが、施設と薬局を近づけている</a:t>
+              <a:t>同じ画面に薬と体調があるから、一般論ではなく目の前の人の話にできる</a:t>
             </a:r>
             <a:endParaRPr lang="en-US" sz="1600" dirty="0"/>
           </a:p>
@@ -17858,547 +17586,12 @@
         </p:nvSpPr>
         <p:spPr>
           <a:xfrm>
-            <a:off x="731520" y="1874520"/>
-            <a:ext cx="475488" cy="475488"/>
-          </a:xfrm>
-          <a:prstGeom prst="ellipse">
-            <a:avLst/>
-          </a:prstGeom>
-          <a:solidFill>
-            <a:srgbClr val="3E8E84"/>
-          </a:solidFill>
-          <a:ln w="12700">
-            <a:solidFill>
-              <a:srgbClr val="3E8E84"/>
-            </a:solidFill>
-            <a:prstDash val="solid"/>
-          </a:ln>
-        </p:spPr>
-      </p:sp>
-      <p:sp>
-        <p:nvSpPr>
-          <p:cNvPr id="5" name="Text 3"/>
-          <p:cNvSpPr/>
-          <p:nvPr/>
-        </p:nvSpPr>
-        <p:spPr>
-          <a:xfrm>
-            <a:off x="731520" y="1874520"/>
-            <a:ext cx="475488" cy="475488"/>
-          </a:xfrm>
-          <a:prstGeom prst="rect">
-            <a:avLst/>
-          </a:prstGeom>
-          <a:noFill/>
-          <a:ln/>
-        </p:spPr>
-        <p:txBody>
-          <a:bodyPr wrap="square" lIns="0" tIns="0" rIns="0" bIns="0" rtlCol="0" anchor="ctr"/>
-          <a:lstStyle/>
-          <a:p>
-            <a:pPr algn="ctr" indent="0" marL="0">
-              <a:buNone/>
-            </a:pPr>
-            <a:r>
-              <a:rPr lang="en-US" sz="1500" b="1" dirty="0">
-                <a:solidFill>
-                  <a:srgbClr val="FFFFFF"/>
-                </a:solidFill>
-                <a:latin typeface="Yu Gothic" pitchFamily="34" charset="0"/>
-                <a:ea typeface="Yu Gothic" pitchFamily="34" charset="-122"/>
-                <a:cs typeface="Yu Gothic" pitchFamily="34" charset="-120"/>
-              </a:rPr>
-              <a:t>1</a:t>
-            </a:r>
-            <a:endParaRPr lang="en-US" sz="1500" dirty="0"/>
-          </a:p>
-        </p:txBody>
-      </p:sp>
-      <p:sp>
-        <p:nvSpPr>
-          <p:cNvPr id="6" name="Text 4"/>
-          <p:cNvSpPr/>
-          <p:nvPr/>
-        </p:nvSpPr>
-        <p:spPr>
-          <a:xfrm>
-            <a:off x="1417320" y="1828800"/>
-            <a:ext cx="9966960" cy="411480"/>
-          </a:xfrm>
-          <a:prstGeom prst="rect">
-            <a:avLst/>
-          </a:prstGeom>
-          <a:noFill/>
-          <a:ln/>
-        </p:spPr>
-        <p:txBody>
-          <a:bodyPr wrap="square" lIns="0" tIns="0" rIns="0" bIns="0" rtlCol="0" anchor="ctr"/>
-          <a:lstStyle/>
-          <a:p>
-            <a:pPr indent="0" marL="0">
-              <a:buNone/>
-            </a:pPr>
-            <a:r>
-              <a:rPr lang="en-US" sz="1800" b="1" dirty="0">
-                <a:solidFill>
-                  <a:srgbClr val="14504B"/>
-                </a:solidFill>
-                <a:latin typeface="Yu Gothic" pitchFamily="34" charset="0"/>
-                <a:ea typeface="Yu Gothic" pitchFamily="34" charset="-122"/>
-                <a:cs typeface="Yu Gothic" pitchFamily="34" charset="-120"/>
-              </a:rPr>
-              <a:t>在宅・施設への訪問が国の方向</a:t>
-            </a:r>
-            <a:endParaRPr lang="en-US" sz="1800" dirty="0"/>
-          </a:p>
-        </p:txBody>
-      </p:sp>
-      <p:sp>
-        <p:nvSpPr>
-          <p:cNvPr id="7" name="Text 5"/>
-          <p:cNvSpPr/>
-          <p:nvPr/>
-        </p:nvSpPr>
-        <p:spPr>
-          <a:xfrm>
-            <a:off x="1417320" y="2240280"/>
-            <a:ext cx="9966960" cy="822960"/>
-          </a:xfrm>
-          <a:prstGeom prst="rect">
-            <a:avLst/>
-          </a:prstGeom>
-          <a:noFill/>
-          <a:ln/>
-        </p:spPr>
-        <p:txBody>
-          <a:bodyPr wrap="square" lIns="0" tIns="0" rIns="0" bIns="0" rtlCol="0" anchor="ctr"/>
-          <a:lstStyle/>
-          <a:p>
-            <a:pPr indent="0" marL="0">
-              <a:lnSpc>
-                <a:spcPct val="120000"/>
-              </a:lnSpc>
-              <a:buNone/>
-            </a:pPr>
-            <a:r>
-              <a:rPr lang="en-US" sz="1350" dirty="0">
-                <a:solidFill>
-                  <a:srgbClr val="16211F"/>
-                </a:solidFill>
-                <a:latin typeface="Yu Gothic" pitchFamily="34" charset="0"/>
-                <a:ea typeface="Yu Gothic" pitchFamily="34" charset="-122"/>
-                <a:cs typeface="Yu Gothic" pitchFamily="34" charset="-120"/>
-              </a:rPr>
-              <a:t>薬剤師の役割は「薬を渡す」から「渡したあとを見る」へ移っている。</a:t>
-            </a:r>
-            <a:endParaRPr lang="en-US" sz="1350" dirty="0"/>
-          </a:p>
-          <a:p>
-            <a:pPr indent="0" marL="0">
-              <a:lnSpc>
-                <a:spcPct val="120000"/>
-              </a:lnSpc>
-              <a:buNone/>
-            </a:pPr>
-            <a:r>
-              <a:rPr lang="en-US" sz="1350" dirty="0">
-                <a:solidFill>
-                  <a:srgbClr val="16211F"/>
-                </a:solidFill>
-                <a:latin typeface="Yu Gothic" pitchFamily="34" charset="0"/>
-                <a:ea typeface="Yu Gothic" pitchFamily="34" charset="-122"/>
-                <a:cs typeface="Yu Gothic" pitchFamily="34" charset="-120"/>
-              </a:rPr>
-              <a:t>施設に足を運ぶ機会は今後さらに増える。</a:t>
-            </a:r>
-            <a:endParaRPr lang="en-US" sz="1350" dirty="0"/>
-          </a:p>
-        </p:txBody>
-      </p:sp>
-      <p:sp>
-        <p:nvSpPr>
-          <p:cNvPr id="8" name="Shape 6"/>
-          <p:cNvSpPr/>
-          <p:nvPr/>
-        </p:nvSpPr>
-        <p:spPr>
-          <a:xfrm>
-            <a:off x="731520" y="3172968"/>
-            <a:ext cx="475488" cy="475488"/>
-          </a:xfrm>
-          <a:prstGeom prst="ellipse">
-            <a:avLst/>
-          </a:prstGeom>
-          <a:solidFill>
-            <a:srgbClr val="3E8E84"/>
-          </a:solidFill>
-          <a:ln w="12700">
-            <a:solidFill>
-              <a:srgbClr val="3E8E84"/>
-            </a:solidFill>
-            <a:prstDash val="solid"/>
-          </a:ln>
-        </p:spPr>
-      </p:sp>
-      <p:sp>
-        <p:nvSpPr>
-          <p:cNvPr id="9" name="Text 7"/>
-          <p:cNvSpPr/>
-          <p:nvPr/>
-        </p:nvSpPr>
-        <p:spPr>
-          <a:xfrm>
-            <a:off x="731520" y="3172968"/>
-            <a:ext cx="475488" cy="475488"/>
-          </a:xfrm>
-          <a:prstGeom prst="rect">
-            <a:avLst/>
-          </a:prstGeom>
-          <a:noFill/>
-          <a:ln/>
-        </p:spPr>
-        <p:txBody>
-          <a:bodyPr wrap="square" lIns="0" tIns="0" rIns="0" bIns="0" rtlCol="0" anchor="ctr"/>
-          <a:lstStyle/>
-          <a:p>
-            <a:pPr algn="ctr" indent="0" marL="0">
-              <a:buNone/>
-            </a:pPr>
-            <a:r>
-              <a:rPr lang="en-US" sz="1500" b="1" dirty="0">
-                <a:solidFill>
-                  <a:srgbClr val="FFFFFF"/>
-                </a:solidFill>
-                <a:latin typeface="Yu Gothic" pitchFamily="34" charset="0"/>
-                <a:ea typeface="Yu Gothic" pitchFamily="34" charset="-122"/>
-                <a:cs typeface="Yu Gothic" pitchFamily="34" charset="-120"/>
-              </a:rPr>
-              <a:t>2</a:t>
-            </a:r>
-            <a:endParaRPr lang="en-US" sz="1500" dirty="0"/>
-          </a:p>
-        </p:txBody>
-      </p:sp>
-      <p:sp>
-        <p:nvSpPr>
-          <p:cNvPr id="10" name="Text 8"/>
-          <p:cNvSpPr/>
-          <p:nvPr/>
-        </p:nvSpPr>
-        <p:spPr>
-          <a:xfrm>
-            <a:off x="1417320" y="3127248"/>
-            <a:ext cx="9966960" cy="411480"/>
-          </a:xfrm>
-          <a:prstGeom prst="rect">
-            <a:avLst/>
-          </a:prstGeom>
-          <a:noFill/>
-          <a:ln/>
-        </p:spPr>
-        <p:txBody>
-          <a:bodyPr wrap="square" lIns="0" tIns="0" rIns="0" bIns="0" rtlCol="0" anchor="ctr"/>
-          <a:lstStyle/>
-          <a:p>
-            <a:pPr indent="0" marL="0">
-              <a:buNone/>
-            </a:pPr>
-            <a:r>
-              <a:rPr lang="en-US" sz="1800" b="1" dirty="0">
-                <a:solidFill>
-                  <a:srgbClr val="14504B"/>
-                </a:solidFill>
-                <a:latin typeface="Yu Gothic" pitchFamily="34" charset="0"/>
-                <a:ea typeface="Yu Gothic" pitchFamily="34" charset="-122"/>
-                <a:cs typeface="Yu Gothic" pitchFamily="34" charset="-120"/>
-              </a:rPr>
-              <a:t>門前から面へ</a:t>
-            </a:r>
-            <a:endParaRPr lang="en-US" sz="1800" dirty="0"/>
-          </a:p>
-        </p:txBody>
-      </p:sp>
-      <p:sp>
-        <p:nvSpPr>
-          <p:cNvPr id="11" name="Text 9"/>
-          <p:cNvSpPr/>
-          <p:nvPr/>
-        </p:nvSpPr>
-        <p:spPr>
-          <a:xfrm>
-            <a:off x="1417320" y="3538728"/>
-            <a:ext cx="9966960" cy="822960"/>
-          </a:xfrm>
-          <a:prstGeom prst="rect">
-            <a:avLst/>
-          </a:prstGeom>
-          <a:noFill/>
-          <a:ln/>
-        </p:spPr>
-        <p:txBody>
-          <a:bodyPr wrap="square" lIns="0" tIns="0" rIns="0" bIns="0" rtlCol="0" anchor="ctr"/>
-          <a:lstStyle/>
-          <a:p>
-            <a:pPr indent="0" marL="0">
-              <a:lnSpc>
-                <a:spcPct val="120000"/>
-              </a:lnSpc>
-              <a:buNone/>
-            </a:pPr>
-            <a:r>
-              <a:rPr lang="en-US" sz="1350" dirty="0">
-                <a:solidFill>
-                  <a:srgbClr val="16211F"/>
-                </a:solidFill>
-                <a:latin typeface="Yu Gothic" pitchFamily="34" charset="0"/>
-                <a:ea typeface="Yu Gothic" pitchFamily="34" charset="-122"/>
-                <a:cs typeface="Yu Gothic" pitchFamily="34" charset="-120"/>
-              </a:rPr>
-              <a:t>特定の病院の前に構える薬局から、地域のどの処方箋も受ける薬局へ。</a:t>
-            </a:r>
-            <a:endParaRPr lang="en-US" sz="1350" dirty="0"/>
-          </a:p>
-          <a:p>
-            <a:pPr indent="0" marL="0">
-              <a:lnSpc>
-                <a:spcPct val="120000"/>
-              </a:lnSpc>
-              <a:buNone/>
-            </a:pPr>
-            <a:r>
-              <a:rPr lang="en-US" sz="1350" dirty="0">
-                <a:solidFill>
-                  <a:srgbClr val="16211F"/>
-                </a:solidFill>
-                <a:latin typeface="Yu Gothic" pitchFamily="34" charset="0"/>
-                <a:ea typeface="Yu Gothic" pitchFamily="34" charset="-122"/>
-                <a:cs typeface="Yu Gothic" pitchFamily="34" charset="-120"/>
-              </a:rPr>
-              <a:t>処方元に電話すれば済んでいたことが、済まなくなる。</a:t>
-            </a:r>
-            <a:endParaRPr lang="en-US" sz="1350" dirty="0"/>
-          </a:p>
-          <a:p>
-            <a:pPr indent="0" marL="0">
-              <a:lnSpc>
-                <a:spcPct val="120000"/>
-              </a:lnSpc>
-              <a:buNone/>
-            </a:pPr>
-            <a:r>
-              <a:rPr lang="en-US" sz="1350" dirty="0">
-                <a:solidFill>
-                  <a:srgbClr val="16211F"/>
-                </a:solidFill>
-                <a:latin typeface="Yu Gothic" pitchFamily="34" charset="0"/>
-                <a:ea typeface="Yu Gothic" pitchFamily="34" charset="-122"/>
-                <a:cs typeface="Yu Gothic" pitchFamily="34" charset="-120"/>
-              </a:rPr>
-              <a:t>患者の薬を薬局側で一元的に把握する必要が出てくる。</a:t>
-            </a:r>
-            <a:endParaRPr lang="en-US" sz="1350" dirty="0"/>
-          </a:p>
-        </p:txBody>
-      </p:sp>
-      <p:sp>
-        <p:nvSpPr>
-          <p:cNvPr id="12" name="Shape 10"/>
-          <p:cNvSpPr/>
-          <p:nvPr/>
-        </p:nvSpPr>
-        <p:spPr>
-          <a:xfrm>
-            <a:off x="731520" y="4471416"/>
-            <a:ext cx="475488" cy="475488"/>
-          </a:xfrm>
-          <a:prstGeom prst="ellipse">
-            <a:avLst/>
-          </a:prstGeom>
-          <a:solidFill>
-            <a:srgbClr val="3E8E84"/>
-          </a:solidFill>
-          <a:ln w="12700">
-            <a:solidFill>
-              <a:srgbClr val="3E8E84"/>
-            </a:solidFill>
-            <a:prstDash val="solid"/>
-          </a:ln>
-        </p:spPr>
-      </p:sp>
-      <p:sp>
-        <p:nvSpPr>
-          <p:cNvPr id="13" name="Text 11"/>
-          <p:cNvSpPr/>
-          <p:nvPr/>
-        </p:nvSpPr>
-        <p:spPr>
-          <a:xfrm>
-            <a:off x="731520" y="4471416"/>
-            <a:ext cx="475488" cy="475488"/>
-          </a:xfrm>
-          <a:prstGeom prst="rect">
-            <a:avLst/>
-          </a:prstGeom>
-          <a:noFill/>
-          <a:ln/>
-        </p:spPr>
-        <p:txBody>
-          <a:bodyPr wrap="square" lIns="0" tIns="0" rIns="0" bIns="0" rtlCol="0" anchor="ctr"/>
-          <a:lstStyle/>
-          <a:p>
-            <a:pPr algn="ctr" indent="0" marL="0">
-              <a:buNone/>
-            </a:pPr>
-            <a:r>
-              <a:rPr lang="en-US" sz="1500" b="1" dirty="0">
-                <a:solidFill>
-                  <a:srgbClr val="FFFFFF"/>
-                </a:solidFill>
-                <a:latin typeface="Yu Gothic" pitchFamily="34" charset="0"/>
-                <a:ea typeface="Yu Gothic" pitchFamily="34" charset="-122"/>
-                <a:cs typeface="Yu Gothic" pitchFamily="34" charset="-120"/>
-              </a:rPr>
-              <a:t>3</a:t>
-            </a:r>
-            <a:endParaRPr lang="en-US" sz="1500" dirty="0"/>
-          </a:p>
-        </p:txBody>
-      </p:sp>
-      <p:sp>
-        <p:nvSpPr>
-          <p:cNvPr id="14" name="Text 12"/>
-          <p:cNvSpPr/>
-          <p:nvPr/>
-        </p:nvSpPr>
-        <p:spPr>
-          <a:xfrm>
-            <a:off x="1417320" y="4425696"/>
-            <a:ext cx="9966960" cy="411480"/>
-          </a:xfrm>
-          <a:prstGeom prst="rect">
-            <a:avLst/>
-          </a:prstGeom>
-          <a:noFill/>
-          <a:ln/>
-        </p:spPr>
-        <p:txBody>
-          <a:bodyPr wrap="square" lIns="0" tIns="0" rIns="0" bIns="0" rtlCol="0" anchor="ctr"/>
-          <a:lstStyle/>
-          <a:p>
-            <a:pPr indent="0" marL="0">
-              <a:buNone/>
-            </a:pPr>
-            <a:r>
-              <a:rPr lang="en-US" sz="1800" b="1" dirty="0">
-                <a:solidFill>
-                  <a:srgbClr val="14504B"/>
-                </a:solidFill>
-                <a:latin typeface="Yu Gothic" pitchFamily="34" charset="0"/>
-                <a:ea typeface="Yu Gothic" pitchFamily="34" charset="-122"/>
-                <a:cs typeface="Yu Gothic" pitchFamily="34" charset="-120"/>
-              </a:rPr>
-              <a:t>服薬期間中のフォローアップは、すでに義務</a:t>
-            </a:r>
-            <a:endParaRPr lang="en-US" sz="1800" dirty="0"/>
-          </a:p>
-        </p:txBody>
-      </p:sp>
-      <p:sp>
-        <p:nvSpPr>
-          <p:cNvPr id="15" name="Text 13"/>
-          <p:cNvSpPr/>
-          <p:nvPr/>
-        </p:nvSpPr>
-        <p:spPr>
-          <a:xfrm>
-            <a:off x="1417320" y="4837176"/>
-            <a:ext cx="9966960" cy="822960"/>
-          </a:xfrm>
-          <a:prstGeom prst="rect">
-            <a:avLst/>
-          </a:prstGeom>
-          <a:noFill/>
-          <a:ln/>
-        </p:spPr>
-        <p:txBody>
-          <a:bodyPr wrap="square" lIns="0" tIns="0" rIns="0" bIns="0" rtlCol="0" anchor="ctr"/>
-          <a:lstStyle/>
-          <a:p>
-            <a:pPr indent="0" marL="0">
-              <a:lnSpc>
-                <a:spcPct val="120000"/>
-              </a:lnSpc>
-              <a:buNone/>
-            </a:pPr>
-            <a:r>
-              <a:rPr lang="en-US" sz="1350" dirty="0">
-                <a:solidFill>
-                  <a:srgbClr val="16211F"/>
-                </a:solidFill>
-                <a:latin typeface="Yu Gothic" pitchFamily="34" charset="0"/>
-                <a:ea typeface="Yu Gothic" pitchFamily="34" charset="-122"/>
-                <a:cs typeface="Yu Gothic" pitchFamily="34" charset="-120"/>
-              </a:rPr>
-              <a:t>2020年9月施行の改正薬機法・薬剤師法で、渡したあとの服薬状況を</a:t>
-            </a:r>
-            <a:endParaRPr lang="en-US" sz="1350" dirty="0"/>
-          </a:p>
-          <a:p>
-            <a:pPr indent="0" marL="0">
-              <a:lnSpc>
-                <a:spcPct val="120000"/>
-              </a:lnSpc>
-              <a:buNone/>
-            </a:pPr>
-            <a:r>
-              <a:rPr lang="en-US" sz="1350" dirty="0">
-                <a:solidFill>
-                  <a:srgbClr val="16211F"/>
-                </a:solidFill>
-                <a:latin typeface="Yu Gothic" pitchFamily="34" charset="0"/>
-                <a:ea typeface="Yu Gothic" pitchFamily="34" charset="-122"/>
-                <a:cs typeface="Yu Gothic" pitchFamily="34" charset="-120"/>
-              </a:rPr>
-              <a:t>継続的に把握することが薬剤師の責務になった。</a:t>
-            </a:r>
-            <a:endParaRPr lang="en-US" sz="1350" dirty="0"/>
-          </a:p>
-          <a:p>
-            <a:pPr indent="0" marL="0">
-              <a:lnSpc>
-                <a:spcPct val="120000"/>
-              </a:lnSpc>
-              <a:buNone/>
-            </a:pPr>
-            <a:r>
-              <a:rPr lang="en-US" sz="1350" dirty="0">
-                <a:solidFill>
-                  <a:srgbClr val="16211F"/>
-                </a:solidFill>
-                <a:latin typeface="Yu Gothic" pitchFamily="34" charset="0"/>
-                <a:ea typeface="Yu Gothic" pitchFamily="34" charset="-122"/>
-                <a:cs typeface="Yu Gothic" pitchFamily="34" charset="-120"/>
-              </a:rPr>
-              <a:t>ただし現場の手段は電話が中心で、続けるのが難しい。</a:t>
-            </a:r>
-            <a:endParaRPr lang="en-US" sz="1350" dirty="0"/>
-          </a:p>
-        </p:txBody>
-      </p:sp>
-      <p:sp>
-        <p:nvSpPr>
-          <p:cNvPr id="16" name="Shape 14"/>
-          <p:cNvSpPr/>
-          <p:nvPr/>
-        </p:nvSpPr>
-        <p:spPr>
-          <a:xfrm>
-            <a:off x="731520" y="5760720"/>
-            <a:ext cx="10698480" cy="777240"/>
+            <a:off x="731520" y="1920240"/>
+            <a:ext cx="3413455" cy="2651760"/>
           </a:xfrm>
           <a:prstGeom prst="roundRect">
             <a:avLst>
-              <a:gd name="adj" fmla="val 9412"/>
+              <a:gd name="adj" fmla="val 2759"/>
             </a:avLst>
           </a:prstGeom>
           <a:solidFill>
@@ -18414,40 +17607,847 @@
       </p:sp>
       <p:sp>
         <p:nvSpPr>
-          <p:cNvPr id="17" name="Text 15"/>
-          <p:cNvSpPr/>
-          <p:nvPr/>
-        </p:nvSpPr>
-        <p:spPr>
-          <a:xfrm>
-            <a:off x="1051560" y="5760720"/>
-            <a:ext cx="10058400" cy="777240"/>
-          </a:xfrm>
-          <a:prstGeom prst="rect">
-            <a:avLst/>
-          </a:prstGeom>
-          <a:noFill/>
-          <a:ln/>
-        </p:spPr>
-        <p:txBody>
-          <a:bodyPr wrap="square" lIns="0" tIns="0" rIns="0" bIns="0" rtlCol="0" anchor="ctr"/>
-          <a:lstStyle/>
-          <a:p>
-            <a:pPr indent="0" marL="0">
+          <p:cNvPr id="5" name="Shape 3"/>
+          <p:cNvSpPr/>
+          <p:nvPr/>
+        </p:nvSpPr>
+        <p:spPr>
+          <a:xfrm>
+            <a:off x="1005840" y="2148840"/>
+            <a:ext cx="457200" cy="457200"/>
+          </a:xfrm>
+          <a:prstGeom prst="ellipse">
+            <a:avLst/>
+          </a:prstGeom>
+          <a:solidFill>
+            <a:srgbClr val="14504B"/>
+          </a:solidFill>
+          <a:ln w="12700">
+            <a:solidFill>
+              <a:srgbClr val="14504B"/>
+            </a:solidFill>
+            <a:prstDash val="solid"/>
+          </a:ln>
+        </p:spPr>
+      </p:sp>
+      <p:sp>
+        <p:nvSpPr>
+          <p:cNvPr id="6" name="Text 4"/>
+          <p:cNvSpPr/>
+          <p:nvPr/>
+        </p:nvSpPr>
+        <p:spPr>
+          <a:xfrm>
+            <a:off x="1005840" y="2148840"/>
+            <a:ext cx="457200" cy="457200"/>
+          </a:xfrm>
+          <a:prstGeom prst="rect">
+            <a:avLst/>
+          </a:prstGeom>
+          <a:noFill/>
+          <a:ln/>
+        </p:spPr>
+        <p:txBody>
+          <a:bodyPr wrap="square" lIns="0" tIns="0" rIns="0" bIns="0" rtlCol="0" anchor="ctr"/>
+          <a:lstStyle/>
+          <a:p>
+            <a:pPr algn="ctr" indent="0" marL="0">
               <a:buNone/>
             </a:pPr>
             <a:r>
               <a:rPr lang="en-US" sz="1500" b="1" dirty="0">
                 <a:solidFill>
+                  <a:srgbClr val="FFFFFF"/>
+                </a:solidFill>
+                <a:latin typeface="Yu Gothic" pitchFamily="34" charset="0"/>
+                <a:ea typeface="Yu Gothic" pitchFamily="34" charset="-122"/>
+                <a:cs typeface="Yu Gothic" pitchFamily="34" charset="-120"/>
+              </a:rPr>
+              <a:t>1</a:t>
+            </a:r>
+            <a:endParaRPr lang="en-US" sz="1500" dirty="0"/>
+          </a:p>
+        </p:txBody>
+      </p:sp>
+      <p:sp>
+        <p:nvSpPr>
+          <p:cNvPr id="7" name="Text 5"/>
+          <p:cNvSpPr/>
+          <p:nvPr/>
+        </p:nvSpPr>
+        <p:spPr>
+          <a:xfrm>
+            <a:off x="1600200" y="2176272"/>
+            <a:ext cx="2316175" cy="411480"/>
+          </a:xfrm>
+          <a:prstGeom prst="rect">
+            <a:avLst/>
+          </a:prstGeom>
+          <a:noFill/>
+          <a:ln/>
+        </p:spPr>
+        <p:txBody>
+          <a:bodyPr wrap="square" lIns="0" tIns="0" rIns="0" bIns="0" rtlCol="0" anchor="ctr"/>
+          <a:lstStyle/>
+          <a:p>
+            <a:pPr indent="0" marL="0">
+              <a:buNone/>
+            </a:pPr>
+            <a:r>
+              <a:rPr lang="en-US" sz="1700" b="1" dirty="0">
+                <a:solidFill>
                   <a:srgbClr val="14504B"/>
                 </a:solidFill>
                 <a:latin typeface="Yu Gothic" pitchFamily="34" charset="0"/>
                 <a:ea typeface="Yu Gothic" pitchFamily="34" charset="-122"/>
                 <a:cs typeface="Yu Gothic" pitchFamily="34" charset="-120"/>
               </a:rPr>
-              <a:t>義務だから電話をかけるのではなく、続けられる形にする。それが結果として、選ばれる薬局につながる</a:t>
+              <a:t>施設が記録する</a:t>
+            </a:r>
+            <a:endParaRPr lang="en-US" sz="1700" dirty="0"/>
+          </a:p>
+        </p:txBody>
+      </p:sp>
+      <p:sp>
+        <p:nvSpPr>
+          <p:cNvPr id="8" name="Text 6"/>
+          <p:cNvSpPr/>
+          <p:nvPr/>
+        </p:nvSpPr>
+        <p:spPr>
+          <a:xfrm>
+            <a:off x="1005840" y="2724912"/>
+            <a:ext cx="2956255" cy="1554480"/>
+          </a:xfrm>
+          <a:prstGeom prst="rect">
+            <a:avLst/>
+          </a:prstGeom>
+          <a:noFill/>
+          <a:ln/>
+        </p:spPr>
+        <p:txBody>
+          <a:bodyPr wrap="square" lIns="0" tIns="0" rIns="0" bIns="0" rtlCol="0" anchor="ctr"/>
+          <a:lstStyle/>
+          <a:p>
+            <a:pPr indent="0" marL="0">
+              <a:lnSpc>
+                <a:spcPct val="125000"/>
+              </a:lnSpc>
+              <a:buNone/>
+            </a:pPr>
+            <a:r>
+              <a:rPr lang="en-US" sz="1350" dirty="0">
+                <a:solidFill>
+                  <a:srgbClr val="16211F"/>
+                </a:solidFill>
+                <a:latin typeface="Yu Gothic" pitchFamily="34" charset="0"/>
+                <a:ea typeface="Yu Gothic" pitchFamily="34" charset="-122"/>
+                <a:cs typeface="Yu Gothic" pitchFamily="34" charset="-120"/>
+              </a:rPr>
+              <a:t>服薬の実施、血圧・体温・SpO₂。</a:t>
+            </a:r>
+            <a:endParaRPr lang="en-US" sz="1350" dirty="0"/>
+          </a:p>
+          <a:p>
+            <a:pPr indent="0" marL="0">
+              <a:lnSpc>
+                <a:spcPct val="125000"/>
+              </a:lnSpc>
+              <a:buNone/>
+            </a:pPr>
+            <a:r>
+              <a:rPr lang="en-US" sz="1350" dirty="0">
+                <a:solidFill>
+                  <a:srgbClr val="16211F"/>
+                </a:solidFill>
+                <a:latin typeface="Yu Gothic" pitchFamily="34" charset="0"/>
+                <a:ea typeface="Yu Gothic" pitchFamily="34" charset="-122"/>
+                <a:cs typeface="Yu Gothic" pitchFamily="34" charset="-120"/>
+              </a:rPr>
+              <a:t>いつも職員がつけている記録を、</a:t>
+            </a:r>
+            <a:endParaRPr lang="en-US" sz="1350" dirty="0"/>
+          </a:p>
+          <a:p>
+            <a:pPr indent="0" marL="0">
+              <a:lnSpc>
+                <a:spcPct val="125000"/>
+              </a:lnSpc>
+              <a:buNone/>
+            </a:pPr>
+            <a:r>
+              <a:rPr lang="en-US" sz="1350" dirty="0">
+                <a:solidFill>
+                  <a:srgbClr val="16211F"/>
+                </a:solidFill>
+                <a:latin typeface="Yu Gothic" pitchFamily="34" charset="0"/>
+                <a:ea typeface="Yu Gothic" pitchFamily="34" charset="-122"/>
+                <a:cs typeface="Yu Gothic" pitchFamily="34" charset="-120"/>
+              </a:rPr>
+              <a:t>そのまま入れる。</a:t>
+            </a:r>
+            <a:endParaRPr lang="en-US" sz="1350" dirty="0"/>
+          </a:p>
+        </p:txBody>
+      </p:sp>
+      <p:sp>
+        <p:nvSpPr>
+          <p:cNvPr id="9" name="Shape 7"/>
+          <p:cNvSpPr/>
+          <p:nvPr/>
+        </p:nvSpPr>
+        <p:spPr>
+          <a:xfrm>
+            <a:off x="4163263" y="3154680"/>
+            <a:ext cx="182880" cy="237744"/>
+          </a:xfrm>
+          <a:prstGeom prst="rightArrow">
+            <a:avLst/>
+          </a:prstGeom>
+          <a:solidFill>
+            <a:srgbClr val="A8CFC9"/>
+          </a:solidFill>
+          <a:ln w="12700">
+            <a:solidFill>
+              <a:srgbClr val="A8CFC9"/>
+            </a:solidFill>
+            <a:prstDash val="solid"/>
+          </a:ln>
+        </p:spPr>
+      </p:sp>
+      <p:sp>
+        <p:nvSpPr>
+          <p:cNvPr id="10" name="Shape 8"/>
+          <p:cNvSpPr/>
+          <p:nvPr/>
+        </p:nvSpPr>
+        <p:spPr>
+          <a:xfrm>
+            <a:off x="4373575" y="1920240"/>
+            <a:ext cx="3413455" cy="2651760"/>
+          </a:xfrm>
+          <a:prstGeom prst="roundRect">
+            <a:avLst>
+              <a:gd name="adj" fmla="val 2759"/>
+            </a:avLst>
+          </a:prstGeom>
+          <a:solidFill>
+            <a:srgbClr val="F1F6F5"/>
+          </a:solidFill>
+          <a:ln w="12700">
+            <a:solidFill>
+              <a:srgbClr val="F1F6F5"/>
+            </a:solidFill>
+            <a:prstDash val="solid"/>
+          </a:ln>
+        </p:spPr>
+      </p:sp>
+      <p:sp>
+        <p:nvSpPr>
+          <p:cNvPr id="11" name="Shape 9"/>
+          <p:cNvSpPr/>
+          <p:nvPr/>
+        </p:nvSpPr>
+        <p:spPr>
+          <a:xfrm>
+            <a:off x="4647895" y="2148840"/>
+            <a:ext cx="457200" cy="457200"/>
+          </a:xfrm>
+          <a:prstGeom prst="ellipse">
+            <a:avLst/>
+          </a:prstGeom>
+          <a:solidFill>
+            <a:srgbClr val="14504B"/>
+          </a:solidFill>
+          <a:ln w="12700">
+            <a:solidFill>
+              <a:srgbClr val="14504B"/>
+            </a:solidFill>
+            <a:prstDash val="solid"/>
+          </a:ln>
+        </p:spPr>
+      </p:sp>
+      <p:sp>
+        <p:nvSpPr>
+          <p:cNvPr id="12" name="Text 10"/>
+          <p:cNvSpPr/>
+          <p:nvPr/>
+        </p:nvSpPr>
+        <p:spPr>
+          <a:xfrm>
+            <a:off x="4647895" y="2148840"/>
+            <a:ext cx="457200" cy="457200"/>
+          </a:xfrm>
+          <a:prstGeom prst="rect">
+            <a:avLst/>
+          </a:prstGeom>
+          <a:noFill/>
+          <a:ln/>
+        </p:spPr>
+        <p:txBody>
+          <a:bodyPr wrap="square" lIns="0" tIns="0" rIns="0" bIns="0" rtlCol="0" anchor="ctr"/>
+          <a:lstStyle/>
+          <a:p>
+            <a:pPr algn="ctr" indent="0" marL="0">
+              <a:buNone/>
+            </a:pPr>
+            <a:r>
+              <a:rPr lang="en-US" sz="1500" b="1" dirty="0">
+                <a:solidFill>
+                  <a:srgbClr val="FFFFFF"/>
+                </a:solidFill>
+                <a:latin typeface="Yu Gothic" pitchFamily="34" charset="0"/>
+                <a:ea typeface="Yu Gothic" pitchFamily="34" charset="-122"/>
+                <a:cs typeface="Yu Gothic" pitchFamily="34" charset="-120"/>
+              </a:rPr>
+              <a:t>2</a:t>
             </a:r>
             <a:endParaRPr lang="en-US" sz="1500" dirty="0"/>
+          </a:p>
+        </p:txBody>
+      </p:sp>
+      <p:sp>
+        <p:nvSpPr>
+          <p:cNvPr id="13" name="Text 11"/>
+          <p:cNvSpPr/>
+          <p:nvPr/>
+        </p:nvSpPr>
+        <p:spPr>
+          <a:xfrm>
+            <a:off x="5242255" y="2176272"/>
+            <a:ext cx="2316175" cy="411480"/>
+          </a:xfrm>
+          <a:prstGeom prst="rect">
+            <a:avLst/>
+          </a:prstGeom>
+          <a:noFill/>
+          <a:ln/>
+        </p:spPr>
+        <p:txBody>
+          <a:bodyPr wrap="square" lIns="0" tIns="0" rIns="0" bIns="0" rtlCol="0" anchor="ctr"/>
+          <a:lstStyle/>
+          <a:p>
+            <a:pPr indent="0" marL="0">
+              <a:buNone/>
+            </a:pPr>
+            <a:r>
+              <a:rPr lang="en-US" sz="1700" b="1" dirty="0">
+                <a:solidFill>
+                  <a:srgbClr val="14504B"/>
+                </a:solidFill>
+                <a:latin typeface="Yu Gothic" pitchFamily="34" charset="0"/>
+                <a:ea typeface="Yu Gothic" pitchFamily="34" charset="-122"/>
+                <a:cs typeface="Yu Gothic" pitchFamily="34" charset="-120"/>
+              </a:rPr>
+              <a:t>薬剤師に相談する</a:t>
+            </a:r>
+            <a:endParaRPr lang="en-US" sz="1700" dirty="0"/>
+          </a:p>
+        </p:txBody>
+      </p:sp>
+      <p:sp>
+        <p:nvSpPr>
+          <p:cNvPr id="14" name="Text 12"/>
+          <p:cNvSpPr/>
+          <p:nvPr/>
+        </p:nvSpPr>
+        <p:spPr>
+          <a:xfrm>
+            <a:off x="4647895" y="2724912"/>
+            <a:ext cx="2956255" cy="1554480"/>
+          </a:xfrm>
+          <a:prstGeom prst="rect">
+            <a:avLst/>
+          </a:prstGeom>
+          <a:noFill/>
+          <a:ln/>
+        </p:spPr>
+        <p:txBody>
+          <a:bodyPr wrap="square" lIns="0" tIns="0" rIns="0" bIns="0" rtlCol="0" anchor="ctr"/>
+          <a:lstStyle/>
+          <a:p>
+            <a:pPr indent="0" marL="0">
+              <a:lnSpc>
+                <a:spcPct val="125000"/>
+              </a:lnSpc>
+              <a:buNone/>
+            </a:pPr>
+            <a:r>
+              <a:rPr lang="en-US" sz="1350" dirty="0">
+                <a:solidFill>
+                  <a:srgbClr val="16211F"/>
+                </a:solidFill>
+                <a:latin typeface="Yu Gothic" pitchFamily="34" charset="0"/>
+                <a:ea typeface="Yu Gothic" pitchFamily="34" charset="-122"/>
+                <a:cs typeface="Yu Gothic" pitchFamily="34" charset="-120"/>
+              </a:rPr>
+              <a:t>電話と違い、何の薬の話かを</a:t>
+            </a:r>
+            <a:endParaRPr lang="en-US" sz="1350" dirty="0"/>
+          </a:p>
+          <a:p>
+            <a:pPr indent="0" marL="0">
+              <a:lnSpc>
+                <a:spcPct val="125000"/>
+              </a:lnSpc>
+              <a:buNone/>
+            </a:pPr>
+            <a:r>
+              <a:rPr lang="en-US" sz="1350" dirty="0">
+                <a:solidFill>
+                  <a:srgbClr val="16211F"/>
+                </a:solidFill>
+                <a:latin typeface="Yu Gothic" pitchFamily="34" charset="0"/>
+                <a:ea typeface="Yu Gothic" pitchFamily="34" charset="-122"/>
+                <a:cs typeface="Yu Gothic" pitchFamily="34" charset="-120"/>
+              </a:rPr>
+              <a:t>説明し直さなくていい。</a:t>
+            </a:r>
+            <a:endParaRPr lang="en-US" sz="1350" dirty="0"/>
+          </a:p>
+          <a:p>
+            <a:pPr indent="0" marL="0">
+              <a:lnSpc>
+                <a:spcPct val="125000"/>
+              </a:lnSpc>
+              <a:buNone/>
+            </a:pPr>
+            <a:r>
+              <a:rPr lang="en-US" sz="1350" dirty="0">
+                <a:solidFill>
+                  <a:srgbClr val="16211F"/>
+                </a:solidFill>
+                <a:latin typeface="Yu Gothic" pitchFamily="34" charset="0"/>
+                <a:ea typeface="Yu Gothic" pitchFamily="34" charset="-122"/>
+                <a:cs typeface="Yu Gothic" pitchFamily="34" charset="-120"/>
+              </a:rPr>
+              <a:t>やり取りは記録として残る。</a:t>
+            </a:r>
+            <a:endParaRPr lang="en-US" sz="1350" dirty="0"/>
+          </a:p>
+        </p:txBody>
+      </p:sp>
+      <p:sp>
+        <p:nvSpPr>
+          <p:cNvPr id="15" name="Shape 13"/>
+          <p:cNvSpPr/>
+          <p:nvPr/>
+        </p:nvSpPr>
+        <p:spPr>
+          <a:xfrm>
+            <a:off x="7805318" y="3154680"/>
+            <a:ext cx="182880" cy="237744"/>
+          </a:xfrm>
+          <a:prstGeom prst="rightArrow">
+            <a:avLst/>
+          </a:prstGeom>
+          <a:solidFill>
+            <a:srgbClr val="A8CFC9"/>
+          </a:solidFill>
+          <a:ln w="12700">
+            <a:solidFill>
+              <a:srgbClr val="A8CFC9"/>
+            </a:solidFill>
+            <a:prstDash val="solid"/>
+          </a:ln>
+        </p:spPr>
+      </p:sp>
+      <p:sp>
+        <p:nvSpPr>
+          <p:cNvPr id="16" name="Shape 14"/>
+          <p:cNvSpPr/>
+          <p:nvPr/>
+        </p:nvSpPr>
+        <p:spPr>
+          <a:xfrm>
+            <a:off x="8015630" y="1920240"/>
+            <a:ext cx="3413455" cy="2651760"/>
+          </a:xfrm>
+          <a:prstGeom prst="roundRect">
+            <a:avLst>
+              <a:gd name="adj" fmla="val 2759"/>
+            </a:avLst>
+          </a:prstGeom>
+          <a:solidFill>
+            <a:srgbClr val="F1F6F5"/>
+          </a:solidFill>
+          <a:ln w="12700">
+            <a:solidFill>
+              <a:srgbClr val="F1F6F5"/>
+            </a:solidFill>
+            <a:prstDash val="solid"/>
+          </a:ln>
+        </p:spPr>
+      </p:sp>
+      <p:sp>
+        <p:nvSpPr>
+          <p:cNvPr id="17" name="Shape 15"/>
+          <p:cNvSpPr/>
+          <p:nvPr/>
+        </p:nvSpPr>
+        <p:spPr>
+          <a:xfrm>
+            <a:off x="8289950" y="2148840"/>
+            <a:ext cx="457200" cy="457200"/>
+          </a:xfrm>
+          <a:prstGeom prst="ellipse">
+            <a:avLst/>
+          </a:prstGeom>
+          <a:solidFill>
+            <a:srgbClr val="14504B"/>
+          </a:solidFill>
+          <a:ln w="12700">
+            <a:solidFill>
+              <a:srgbClr val="14504B"/>
+            </a:solidFill>
+            <a:prstDash val="solid"/>
+          </a:ln>
+        </p:spPr>
+      </p:sp>
+      <p:sp>
+        <p:nvSpPr>
+          <p:cNvPr id="18" name="Text 16"/>
+          <p:cNvSpPr/>
+          <p:nvPr/>
+        </p:nvSpPr>
+        <p:spPr>
+          <a:xfrm>
+            <a:off x="8289950" y="2148840"/>
+            <a:ext cx="457200" cy="457200"/>
+          </a:xfrm>
+          <a:prstGeom prst="rect">
+            <a:avLst/>
+          </a:prstGeom>
+          <a:noFill/>
+          <a:ln/>
+        </p:spPr>
+        <p:txBody>
+          <a:bodyPr wrap="square" lIns="0" tIns="0" rIns="0" bIns="0" rtlCol="0" anchor="ctr"/>
+          <a:lstStyle/>
+          <a:p>
+            <a:pPr algn="ctr" indent="0" marL="0">
+              <a:buNone/>
+            </a:pPr>
+            <a:r>
+              <a:rPr lang="en-US" sz="1500" b="1" dirty="0">
+                <a:solidFill>
+                  <a:srgbClr val="FFFFFF"/>
+                </a:solidFill>
+                <a:latin typeface="Yu Gothic" pitchFamily="34" charset="0"/>
+                <a:ea typeface="Yu Gothic" pitchFamily="34" charset="-122"/>
+                <a:cs typeface="Yu Gothic" pitchFamily="34" charset="-120"/>
+              </a:rPr>
+              <a:t>3</a:t>
+            </a:r>
+            <a:endParaRPr lang="en-US" sz="1500" dirty="0"/>
+          </a:p>
+        </p:txBody>
+      </p:sp>
+      <p:sp>
+        <p:nvSpPr>
+          <p:cNvPr id="19" name="Text 17"/>
+          <p:cNvSpPr/>
+          <p:nvPr/>
+        </p:nvSpPr>
+        <p:spPr>
+          <a:xfrm>
+            <a:off x="8884310" y="2176272"/>
+            <a:ext cx="2316175" cy="411480"/>
+          </a:xfrm>
+          <a:prstGeom prst="rect">
+            <a:avLst/>
+          </a:prstGeom>
+          <a:noFill/>
+          <a:ln/>
+        </p:spPr>
+        <p:txBody>
+          <a:bodyPr wrap="square" lIns="0" tIns="0" rIns="0" bIns="0" rtlCol="0" anchor="ctr"/>
+          <a:lstStyle/>
+          <a:p>
+            <a:pPr indent="0" marL="0">
+              <a:buNone/>
+            </a:pPr>
+            <a:r>
+              <a:rPr lang="en-US" sz="1700" b="1" dirty="0">
+                <a:solidFill>
+                  <a:srgbClr val="14504B"/>
+                </a:solidFill>
+                <a:latin typeface="Yu Gothic" pitchFamily="34" charset="0"/>
+                <a:ea typeface="Yu Gothic" pitchFamily="34" charset="-122"/>
+                <a:cs typeface="Yu Gothic" pitchFamily="34" charset="-120"/>
+              </a:rPr>
+              <a:t>その人に合わせて返す</a:t>
+            </a:r>
+            <a:endParaRPr lang="en-US" sz="1700" dirty="0"/>
+          </a:p>
+        </p:txBody>
+      </p:sp>
+      <p:sp>
+        <p:nvSpPr>
+          <p:cNvPr id="20" name="Text 18"/>
+          <p:cNvSpPr/>
+          <p:nvPr/>
+        </p:nvSpPr>
+        <p:spPr>
+          <a:xfrm>
+            <a:off x="8289950" y="2724912"/>
+            <a:ext cx="2956255" cy="1554480"/>
+          </a:xfrm>
+          <a:prstGeom prst="rect">
+            <a:avLst/>
+          </a:prstGeom>
+          <a:noFill/>
+          <a:ln/>
+        </p:spPr>
+        <p:txBody>
+          <a:bodyPr wrap="square" lIns="0" tIns="0" rIns="0" bIns="0" rtlCol="0" anchor="ctr"/>
+          <a:lstStyle/>
+          <a:p>
+            <a:pPr indent="0" marL="0">
+              <a:lnSpc>
+                <a:spcPct val="125000"/>
+              </a:lnSpc>
+              <a:buNone/>
+            </a:pPr>
+            <a:r>
+              <a:rPr lang="en-US" sz="1350" dirty="0">
+                <a:solidFill>
+                  <a:srgbClr val="16211F"/>
+                </a:solidFill>
+                <a:latin typeface="Yu Gothic" pitchFamily="34" charset="0"/>
+                <a:ea typeface="Yu Gothic" pitchFamily="34" charset="-122"/>
+                <a:cs typeface="Yu Gothic" pitchFamily="34" charset="-120"/>
+              </a:rPr>
+              <a:t>腎機能・肝機能・年齢を見て</a:t>
+            </a:r>
+            <a:endParaRPr lang="en-US" sz="1350" dirty="0"/>
+          </a:p>
+          <a:p>
+            <a:pPr indent="0" marL="0">
+              <a:lnSpc>
+                <a:spcPct val="125000"/>
+              </a:lnSpc>
+              <a:buNone/>
+            </a:pPr>
+            <a:r>
+              <a:rPr lang="en-US" sz="1350" dirty="0">
+                <a:solidFill>
+                  <a:srgbClr val="16211F"/>
+                </a:solidFill>
+                <a:latin typeface="Yu Gothic" pitchFamily="34" charset="0"/>
+                <a:ea typeface="Yu Gothic" pitchFamily="34" charset="-122"/>
+                <a:cs typeface="Yu Gothic" pitchFamily="34" charset="-120"/>
+              </a:rPr>
+              <a:t>注意点を出し分ける。</a:t>
+            </a:r>
+            <a:endParaRPr lang="en-US" sz="1350" dirty="0"/>
+          </a:p>
+          <a:p>
+            <a:pPr indent="0" marL="0">
+              <a:lnSpc>
+                <a:spcPct val="125000"/>
+              </a:lnSpc>
+              <a:buNone/>
+            </a:pPr>
+            <a:r>
+              <a:rPr lang="en-US" sz="1350" dirty="0">
+                <a:solidFill>
+                  <a:srgbClr val="16211F"/>
+                </a:solidFill>
+                <a:latin typeface="Yu Gothic" pitchFamily="34" charset="0"/>
+                <a:ea typeface="Yu Gothic" pitchFamily="34" charset="-122"/>
+                <a:cs typeface="Yu Gothic" pitchFamily="34" charset="-120"/>
+              </a:rPr>
+              <a:t>症状からは、受診かOTCかの</a:t>
+            </a:r>
+            <a:endParaRPr lang="en-US" sz="1350" dirty="0"/>
+          </a:p>
+          <a:p>
+            <a:pPr indent="0" marL="0">
+              <a:lnSpc>
+                <a:spcPct val="125000"/>
+              </a:lnSpc>
+              <a:buNone/>
+            </a:pPr>
+            <a:r>
+              <a:rPr lang="en-US" sz="1350" dirty="0">
+                <a:solidFill>
+                  <a:srgbClr val="16211F"/>
+                </a:solidFill>
+                <a:latin typeface="Yu Gothic" pitchFamily="34" charset="0"/>
+                <a:ea typeface="Yu Gothic" pitchFamily="34" charset="-122"/>
+                <a:cs typeface="Yu Gothic" pitchFamily="34" charset="-120"/>
+              </a:rPr>
+              <a:t>目安を出す。</a:t>
+            </a:r>
+            <a:endParaRPr lang="en-US" sz="1350" dirty="0"/>
+          </a:p>
+        </p:txBody>
+      </p:sp>
+      <p:sp>
+        <p:nvSpPr>
+          <p:cNvPr id="21" name="Text 19"/>
+          <p:cNvSpPr/>
+          <p:nvPr/>
+        </p:nvSpPr>
+        <p:spPr>
+          <a:xfrm>
+            <a:off x="731520" y="4846320"/>
+            <a:ext cx="10698480" cy="365760"/>
+          </a:xfrm>
+          <a:prstGeom prst="rect">
+            <a:avLst/>
+          </a:prstGeom>
+          <a:noFill/>
+          <a:ln/>
+        </p:spPr>
+        <p:txBody>
+          <a:bodyPr wrap="square" lIns="0" tIns="0" rIns="0" bIns="0" rtlCol="0" anchor="ctr"/>
+          <a:lstStyle/>
+          <a:p>
+            <a:pPr indent="0" marL="0">
+              <a:buNone/>
+            </a:pPr>
+            <a:r>
+              <a:rPr lang="en-US" sz="1300" b="1" dirty="0">
+                <a:solidFill>
+                  <a:srgbClr val="1F6F78"/>
+                </a:solidFill>
+                <a:latin typeface="Yu Gothic" pitchFamily="34" charset="0"/>
+                <a:ea typeface="Yu Gothic" pitchFamily="34" charset="-122"/>
+                <a:cs typeface="Yu Gothic" pitchFamily="34" charset="-120"/>
+              </a:rPr>
+              <a:t>ここが既存サービスとの違い</a:t>
+            </a:r>
+            <a:endParaRPr lang="en-US" sz="1300" dirty="0"/>
+          </a:p>
+        </p:txBody>
+      </p:sp>
+      <p:sp>
+        <p:nvSpPr>
+          <p:cNvPr id="22" name="Shape 20"/>
+          <p:cNvSpPr/>
+          <p:nvPr/>
+        </p:nvSpPr>
+        <p:spPr>
+          <a:xfrm>
+            <a:off x="731520" y="5321808"/>
+            <a:ext cx="36576" cy="384048"/>
+          </a:xfrm>
+          <a:prstGeom prst="rect">
+            <a:avLst/>
+          </a:prstGeom>
+          <a:solidFill>
+            <a:srgbClr val="D98A2B"/>
+          </a:solidFill>
+          <a:ln w="12700">
+            <a:solidFill>
+              <a:srgbClr val="D98A2B"/>
+            </a:solidFill>
+            <a:prstDash val="solid"/>
+          </a:ln>
+        </p:spPr>
+      </p:sp>
+      <p:sp>
+        <p:nvSpPr>
+          <p:cNvPr id="23" name="Text 21"/>
+          <p:cNvSpPr/>
+          <p:nvPr/>
+        </p:nvSpPr>
+        <p:spPr>
+          <a:xfrm>
+            <a:off x="960120" y="5285232"/>
+            <a:ext cx="10424160" cy="457200"/>
+          </a:xfrm>
+          <a:prstGeom prst="rect">
+            <a:avLst/>
+          </a:prstGeom>
+          <a:noFill/>
+          <a:ln/>
+        </p:spPr>
+        <p:txBody>
+          <a:bodyPr wrap="square" lIns="0" tIns="0" rIns="0" bIns="0" rtlCol="0" anchor="ctr"/>
+          <a:lstStyle/>
+          <a:p>
+            <a:pPr indent="0" marL="0">
+              <a:buNone/>
+            </a:pPr>
+            <a:r>
+              <a:rPr lang="en-US" sz="1400" dirty="0">
+                <a:solidFill>
+                  <a:srgbClr val="16211F"/>
+                </a:solidFill>
+                <a:latin typeface="Yu Gothic" pitchFamily="34" charset="0"/>
+                <a:ea typeface="Yu Gothic" pitchFamily="34" charset="-122"/>
+                <a:cs typeface="Yu Gothic" pitchFamily="34" charset="-120"/>
+              </a:rPr>
+              <a:t>バイタルが薬の話とつながっている — 「血圧が下がってきたので降圧薬を見直しては」という会話が、数字を見ながらできる</a:t>
+            </a:r>
+            <a:endParaRPr lang="en-US" sz="1400" dirty="0"/>
+          </a:p>
+        </p:txBody>
+      </p:sp>
+      <p:sp>
+        <p:nvSpPr>
+          <p:cNvPr id="24" name="Shape 22"/>
+          <p:cNvSpPr/>
+          <p:nvPr/>
+        </p:nvSpPr>
+        <p:spPr>
+          <a:xfrm>
+            <a:off x="731520" y="5870448"/>
+            <a:ext cx="36576" cy="384048"/>
+          </a:xfrm>
+          <a:prstGeom prst="rect">
+            <a:avLst/>
+          </a:prstGeom>
+          <a:solidFill>
+            <a:srgbClr val="D98A2B"/>
+          </a:solidFill>
+          <a:ln w="12700">
+            <a:solidFill>
+              <a:srgbClr val="D98A2B"/>
+            </a:solidFill>
+            <a:prstDash val="solid"/>
+          </a:ln>
+        </p:spPr>
+      </p:sp>
+      <p:sp>
+        <p:nvSpPr>
+          <p:cNvPr id="25" name="Text 23"/>
+          <p:cNvSpPr/>
+          <p:nvPr/>
+        </p:nvSpPr>
+        <p:spPr>
+          <a:xfrm>
+            <a:off x="960120" y="5833872"/>
+            <a:ext cx="10424160" cy="457200"/>
+          </a:xfrm>
+          <a:prstGeom prst="rect">
+            <a:avLst/>
+          </a:prstGeom>
+          <a:noFill/>
+          <a:ln/>
+        </p:spPr>
+        <p:txBody>
+          <a:bodyPr wrap="square" lIns="0" tIns="0" rIns="0" bIns="0" rtlCol="0" anchor="ctr"/>
+          <a:lstStyle/>
+          <a:p>
+            <a:pPr indent="0" marL="0">
+              <a:buNone/>
+            </a:pPr>
+            <a:r>
+              <a:rPr lang="en-US" sz="1400" dirty="0">
+                <a:solidFill>
+                  <a:srgbClr val="16211F"/>
+                </a:solidFill>
+                <a:latin typeface="Yu Gothic" pitchFamily="34" charset="0"/>
+                <a:ea typeface="Yu Gothic" pitchFamily="34" charset="-122"/>
+                <a:cs typeface="Yu Gothic" pitchFamily="34" charset="-120"/>
+              </a:rPr>
+              <a:t>症状が出たときの入口がある — 受診すべきか、市販薬で様子を見てよいかの目安を、危険な兆候の有無から出す</a:t>
+            </a:r>
+            <a:endParaRPr lang="en-US" sz="1400" dirty="0"/>
           </a:p>
         </p:txBody>
       </p:sp>

</xml_diff>

<commit_message>
deck: let the signup slide carry the overview
Reverted the swap from the last commit — signup goes back ahead of the
feature grid — and reframed it, because the reason it belongs there is
that it answers "what kind of app is this" before any feature does. The
five steps show a facility as the unit, invite codes as how people join,
and the roles table shows that what you see depends on who you are. Read
that way it is a shape, not a procedure, and the eight features land
inside a structure the reader already holds.

Retitled from "create a facility, connect by invite code" to say what the
arrangement is rather than what to click.

Also restored a fact lost when slide 3 was rewritten: the app runs in a
browser with nothing to install, on whatever shared PC or tablet the
floor already has. That is one of the first things a facility weighing
adoption asks, and it had fallen out of the deck entirely.

Co-Authored-By: Claude Opus 5 <noreply@anthropic.com>
</commit_message>
<xml_diff>
--- a/PharmaCare_紹介資料.pptx
+++ b/PharmaCare_紹介資料.pptx
@@ -16785,7 +16785,7 @@
                 <a:ea typeface="Yu Gothic" pitchFamily="34" charset="-122"/>
                 <a:cs typeface="Yu Gothic" pitchFamily="34" charset="-120"/>
               </a:rPr>
-              <a:t>日々の記録から、判断の支援まで</a:t>
+              <a:t>施設を単位に、関わる人が集まる</a:t>
             </a:r>
             <a:endParaRPr lang="en-US" sz="3600" dirty="0"/>
           </a:p>
@@ -16824,7 +16824,7 @@
                 <a:ea typeface="Yu Gothic" pitchFamily="34" charset="-122"/>
                 <a:cs typeface="Yu Gothic" pitchFamily="34" charset="-120"/>
               </a:rPr>
-              <a:t>記録する・相談する・判断を助ける。ばらばらだったものが、ひとつの画面の中でつながります</a:t>
+              <a:t>作るのは施設ひとつ。あとは招待コードで、職員・薬剤師・ご家族が加わります</a:t>
             </a:r>
             <a:endParaRPr lang="en-US" sz="1600" dirty="0"/>
           </a:p>
@@ -16838,12 +16838,12 @@
         </p:nvSpPr>
         <p:spPr>
           <a:xfrm>
-            <a:off x="731520" y="1920240"/>
-            <a:ext cx="2503170" cy="1965960"/>
+            <a:off x="731520" y="2057400"/>
+            <a:ext cx="1920240" cy="1828800"/>
           </a:xfrm>
           <a:prstGeom prst="roundRect">
             <a:avLst>
-              <a:gd name="adj" fmla="val 3721"/>
+              <a:gd name="adj" fmla="val 4000"/>
             </a:avLst>
           </a:prstGeom>
           <a:solidFill>
@@ -16865,8 +16865,163 @@
         </p:nvSpPr>
         <p:spPr>
           <a:xfrm>
-            <a:off x="950976" y="2121408"/>
-            <a:ext cx="402336" cy="402336"/>
+            <a:off x="1417320" y="2286000"/>
+            <a:ext cx="566928" cy="566928"/>
+          </a:xfrm>
+          <a:prstGeom prst="ellipse">
+            <a:avLst/>
+          </a:prstGeom>
+          <a:solidFill>
+            <a:srgbClr val="14504B"/>
+          </a:solidFill>
+          <a:ln w="12700">
+            <a:solidFill>
+              <a:srgbClr val="14504B"/>
+            </a:solidFill>
+            <a:prstDash val="solid"/>
+          </a:ln>
+        </p:spPr>
+      </p:sp>
+      <p:sp>
+        <p:nvSpPr>
+          <p:cNvPr id="6" name="Text 4"/>
+          <p:cNvSpPr/>
+          <p:nvPr/>
+        </p:nvSpPr>
+        <p:spPr>
+          <a:xfrm>
+            <a:off x="1417320" y="2286000"/>
+            <a:ext cx="566928" cy="566928"/>
+          </a:xfrm>
+          <a:prstGeom prst="rect">
+            <a:avLst/>
+          </a:prstGeom>
+          <a:noFill/>
+          <a:ln/>
+        </p:spPr>
+        <p:txBody>
+          <a:bodyPr wrap="square" lIns="0" tIns="0" rIns="0" bIns="0" rtlCol="0" anchor="ctr"/>
+          <a:lstStyle/>
+          <a:p>
+            <a:pPr algn="ctr" indent="0" marL="0">
+              <a:buNone/>
+            </a:pPr>
+            <a:r>
+              <a:rPr lang="en-US" sz="2000" b="1" dirty="0">
+                <a:solidFill>
+                  <a:srgbClr val="FFFFFF"/>
+                </a:solidFill>
+                <a:latin typeface="Yu Gothic" pitchFamily="34" charset="0"/>
+                <a:ea typeface="Yu Gothic" pitchFamily="34" charset="-122"/>
+                <a:cs typeface="Yu Gothic" pitchFamily="34" charset="-120"/>
+              </a:rPr>
+              <a:t>1</a:t>
+            </a:r>
+            <a:endParaRPr lang="en-US" sz="2000" dirty="0"/>
+          </a:p>
+        </p:txBody>
+      </p:sp>
+      <p:sp>
+        <p:nvSpPr>
+          <p:cNvPr id="7" name="Text 5"/>
+          <p:cNvSpPr/>
+          <p:nvPr/>
+        </p:nvSpPr>
+        <p:spPr>
+          <a:xfrm>
+            <a:off x="749808" y="3063240"/>
+            <a:ext cx="1883664" cy="685800"/>
+          </a:xfrm>
+          <a:prstGeom prst="rect">
+            <a:avLst/>
+          </a:prstGeom>
+          <a:noFill/>
+          <a:ln/>
+        </p:spPr>
+        <p:txBody>
+          <a:bodyPr wrap="square" lIns="0" tIns="0" rIns="0" bIns="0" rtlCol="0" anchor="ctr"/>
+          <a:lstStyle/>
+          <a:p>
+            <a:pPr algn="ctr" indent="0" marL="0">
+              <a:buNone/>
+            </a:pPr>
+            <a:r>
+              <a:rPr lang="en-US" sz="1500" b="1" dirty="0">
+                <a:solidFill>
+                  <a:srgbClr val="14504B"/>
+                </a:solidFill>
+                <a:latin typeface="Yu Gothic" pitchFamily="34" charset="0"/>
+                <a:ea typeface="Yu Gothic" pitchFamily="34" charset="-122"/>
+                <a:cs typeface="Yu Gothic" pitchFamily="34" charset="-120"/>
+              </a:rPr>
+              <a:t>施設をつくる</a:t>
+            </a:r>
+            <a:endParaRPr lang="en-US" sz="1500" dirty="0"/>
+          </a:p>
+        </p:txBody>
+      </p:sp>
+      <p:sp>
+        <p:nvSpPr>
+          <p:cNvPr id="8" name="Shape 6"/>
+          <p:cNvSpPr/>
+          <p:nvPr/>
+        </p:nvSpPr>
+        <p:spPr>
+          <a:xfrm>
+            <a:off x="2688336" y="2880360"/>
+            <a:ext cx="219456" cy="237744"/>
+          </a:xfrm>
+          <a:prstGeom prst="rightArrow">
+            <a:avLst/>
+          </a:prstGeom>
+          <a:solidFill>
+            <a:srgbClr val="A8CFC9"/>
+          </a:solidFill>
+          <a:ln w="12700">
+            <a:solidFill>
+              <a:srgbClr val="A8CFC9"/>
+            </a:solidFill>
+            <a:prstDash val="solid"/>
+          </a:ln>
+        </p:spPr>
+      </p:sp>
+      <p:sp>
+        <p:nvSpPr>
+          <p:cNvPr id="9" name="Shape 7"/>
+          <p:cNvSpPr/>
+          <p:nvPr/>
+        </p:nvSpPr>
+        <p:spPr>
+          <a:xfrm>
+            <a:off x="2971800" y="2057400"/>
+            <a:ext cx="1920240" cy="1828800"/>
+          </a:xfrm>
+          <a:prstGeom prst="roundRect">
+            <a:avLst>
+              <a:gd name="adj" fmla="val 4000"/>
+            </a:avLst>
+          </a:prstGeom>
+          <a:solidFill>
+            <a:srgbClr val="F1F6F5"/>
+          </a:solidFill>
+          <a:ln w="12700">
+            <a:solidFill>
+              <a:srgbClr val="F1F6F5"/>
+            </a:solidFill>
+            <a:prstDash val="solid"/>
+          </a:ln>
+        </p:spPr>
+      </p:sp>
+      <p:sp>
+        <p:nvSpPr>
+          <p:cNvPr id="10" name="Shape 8"/>
+          <p:cNvSpPr/>
+          <p:nvPr/>
+        </p:nvSpPr>
+        <p:spPr>
+          <a:xfrm>
+            <a:off x="3657600" y="2286000"/>
+            <a:ext cx="566928" cy="566928"/>
           </a:xfrm>
           <a:prstGeom prst="ellipse">
             <a:avLst/>
@@ -16884,14 +17039,14 @@
       </p:sp>
       <p:sp>
         <p:nvSpPr>
-          <p:cNvPr id="6" name="Text 4"/>
-          <p:cNvSpPr/>
-          <p:nvPr/>
-        </p:nvSpPr>
-        <p:spPr>
-          <a:xfrm>
-            <a:off x="950976" y="2121408"/>
-            <a:ext cx="402336" cy="402336"/>
+          <p:cNvPr id="11" name="Text 9"/>
+          <p:cNvSpPr/>
+          <p:nvPr/>
+        </p:nvSpPr>
+        <p:spPr>
+          <a:xfrm>
+            <a:off x="3657600" y="2286000"/>
+            <a:ext cx="566928" cy="566928"/>
           </a:xfrm>
           <a:prstGeom prst="rect">
             <a:avLst/>
@@ -16907,7 +17062,7 @@
               <a:buNone/>
             </a:pPr>
             <a:r>
-              <a:rPr lang="en-US" sz="1300" b="1" dirty="0">
+              <a:rPr lang="en-US" sz="2000" b="1" dirty="0">
                 <a:solidFill>
                   <a:srgbClr val="FFFFFF"/>
                 </a:solidFill>
@@ -16915,34 +17070,34 @@
                 <a:ea typeface="Yu Gothic" pitchFamily="34" charset="-122"/>
                 <a:cs typeface="Yu Gothic" pitchFamily="34" charset="-120"/>
               </a:rPr>
-              <a:t>1</a:t>
-            </a:r>
-            <a:endParaRPr lang="en-US" sz="1300" dirty="0"/>
-          </a:p>
-        </p:txBody>
-      </p:sp>
-      <p:sp>
-        <p:nvSpPr>
-          <p:cNvPr id="7" name="Text 5"/>
-          <p:cNvSpPr/>
-          <p:nvPr/>
-        </p:nvSpPr>
-        <p:spPr>
-          <a:xfrm>
-            <a:off x="932688" y="2615184"/>
-            <a:ext cx="2183130" cy="347472"/>
-          </a:xfrm>
-          <a:prstGeom prst="rect">
-            <a:avLst/>
-          </a:prstGeom>
-          <a:noFill/>
-          <a:ln/>
-        </p:spPr>
-        <p:txBody>
-          <a:bodyPr wrap="square" lIns="0" tIns="0" rIns="0" bIns="0" rtlCol="0" anchor="ctr"/>
-          <a:lstStyle/>
-          <a:p>
-            <a:pPr indent="0" marL="0">
+              <a:t>2</a:t>
+            </a:r>
+            <a:endParaRPr lang="en-US" sz="2000" dirty="0"/>
+          </a:p>
+        </p:txBody>
+      </p:sp>
+      <p:sp>
+        <p:nvSpPr>
+          <p:cNvPr id="12" name="Text 10"/>
+          <p:cNvSpPr/>
+          <p:nvPr/>
+        </p:nvSpPr>
+        <p:spPr>
+          <a:xfrm>
+            <a:off x="2990088" y="3063240"/>
+            <a:ext cx="1883664" cy="685800"/>
+          </a:xfrm>
+          <a:prstGeom prst="rect">
+            <a:avLst/>
+          </a:prstGeom>
+          <a:noFill/>
+          <a:ln/>
+        </p:spPr>
+        <p:txBody>
+          <a:bodyPr wrap="square" lIns="0" tIns="0" rIns="0" bIns="0" rtlCol="0" anchor="ctr"/>
+          <a:lstStyle/>
+          <a:p>
+            <a:pPr algn="ctr" indent="0" marL="0">
               <a:buNone/>
             </a:pPr>
             <a:r>
@@ -16954,7 +17109,7 @@
                 <a:ea typeface="Yu Gothic" pitchFamily="34" charset="-122"/>
                 <a:cs typeface="Yu Gothic" pitchFamily="34" charset="-120"/>
               </a:rPr>
-              <a:t>お薬手帳</a:t>
+              <a:t>招待コード発行</a:t>
             </a:r>
             <a:endParaRPr lang="en-US" sz="1500" dirty="0"/>
           </a:p>
@@ -16962,80 +17117,43 @@
       </p:sp>
       <p:sp>
         <p:nvSpPr>
-          <p:cNvPr id="8" name="Text 6"/>
-          <p:cNvSpPr/>
-          <p:nvPr/>
-        </p:nvSpPr>
-        <p:spPr>
-          <a:xfrm>
-            <a:off x="932688" y="2999232"/>
-            <a:ext cx="2228850" cy="777240"/>
-          </a:xfrm>
-          <a:prstGeom prst="rect">
-            <a:avLst/>
-          </a:prstGeom>
-          <a:noFill/>
-          <a:ln/>
-        </p:spPr>
-        <p:txBody>
-          <a:bodyPr wrap="square" lIns="0" tIns="0" rIns="0" bIns="0" rtlCol="0" anchor="ctr"/>
-          <a:lstStyle/>
-          <a:p>
-            <a:pPr indent="0" marL="0">
-              <a:lnSpc>
-                <a:spcPct val="120000"/>
-              </a:lnSpc>
-              <a:buNone/>
-            </a:pPr>
-            <a:r>
-              <a:rPr lang="en-US" sz="1200" dirty="0">
-                <a:solidFill>
-                  <a:srgbClr val="5C6B68"/>
-                </a:solidFill>
-                <a:latin typeface="Yu Gothic" pitchFamily="34" charset="0"/>
-                <a:ea typeface="Yu Gothic" pitchFamily="34" charset="-122"/>
-                <a:cs typeface="Yu Gothic" pitchFamily="34" charset="-120"/>
-              </a:rPr>
-              <a:t>QRコードで5秒登録。</a:t>
-            </a:r>
-            <a:endParaRPr lang="en-US" sz="1200" dirty="0"/>
-          </a:p>
-          <a:p>
-            <a:pPr indent="0" marL="0">
-              <a:lnSpc>
-                <a:spcPct val="120000"/>
-              </a:lnSpc>
-              <a:buNone/>
-            </a:pPr>
-            <a:r>
-              <a:rPr lang="en-US" sz="1200" dirty="0">
-                <a:solidFill>
-                  <a:srgbClr val="5C6B68"/>
-                </a:solidFill>
-                <a:latin typeface="Yu Gothic" pitchFamily="34" charset="0"/>
-                <a:ea typeface="Yu Gothic" pitchFamily="34" charset="-122"/>
-                <a:cs typeface="Yu Gothic" pitchFamily="34" charset="-120"/>
-              </a:rPr>
-              <a:t>変更履歴も自動で残る</a:t>
-            </a:r>
-            <a:endParaRPr lang="en-US" sz="1200" dirty="0"/>
-          </a:p>
-        </p:txBody>
-      </p:sp>
-      <p:sp>
-        <p:nvSpPr>
-          <p:cNvPr id="9" name="Shape 7"/>
-          <p:cNvSpPr/>
-          <p:nvPr/>
-        </p:nvSpPr>
-        <p:spPr>
-          <a:xfrm>
-            <a:off x="3463290" y="1920240"/>
-            <a:ext cx="2503170" cy="1965960"/>
+          <p:cNvPr id="13" name="Shape 11"/>
+          <p:cNvSpPr/>
+          <p:nvPr/>
+        </p:nvSpPr>
+        <p:spPr>
+          <a:xfrm>
+            <a:off x="4928616" y="2880360"/>
+            <a:ext cx="219456" cy="237744"/>
+          </a:xfrm>
+          <a:prstGeom prst="rightArrow">
+            <a:avLst/>
+          </a:prstGeom>
+          <a:solidFill>
+            <a:srgbClr val="A8CFC9"/>
+          </a:solidFill>
+          <a:ln w="12700">
+            <a:solidFill>
+              <a:srgbClr val="A8CFC9"/>
+            </a:solidFill>
+            <a:prstDash val="solid"/>
+          </a:ln>
+        </p:spPr>
+      </p:sp>
+      <p:sp>
+        <p:nvSpPr>
+          <p:cNvPr id="14" name="Shape 12"/>
+          <p:cNvSpPr/>
+          <p:nvPr/>
+        </p:nvSpPr>
+        <p:spPr>
+          <a:xfrm>
+            <a:off x="5212080" y="2057400"/>
+            <a:ext cx="1920240" cy="1828800"/>
           </a:xfrm>
           <a:prstGeom prst="roundRect">
             <a:avLst>
-              <a:gd name="adj" fmla="val 3721"/>
+              <a:gd name="adj" fmla="val 4000"/>
             </a:avLst>
           </a:prstGeom>
           <a:solidFill>
@@ -17051,14 +17169,14 @@
       </p:sp>
       <p:sp>
         <p:nvSpPr>
-          <p:cNvPr id="10" name="Shape 8"/>
-          <p:cNvSpPr/>
-          <p:nvPr/>
-        </p:nvSpPr>
-        <p:spPr>
-          <a:xfrm>
-            <a:off x="3682746" y="2121408"/>
-            <a:ext cx="402336" cy="402336"/>
+          <p:cNvPr id="15" name="Shape 13"/>
+          <p:cNvSpPr/>
+          <p:nvPr/>
+        </p:nvSpPr>
+        <p:spPr>
+          <a:xfrm>
+            <a:off x="5897880" y="2286000"/>
+            <a:ext cx="566928" cy="566928"/>
           </a:xfrm>
           <a:prstGeom prst="ellipse">
             <a:avLst/>
@@ -17076,14 +17194,14 @@
       </p:sp>
       <p:sp>
         <p:nvSpPr>
-          <p:cNvPr id="11" name="Text 9"/>
-          <p:cNvSpPr/>
-          <p:nvPr/>
-        </p:nvSpPr>
-        <p:spPr>
-          <a:xfrm>
-            <a:off x="3682746" y="2121408"/>
-            <a:ext cx="402336" cy="402336"/>
+          <p:cNvPr id="16" name="Text 14"/>
+          <p:cNvSpPr/>
+          <p:nvPr/>
+        </p:nvSpPr>
+        <p:spPr>
+          <a:xfrm>
+            <a:off x="5897880" y="2286000"/>
+            <a:ext cx="566928" cy="566928"/>
           </a:xfrm>
           <a:prstGeom prst="rect">
             <a:avLst/>
@@ -17099,7 +17217,7 @@
               <a:buNone/>
             </a:pPr>
             <a:r>
-              <a:rPr lang="en-US" sz="1300" b="1" dirty="0">
+              <a:rPr lang="en-US" sz="2000" b="1" dirty="0">
                 <a:solidFill>
                   <a:srgbClr val="FFFFFF"/>
                 </a:solidFill>
@@ -17107,34 +17225,34 @@
                 <a:ea typeface="Yu Gothic" pitchFamily="34" charset="-122"/>
                 <a:cs typeface="Yu Gothic" pitchFamily="34" charset="-120"/>
               </a:rPr>
-              <a:t>2</a:t>
-            </a:r>
-            <a:endParaRPr lang="en-US" sz="1300" dirty="0"/>
-          </a:p>
-        </p:txBody>
-      </p:sp>
-      <p:sp>
-        <p:nvSpPr>
-          <p:cNvPr id="12" name="Text 10"/>
-          <p:cNvSpPr/>
-          <p:nvPr/>
-        </p:nvSpPr>
-        <p:spPr>
-          <a:xfrm>
-            <a:off x="3664458" y="2615184"/>
-            <a:ext cx="2183130" cy="347472"/>
-          </a:xfrm>
-          <a:prstGeom prst="rect">
-            <a:avLst/>
-          </a:prstGeom>
-          <a:noFill/>
-          <a:ln/>
-        </p:spPr>
-        <p:txBody>
-          <a:bodyPr wrap="square" lIns="0" tIns="0" rIns="0" bIns="0" rtlCol="0" anchor="ctr"/>
-          <a:lstStyle/>
-          <a:p>
-            <a:pPr indent="0" marL="0">
+              <a:t>3</a:t>
+            </a:r>
+            <a:endParaRPr lang="en-US" sz="2000" dirty="0"/>
+          </a:p>
+        </p:txBody>
+      </p:sp>
+      <p:sp>
+        <p:nvSpPr>
+          <p:cNvPr id="17" name="Text 15"/>
+          <p:cNvSpPr/>
+          <p:nvPr/>
+        </p:nvSpPr>
+        <p:spPr>
+          <a:xfrm>
+            <a:off x="5230368" y="3063240"/>
+            <a:ext cx="1883664" cy="685800"/>
+          </a:xfrm>
+          <a:prstGeom prst="rect">
+            <a:avLst/>
+          </a:prstGeom>
+          <a:noFill/>
+          <a:ln/>
+        </p:spPr>
+        <p:txBody>
+          <a:bodyPr wrap="square" lIns="0" tIns="0" rIns="0" bIns="0" rtlCol="0" anchor="ctr"/>
+          <a:lstStyle/>
+          <a:p>
+            <a:pPr algn="ctr" indent="0" marL="0">
               <a:buNone/>
             </a:pPr>
             <a:r>
@@ -17146,7 +17264,7 @@
                 <a:ea typeface="Yu Gothic" pitchFamily="34" charset="-122"/>
                 <a:cs typeface="Yu Gothic" pitchFamily="34" charset="-120"/>
               </a:rPr>
-              <a:t>服薬記録・バイタル</a:t>
+              <a:t>職員が参加</a:t>
             </a:r>
             <a:endParaRPr lang="en-US" sz="1500" dirty="0"/>
           </a:p>
@@ -17154,80 +17272,43 @@
       </p:sp>
       <p:sp>
         <p:nvSpPr>
-          <p:cNvPr id="13" name="Text 11"/>
-          <p:cNvSpPr/>
-          <p:nvPr/>
-        </p:nvSpPr>
-        <p:spPr>
-          <a:xfrm>
-            <a:off x="3664458" y="2999232"/>
-            <a:ext cx="2228850" cy="777240"/>
-          </a:xfrm>
-          <a:prstGeom prst="rect">
-            <a:avLst/>
-          </a:prstGeom>
-          <a:noFill/>
-          <a:ln/>
-        </p:spPr>
-        <p:txBody>
-          <a:bodyPr wrap="square" lIns="0" tIns="0" rIns="0" bIns="0" rtlCol="0" anchor="ctr"/>
-          <a:lstStyle/>
-          <a:p>
-            <a:pPr indent="0" marL="0">
-              <a:lnSpc>
-                <a:spcPct val="120000"/>
-              </a:lnSpc>
-              <a:buNone/>
-            </a:pPr>
-            <a:r>
-              <a:rPr lang="en-US" sz="1200" dirty="0">
-                <a:solidFill>
-                  <a:srgbClr val="5C6B68"/>
-                </a:solidFill>
-                <a:latin typeface="Yu Gothic" pitchFamily="34" charset="0"/>
-                <a:ea typeface="Yu Gothic" pitchFamily="34" charset="-122"/>
-                <a:cs typeface="Yu Gothic" pitchFamily="34" charset="-120"/>
-              </a:rPr>
-              <a:t>服薬の実施、血圧・体温・</a:t>
-            </a:r>
-            <a:endParaRPr lang="en-US" sz="1200" dirty="0"/>
-          </a:p>
-          <a:p>
-            <a:pPr indent="0" marL="0">
-              <a:lnSpc>
-                <a:spcPct val="120000"/>
-              </a:lnSpc>
-              <a:buNone/>
-            </a:pPr>
-            <a:r>
-              <a:rPr lang="en-US" sz="1200" dirty="0">
-                <a:solidFill>
-                  <a:srgbClr val="5C6B68"/>
-                </a:solidFill>
-                <a:latin typeface="Yu Gothic" pitchFamily="34" charset="0"/>
-                <a:ea typeface="Yu Gothic" pitchFamily="34" charset="-122"/>
-                <a:cs typeface="Yu Gothic" pitchFamily="34" charset="-120"/>
-              </a:rPr>
-              <a:t>SpO₂を日々の記録として</a:t>
-            </a:r>
-            <a:endParaRPr lang="en-US" sz="1200" dirty="0"/>
-          </a:p>
-        </p:txBody>
-      </p:sp>
-      <p:sp>
-        <p:nvSpPr>
-          <p:cNvPr id="14" name="Shape 12"/>
-          <p:cNvSpPr/>
-          <p:nvPr/>
-        </p:nvSpPr>
-        <p:spPr>
-          <a:xfrm>
-            <a:off x="6195060" y="1920240"/>
-            <a:ext cx="2503170" cy="1965960"/>
+          <p:cNvPr id="18" name="Shape 16"/>
+          <p:cNvSpPr/>
+          <p:nvPr/>
+        </p:nvSpPr>
+        <p:spPr>
+          <a:xfrm>
+            <a:off x="7168896" y="2880360"/>
+            <a:ext cx="219456" cy="237744"/>
+          </a:xfrm>
+          <a:prstGeom prst="rightArrow">
+            <a:avLst/>
+          </a:prstGeom>
+          <a:solidFill>
+            <a:srgbClr val="A8CFC9"/>
+          </a:solidFill>
+          <a:ln w="12700">
+            <a:solidFill>
+              <a:srgbClr val="A8CFC9"/>
+            </a:solidFill>
+            <a:prstDash val="solid"/>
+          </a:ln>
+        </p:spPr>
+      </p:sp>
+      <p:sp>
+        <p:nvSpPr>
+          <p:cNvPr id="19" name="Shape 17"/>
+          <p:cNvSpPr/>
+          <p:nvPr/>
+        </p:nvSpPr>
+        <p:spPr>
+          <a:xfrm>
+            <a:off x="7452360" y="2057400"/>
+            <a:ext cx="1920240" cy="1828800"/>
           </a:xfrm>
           <a:prstGeom prst="roundRect">
             <a:avLst>
-              <a:gd name="adj" fmla="val 3721"/>
+              <a:gd name="adj" fmla="val 4000"/>
             </a:avLst>
           </a:prstGeom>
           <a:solidFill>
@@ -17243,14 +17324,14 @@
       </p:sp>
       <p:sp>
         <p:nvSpPr>
-          <p:cNvPr id="15" name="Shape 13"/>
-          <p:cNvSpPr/>
-          <p:nvPr/>
-        </p:nvSpPr>
-        <p:spPr>
-          <a:xfrm>
-            <a:off x="6414516" y="2121408"/>
-            <a:ext cx="402336" cy="402336"/>
+          <p:cNvPr id="20" name="Shape 18"/>
+          <p:cNvSpPr/>
+          <p:nvPr/>
+        </p:nvSpPr>
+        <p:spPr>
+          <a:xfrm>
+            <a:off x="8138160" y="2286000"/>
+            <a:ext cx="566928" cy="566928"/>
           </a:xfrm>
           <a:prstGeom prst="ellipse">
             <a:avLst/>
@@ -17268,14 +17349,14 @@
       </p:sp>
       <p:sp>
         <p:nvSpPr>
-          <p:cNvPr id="16" name="Text 14"/>
-          <p:cNvSpPr/>
-          <p:nvPr/>
-        </p:nvSpPr>
-        <p:spPr>
-          <a:xfrm>
-            <a:off x="6414516" y="2121408"/>
-            <a:ext cx="402336" cy="402336"/>
+          <p:cNvPr id="21" name="Text 19"/>
+          <p:cNvSpPr/>
+          <p:nvPr/>
+        </p:nvSpPr>
+        <p:spPr>
+          <a:xfrm>
+            <a:off x="8138160" y="2286000"/>
+            <a:ext cx="566928" cy="566928"/>
           </a:xfrm>
           <a:prstGeom prst="rect">
             <a:avLst/>
@@ -17291,7 +17372,7 @@
               <a:buNone/>
             </a:pPr>
             <a:r>
-              <a:rPr lang="en-US" sz="1300" b="1" dirty="0">
+              <a:rPr lang="en-US" sz="2000" b="1" dirty="0">
                 <a:solidFill>
                   <a:srgbClr val="FFFFFF"/>
                 </a:solidFill>
@@ -17299,34 +17380,34 @@
                 <a:ea typeface="Yu Gothic" pitchFamily="34" charset="-122"/>
                 <a:cs typeface="Yu Gothic" pitchFamily="34" charset="-120"/>
               </a:rPr>
-              <a:t>3</a:t>
-            </a:r>
-            <a:endParaRPr lang="en-US" sz="1300" dirty="0"/>
-          </a:p>
-        </p:txBody>
-      </p:sp>
-      <p:sp>
-        <p:nvSpPr>
-          <p:cNvPr id="17" name="Text 15"/>
-          <p:cNvSpPr/>
-          <p:nvPr/>
-        </p:nvSpPr>
-        <p:spPr>
-          <a:xfrm>
-            <a:off x="6396228" y="2615184"/>
-            <a:ext cx="2183130" cy="347472"/>
-          </a:xfrm>
-          <a:prstGeom prst="rect">
-            <a:avLst/>
-          </a:prstGeom>
-          <a:noFill/>
-          <a:ln/>
-        </p:spPr>
-        <p:txBody>
-          <a:bodyPr wrap="square" lIns="0" tIns="0" rIns="0" bIns="0" rtlCol="0" anchor="ctr"/>
-          <a:lstStyle/>
-          <a:p>
-            <a:pPr indent="0" marL="0">
+              <a:t>4</a:t>
+            </a:r>
+            <a:endParaRPr lang="en-US" sz="2000" dirty="0"/>
+          </a:p>
+        </p:txBody>
+      </p:sp>
+      <p:sp>
+        <p:nvSpPr>
+          <p:cNvPr id="22" name="Text 20"/>
+          <p:cNvSpPr/>
+          <p:nvPr/>
+        </p:nvSpPr>
+        <p:spPr>
+          <a:xfrm>
+            <a:off x="7470648" y="3063240"/>
+            <a:ext cx="1883664" cy="685800"/>
+          </a:xfrm>
+          <a:prstGeom prst="rect">
+            <a:avLst/>
+          </a:prstGeom>
+          <a:noFill/>
+          <a:ln/>
+        </p:spPr>
+        <p:txBody>
+          <a:bodyPr wrap="square" lIns="0" tIns="0" rIns="0" bIns="0" rtlCol="0" anchor="ctr"/>
+          <a:lstStyle/>
+          <a:p>
+            <a:pPr algn="ctr" indent="0" marL="0">
               <a:buNone/>
             </a:pPr>
             <a:r>
@@ -17338,7 +17419,7 @@
                 <a:ea typeface="Yu Gothic" pitchFamily="34" charset="-122"/>
                 <a:cs typeface="Yu Gothic" pitchFamily="34" charset="-120"/>
               </a:rPr>
-              <a:t>チャット</a:t>
+              <a:t>入居者を登録</a:t>
             </a:r>
             <a:endParaRPr lang="en-US" sz="1500" dirty="0"/>
           </a:p>
@@ -17346,100 +17427,43 @@
       </p:sp>
       <p:sp>
         <p:nvSpPr>
-          <p:cNvPr id="18" name="Text 16"/>
-          <p:cNvSpPr/>
-          <p:nvPr/>
-        </p:nvSpPr>
-        <p:spPr>
-          <a:xfrm>
-            <a:off x="6396228" y="2999232"/>
-            <a:ext cx="2228850" cy="777240"/>
-          </a:xfrm>
-          <a:prstGeom prst="rect">
-            <a:avLst/>
-          </a:prstGeom>
-          <a:noFill/>
-          <a:ln/>
-        </p:spPr>
-        <p:txBody>
-          <a:bodyPr wrap="square" lIns="0" tIns="0" rIns="0" bIns="0" rtlCol="0" anchor="ctr"/>
-          <a:lstStyle/>
-          <a:p>
-            <a:pPr indent="0" marL="0">
-              <a:lnSpc>
-                <a:spcPct val="120000"/>
-              </a:lnSpc>
-              <a:buNone/>
-            </a:pPr>
-            <a:r>
-              <a:rPr lang="en-US" sz="1200" dirty="0">
-                <a:solidFill>
-                  <a:srgbClr val="5C6B68"/>
-                </a:solidFill>
-                <a:latin typeface="Yu Gothic" pitchFamily="34" charset="0"/>
-                <a:ea typeface="Yu Gothic" pitchFamily="34" charset="-122"/>
-                <a:cs typeface="Yu Gothic" pitchFamily="34" charset="-120"/>
-              </a:rPr>
-              <a:t>入居者ごとの相談ルーム。</a:t>
-            </a:r>
-            <a:endParaRPr lang="en-US" sz="1200" dirty="0"/>
-          </a:p>
-          <a:p>
-            <a:pPr indent="0" marL="0">
-              <a:lnSpc>
-                <a:spcPct val="120000"/>
-              </a:lnSpc>
-              <a:buNone/>
-            </a:pPr>
-            <a:r>
-              <a:rPr lang="en-US" sz="1200" dirty="0">
-                <a:solidFill>
-                  <a:srgbClr val="5C6B68"/>
-                </a:solidFill>
-                <a:latin typeface="Yu Gothic" pitchFamily="34" charset="0"/>
-                <a:ea typeface="Yu Gothic" pitchFamily="34" charset="-122"/>
-                <a:cs typeface="Yu Gothic" pitchFamily="34" charset="-120"/>
-              </a:rPr>
-              <a:t>何の薬の話かが</a:t>
-            </a:r>
-            <a:endParaRPr lang="en-US" sz="1200" dirty="0"/>
-          </a:p>
-          <a:p>
-            <a:pPr indent="0" marL="0">
-              <a:lnSpc>
-                <a:spcPct val="120000"/>
-              </a:lnSpc>
-              <a:buNone/>
-            </a:pPr>
-            <a:r>
-              <a:rPr lang="en-US" sz="1200" dirty="0">
-                <a:solidFill>
-                  <a:srgbClr val="5C6B68"/>
-                </a:solidFill>
-                <a:latin typeface="Yu Gothic" pitchFamily="34" charset="0"/>
-                <a:ea typeface="Yu Gothic" pitchFamily="34" charset="-122"/>
-                <a:cs typeface="Yu Gothic" pitchFamily="34" charset="-120"/>
-              </a:rPr>
-              <a:t>最初から共有されている</a:t>
-            </a:r>
-            <a:endParaRPr lang="en-US" sz="1200" dirty="0"/>
-          </a:p>
-        </p:txBody>
-      </p:sp>
-      <p:sp>
-        <p:nvSpPr>
-          <p:cNvPr id="19" name="Shape 17"/>
-          <p:cNvSpPr/>
-          <p:nvPr/>
-        </p:nvSpPr>
-        <p:spPr>
-          <a:xfrm>
-            <a:off x="8926830" y="1920240"/>
-            <a:ext cx="2503170" cy="1965960"/>
+          <p:cNvPr id="23" name="Shape 21"/>
+          <p:cNvSpPr/>
+          <p:nvPr/>
+        </p:nvSpPr>
+        <p:spPr>
+          <a:xfrm>
+            <a:off x="9409176" y="2880360"/>
+            <a:ext cx="219456" cy="237744"/>
+          </a:xfrm>
+          <a:prstGeom prst="rightArrow">
+            <a:avLst/>
+          </a:prstGeom>
+          <a:solidFill>
+            <a:srgbClr val="A8CFC9"/>
+          </a:solidFill>
+          <a:ln w="12700">
+            <a:solidFill>
+              <a:srgbClr val="A8CFC9"/>
+            </a:solidFill>
+            <a:prstDash val="solid"/>
+          </a:ln>
+        </p:spPr>
+      </p:sp>
+      <p:sp>
+        <p:nvSpPr>
+          <p:cNvPr id="24" name="Shape 22"/>
+          <p:cNvSpPr/>
+          <p:nvPr/>
+        </p:nvSpPr>
+        <p:spPr>
+          <a:xfrm>
+            <a:off x="9692640" y="2057400"/>
+            <a:ext cx="1920240" cy="1828800"/>
           </a:xfrm>
           <a:prstGeom prst="roundRect">
             <a:avLst>
-              <a:gd name="adj" fmla="val 3721"/>
+              <a:gd name="adj" fmla="val 4000"/>
             </a:avLst>
           </a:prstGeom>
           <a:solidFill>
@@ -17455,206 +17479,14 @@
       </p:sp>
       <p:sp>
         <p:nvSpPr>
-          <p:cNvPr id="20" name="Shape 18"/>
-          <p:cNvSpPr/>
-          <p:nvPr/>
-        </p:nvSpPr>
-        <p:spPr>
-          <a:xfrm>
-            <a:off x="9146286" y="2121408"/>
-            <a:ext cx="402336" cy="402336"/>
-          </a:xfrm>
-          <a:prstGeom prst="ellipse">
-            <a:avLst/>
-          </a:prstGeom>
-          <a:solidFill>
-            <a:srgbClr val="3E8E84"/>
-          </a:solidFill>
-          <a:ln w="12700">
-            <a:solidFill>
-              <a:srgbClr val="3E8E84"/>
-            </a:solidFill>
-            <a:prstDash val="solid"/>
-          </a:ln>
-        </p:spPr>
-      </p:sp>
-      <p:sp>
-        <p:nvSpPr>
-          <p:cNvPr id="21" name="Text 19"/>
-          <p:cNvSpPr/>
-          <p:nvPr/>
-        </p:nvSpPr>
-        <p:spPr>
-          <a:xfrm>
-            <a:off x="9146286" y="2121408"/>
-            <a:ext cx="402336" cy="402336"/>
-          </a:xfrm>
-          <a:prstGeom prst="rect">
-            <a:avLst/>
-          </a:prstGeom>
-          <a:noFill/>
-          <a:ln/>
-        </p:spPr>
-        <p:txBody>
-          <a:bodyPr wrap="square" lIns="0" tIns="0" rIns="0" bIns="0" rtlCol="0" anchor="ctr"/>
-          <a:lstStyle/>
-          <a:p>
-            <a:pPr algn="ctr" indent="0" marL="0">
-              <a:buNone/>
-            </a:pPr>
-            <a:r>
-              <a:rPr lang="en-US" sz="1300" b="1" dirty="0">
-                <a:solidFill>
-                  <a:srgbClr val="FFFFFF"/>
-                </a:solidFill>
-                <a:latin typeface="Yu Gothic" pitchFamily="34" charset="0"/>
-                <a:ea typeface="Yu Gothic" pitchFamily="34" charset="-122"/>
-                <a:cs typeface="Yu Gothic" pitchFamily="34" charset="-120"/>
-              </a:rPr>
-              <a:t>4</a:t>
-            </a:r>
-            <a:endParaRPr lang="en-US" sz="1300" dirty="0"/>
-          </a:p>
-        </p:txBody>
-      </p:sp>
-      <p:sp>
-        <p:nvSpPr>
-          <p:cNvPr id="22" name="Text 20"/>
-          <p:cNvSpPr/>
-          <p:nvPr/>
-        </p:nvSpPr>
-        <p:spPr>
-          <a:xfrm>
-            <a:off x="9127998" y="2615184"/>
-            <a:ext cx="2183130" cy="347472"/>
-          </a:xfrm>
-          <a:prstGeom prst="rect">
-            <a:avLst/>
-          </a:prstGeom>
-          <a:noFill/>
-          <a:ln/>
-        </p:spPr>
-        <p:txBody>
-          <a:bodyPr wrap="square" lIns="0" tIns="0" rIns="0" bIns="0" rtlCol="0" anchor="ctr"/>
-          <a:lstStyle/>
-          <a:p>
-            <a:pPr indent="0" marL="0">
-              <a:buNone/>
-            </a:pPr>
-            <a:r>
-              <a:rPr lang="en-US" sz="1500" b="1" dirty="0">
-                <a:solidFill>
-                  <a:srgbClr val="14504B"/>
-                </a:solidFill>
-                <a:latin typeface="Yu Gothic" pitchFamily="34" charset="0"/>
-                <a:ea typeface="Yu Gothic" pitchFamily="34" charset="-122"/>
-                <a:cs typeface="Yu Gothic" pitchFamily="34" charset="-120"/>
-              </a:rPr>
-              <a:t>カレンダー</a:t>
-            </a:r>
-            <a:endParaRPr lang="en-US" sz="1500" dirty="0"/>
-          </a:p>
-        </p:txBody>
-      </p:sp>
-      <p:sp>
-        <p:nvSpPr>
-          <p:cNvPr id="23" name="Text 21"/>
-          <p:cNvSpPr/>
-          <p:nvPr/>
-        </p:nvSpPr>
-        <p:spPr>
-          <a:xfrm>
-            <a:off x="9127998" y="2999232"/>
-            <a:ext cx="2228850" cy="777240"/>
-          </a:xfrm>
-          <a:prstGeom prst="rect">
-            <a:avLst/>
-          </a:prstGeom>
-          <a:noFill/>
-          <a:ln/>
-        </p:spPr>
-        <p:txBody>
-          <a:bodyPr wrap="square" lIns="0" tIns="0" rIns="0" bIns="0" rtlCol="0" anchor="ctr"/>
-          <a:lstStyle/>
-          <a:p>
-            <a:pPr indent="0" marL="0">
-              <a:lnSpc>
-                <a:spcPct val="120000"/>
-              </a:lnSpc>
-              <a:buNone/>
-            </a:pPr>
-            <a:r>
-              <a:rPr lang="en-US" sz="1200" dirty="0">
-                <a:solidFill>
-                  <a:srgbClr val="5C6B68"/>
-                </a:solidFill>
-                <a:latin typeface="Yu Gothic" pitchFamily="34" charset="0"/>
-                <a:ea typeface="Yu Gothic" pitchFamily="34" charset="-122"/>
-                <a:cs typeface="Yu Gothic" pitchFamily="34" charset="-120"/>
-              </a:rPr>
-              <a:t>薬剤師の訪問予定を</a:t>
-            </a:r>
-            <a:endParaRPr lang="en-US" sz="1200" dirty="0"/>
-          </a:p>
-          <a:p>
-            <a:pPr indent="0" marL="0">
-              <a:lnSpc>
-                <a:spcPct val="120000"/>
-              </a:lnSpc>
-              <a:buNone/>
-            </a:pPr>
-            <a:r>
-              <a:rPr lang="en-US" sz="1200" dirty="0">
-                <a:solidFill>
-                  <a:srgbClr val="5C6B68"/>
-                </a:solidFill>
-                <a:latin typeface="Yu Gothic" pitchFamily="34" charset="0"/>
-                <a:ea typeface="Yu Gothic" pitchFamily="34" charset="-122"/>
-                <a:cs typeface="Yu Gothic" pitchFamily="34" charset="-120"/>
-              </a:rPr>
-              <a:t>施設側にも表示</a:t>
-            </a:r>
-            <a:endParaRPr lang="en-US" sz="1200" dirty="0"/>
-          </a:p>
-        </p:txBody>
-      </p:sp>
-      <p:sp>
-        <p:nvSpPr>
-          <p:cNvPr id="24" name="Shape 22"/>
-          <p:cNvSpPr/>
-          <p:nvPr/>
-        </p:nvSpPr>
-        <p:spPr>
-          <a:xfrm>
-            <a:off x="731520" y="4069080"/>
-            <a:ext cx="2503170" cy="1965960"/>
-          </a:xfrm>
-          <a:prstGeom prst="roundRect">
-            <a:avLst>
-              <a:gd name="adj" fmla="val 3721"/>
-            </a:avLst>
-          </a:prstGeom>
-          <a:solidFill>
-            <a:srgbClr val="F1F6F5"/>
-          </a:solidFill>
-          <a:ln w="12700">
-            <a:solidFill>
-              <a:srgbClr val="F1F6F5"/>
-            </a:solidFill>
-            <a:prstDash val="solid"/>
-          </a:ln>
-        </p:spPr>
-      </p:sp>
-      <p:sp>
-        <p:nvSpPr>
           <p:cNvPr id="25" name="Shape 23"/>
           <p:cNvSpPr/>
           <p:nvPr/>
         </p:nvSpPr>
         <p:spPr>
           <a:xfrm>
-            <a:off x="950976" y="4270248"/>
-            <a:ext cx="402336" cy="402336"/>
+            <a:off x="10378440" y="2286000"/>
+            <a:ext cx="566928" cy="566928"/>
           </a:xfrm>
           <a:prstGeom prst="ellipse">
             <a:avLst/>
@@ -17678,8 +17510,8 @@
         </p:nvSpPr>
         <p:spPr>
           <a:xfrm>
-            <a:off x="950976" y="4270248"/>
-            <a:ext cx="402336" cy="402336"/>
+            <a:off x="10378440" y="2286000"/>
+            <a:ext cx="566928" cy="566928"/>
           </a:xfrm>
           <a:prstGeom prst="rect">
             <a:avLst/>
@@ -17695,7 +17527,7 @@
               <a:buNone/>
             </a:pPr>
             <a:r>
-              <a:rPr lang="en-US" sz="1300" b="1" dirty="0">
+              <a:rPr lang="en-US" sz="2000" b="1" dirty="0">
                 <a:solidFill>
                   <a:srgbClr val="FFFFFF"/>
                 </a:solidFill>
@@ -17705,7 +17537,7 @@
               </a:rPr>
               <a:t>5</a:t>
             </a:r>
-            <a:endParaRPr lang="en-US" sz="1300" dirty="0"/>
+            <a:endParaRPr lang="en-US" sz="2000" dirty="0"/>
           </a:p>
         </p:txBody>
       </p:sp>
@@ -17717,20 +17549,20 @@
         </p:nvSpPr>
         <p:spPr>
           <a:xfrm>
-            <a:off x="932688" y="4764024"/>
-            <a:ext cx="2183130" cy="347472"/>
-          </a:xfrm>
-          <a:prstGeom prst="rect">
-            <a:avLst/>
-          </a:prstGeom>
-          <a:noFill/>
-          <a:ln/>
-        </p:spPr>
-        <p:txBody>
-          <a:bodyPr wrap="square" lIns="0" tIns="0" rIns="0" bIns="0" rtlCol="0" anchor="ctr"/>
-          <a:lstStyle/>
-          <a:p>
-            <a:pPr indent="0" marL="0">
+            <a:off x="9710928" y="3063240"/>
+            <a:ext cx="1883664" cy="685800"/>
+          </a:xfrm>
+          <a:prstGeom prst="rect">
+            <a:avLst/>
+          </a:prstGeom>
+          <a:noFill/>
+          <a:ln/>
+        </p:spPr>
+        <p:txBody>
+          <a:bodyPr wrap="square" lIns="0" tIns="0" rIns="0" bIns="0" rtlCol="0" anchor="ctr"/>
+          <a:lstStyle/>
+          <a:p>
+            <a:pPr algn="ctr" indent="0" marL="0">
               <a:buNone/>
             </a:pPr>
             <a:r>
@@ -17742,7 +17574,7 @@
                 <a:ea typeface="Yu Gothic" pitchFamily="34" charset="-122"/>
                 <a:cs typeface="Yu Gothic" pitchFamily="34" charset="-120"/>
               </a:rPr>
-              <a:t>服薬の注意点</a:t>
+              <a:t>家族を招待</a:t>
             </a:r>
             <a:endParaRPr lang="en-US" sz="1500" dirty="0"/>
           </a:p>
@@ -17750,108 +17582,26 @@
       </p:sp>
       <p:sp>
         <p:nvSpPr>
-          <p:cNvPr id="28" name="Text 26"/>
-          <p:cNvSpPr/>
-          <p:nvPr/>
-        </p:nvSpPr>
-        <p:spPr>
-          <a:xfrm>
-            <a:off x="932688" y="5148072"/>
-            <a:ext cx="2228850" cy="777240"/>
-          </a:xfrm>
-          <a:prstGeom prst="rect">
-            <a:avLst/>
-          </a:prstGeom>
-          <a:noFill/>
-          <a:ln/>
-        </p:spPr>
-        <p:txBody>
-          <a:bodyPr wrap="square" lIns="0" tIns="0" rIns="0" bIns="0" rtlCol="0" anchor="ctr"/>
-          <a:lstStyle/>
-          <a:p>
-            <a:pPr indent="0" marL="0">
-              <a:lnSpc>
-                <a:spcPct val="120000"/>
-              </a:lnSpc>
-              <a:buNone/>
-            </a:pPr>
-            <a:r>
-              <a:rPr lang="en-US" sz="1200" dirty="0">
-                <a:solidFill>
-                  <a:srgbClr val="5C6B68"/>
-                </a:solidFill>
-                <a:latin typeface="Yu Gothic" pitchFamily="34" charset="0"/>
-                <a:ea typeface="Yu Gothic" pitchFamily="34" charset="-122"/>
-                <a:cs typeface="Yu Gothic" pitchFamily="34" charset="-120"/>
-              </a:rPr>
-              <a:t>添付文書から該当箇所だけ。</a:t>
-            </a:r>
-            <a:endParaRPr lang="en-US" sz="1200" dirty="0"/>
-          </a:p>
-          <a:p>
-            <a:pPr indent="0" marL="0">
-              <a:lnSpc>
-                <a:spcPct val="120000"/>
-              </a:lnSpc>
-              <a:buNone/>
-            </a:pPr>
-            <a:r>
-              <a:rPr lang="en-US" sz="1200" dirty="0">
-                <a:solidFill>
-                  <a:srgbClr val="5C6B68"/>
-                </a:solidFill>
-                <a:latin typeface="Yu Gothic" pitchFamily="34" charset="0"/>
-                <a:ea typeface="Yu Gothic" pitchFamily="34" charset="-122"/>
-                <a:cs typeface="Yu Gothic" pitchFamily="34" charset="-120"/>
-              </a:rPr>
-              <a:t>腎機能・肝機能・年齢に</a:t>
-            </a:r>
-            <a:endParaRPr lang="en-US" sz="1200" dirty="0"/>
-          </a:p>
-          <a:p>
-            <a:pPr indent="0" marL="0">
-              <a:lnSpc>
-                <a:spcPct val="120000"/>
-              </a:lnSpc>
-              <a:buNone/>
-            </a:pPr>
-            <a:r>
-              <a:rPr lang="en-US" sz="1200" dirty="0">
-                <a:solidFill>
-                  <a:srgbClr val="5C6B68"/>
-                </a:solidFill>
-                <a:latin typeface="Yu Gothic" pitchFamily="34" charset="0"/>
-                <a:ea typeface="Yu Gothic" pitchFamily="34" charset="-122"/>
-                <a:cs typeface="Yu Gothic" pitchFamily="34" charset="-120"/>
-              </a:rPr>
-              <a:t>合わせて出し分ける</a:t>
-            </a:r>
-            <a:endParaRPr lang="en-US" sz="1200" dirty="0"/>
-          </a:p>
-        </p:txBody>
-      </p:sp>
-      <p:sp>
-        <p:nvSpPr>
-          <p:cNvPr id="29" name="Shape 27"/>
-          <p:cNvSpPr/>
-          <p:nvPr/>
-        </p:nvSpPr>
-        <p:spPr>
-          <a:xfrm>
-            <a:off x="3463290" y="4069080"/>
-            <a:ext cx="2503170" cy="1965960"/>
+          <p:cNvPr id="28" name="Shape 26"/>
+          <p:cNvSpPr/>
+          <p:nvPr/>
+        </p:nvSpPr>
+        <p:spPr>
+          <a:xfrm>
+            <a:off x="731520" y="4343400"/>
+            <a:ext cx="10698480" cy="1645920"/>
           </a:xfrm>
           <a:prstGeom prst="roundRect">
             <a:avLst>
-              <a:gd name="adj" fmla="val 3721"/>
+              <a:gd name="adj" fmla="val 4444"/>
             </a:avLst>
           </a:prstGeom>
           <a:solidFill>
-            <a:srgbClr val="F1F6F5"/>
+            <a:srgbClr val="FFFFFF"/>
           </a:solidFill>
           <a:ln w="12700">
             <a:solidFill>
-              <a:srgbClr val="F1F6F5"/>
+              <a:srgbClr val="DCE6E4"/>
             </a:solidFill>
             <a:prstDash val="solid"/>
           </a:ln>
@@ -17859,28 +17609,81 @@
       </p:sp>
       <p:sp>
         <p:nvSpPr>
-          <p:cNvPr id="30" name="Shape 28"/>
-          <p:cNvSpPr/>
-          <p:nvPr/>
-        </p:nvSpPr>
-        <p:spPr>
-          <a:xfrm>
-            <a:off x="3682746" y="4270248"/>
-            <a:ext cx="402336" cy="402336"/>
-          </a:xfrm>
-          <a:prstGeom prst="ellipse">
-            <a:avLst/>
-          </a:prstGeom>
-          <a:solidFill>
-            <a:srgbClr val="D98A2B"/>
-          </a:solidFill>
-          <a:ln w="12700">
-            <a:solidFill>
-              <a:srgbClr val="D98A2B"/>
-            </a:solidFill>
-            <a:prstDash val="solid"/>
-          </a:ln>
-        </p:spPr>
+          <p:cNvPr id="29" name="Text 27"/>
+          <p:cNvSpPr/>
+          <p:nvPr/>
+        </p:nvSpPr>
+        <p:spPr>
+          <a:xfrm>
+            <a:off x="1051560" y="4553712"/>
+            <a:ext cx="5486400" cy="365760"/>
+          </a:xfrm>
+          <a:prstGeom prst="rect">
+            <a:avLst/>
+          </a:prstGeom>
+          <a:noFill/>
+          <a:ln/>
+        </p:spPr>
+        <p:txBody>
+          <a:bodyPr wrap="square" lIns="0" tIns="0" rIns="0" bIns="0" rtlCol="0" anchor="ctr"/>
+          <a:lstStyle/>
+          <a:p>
+            <a:pPr indent="0" marL="0">
+              <a:buNone/>
+            </a:pPr>
+            <a:r>
+              <a:rPr lang="en-US" sz="1900" b="1" dirty="0">
+                <a:solidFill>
+                  <a:srgbClr val="14504B"/>
+                </a:solidFill>
+                <a:latin typeface="Yu Gothic" pitchFamily="34" charset="0"/>
+                <a:ea typeface="Yu Gothic" pitchFamily="34" charset="-122"/>
+                <a:cs typeface="Yu Gothic" pitchFamily="34" charset="-120"/>
+              </a:rPr>
+              <a:t>役割ごとに、見えるものが違う</a:t>
+            </a:r>
+            <a:endParaRPr lang="en-US" sz="1900" dirty="0"/>
+          </a:p>
+        </p:txBody>
+      </p:sp>
+      <p:sp>
+        <p:nvSpPr>
+          <p:cNvPr id="30" name="Text 28"/>
+          <p:cNvSpPr/>
+          <p:nvPr/>
+        </p:nvSpPr>
+        <p:spPr>
+          <a:xfrm>
+            <a:off x="1051560" y="5029200"/>
+            <a:ext cx="3291840" cy="320040"/>
+          </a:xfrm>
+          <a:prstGeom prst="rect">
+            <a:avLst/>
+          </a:prstGeom>
+          <a:noFill/>
+          <a:ln/>
+        </p:spPr>
+        <p:txBody>
+          <a:bodyPr wrap="square" lIns="0" tIns="0" rIns="0" bIns="0" rtlCol="0" anchor="ctr"/>
+          <a:lstStyle/>
+          <a:p>
+            <a:pPr indent="0" marL="0">
+              <a:buNone/>
+            </a:pPr>
+            <a:r>
+              <a:rPr lang="en-US" sz="1500" b="1" dirty="0">
+                <a:solidFill>
+                  <a:srgbClr val="3E8E84"/>
+                </a:solidFill>
+                <a:latin typeface="Yu Gothic" pitchFamily="34" charset="0"/>
+                <a:ea typeface="Yu Gothic" pitchFamily="34" charset="-122"/>
+                <a:cs typeface="Yu Gothic" pitchFamily="34" charset="-120"/>
+              </a:rPr>
+              <a:t>薬剤師</a:t>
+            </a:r>
+            <a:endParaRPr lang="en-US" sz="1500" dirty="0"/>
+          </a:p>
+        </p:txBody>
       </p:sp>
       <p:sp>
         <p:nvSpPr>
@@ -17890,32 +17693,32 @@
         </p:nvSpPr>
         <p:spPr>
           <a:xfrm>
-            <a:off x="3682746" y="4270248"/>
-            <a:ext cx="402336" cy="402336"/>
-          </a:xfrm>
-          <a:prstGeom prst="rect">
-            <a:avLst/>
-          </a:prstGeom>
-          <a:noFill/>
-          <a:ln/>
-        </p:spPr>
-        <p:txBody>
-          <a:bodyPr wrap="square" lIns="0" tIns="0" rIns="0" bIns="0" rtlCol="0" anchor="ctr"/>
-          <a:lstStyle/>
-          <a:p>
-            <a:pPr algn="ctr" indent="0" marL="0">
-              <a:buNone/>
-            </a:pPr>
-            <a:r>
-              <a:rPr lang="en-US" sz="1300" b="1" dirty="0">
-                <a:solidFill>
-                  <a:srgbClr val="FFFFFF"/>
-                </a:solidFill>
-                <a:latin typeface="Yu Gothic" pitchFamily="34" charset="0"/>
-                <a:ea typeface="Yu Gothic" pitchFamily="34" charset="-122"/>
-                <a:cs typeface="Yu Gothic" pitchFamily="34" charset="-120"/>
-              </a:rPr>
-              <a:t>6</a:t>
+            <a:off x="1051560" y="5394960"/>
+            <a:ext cx="3337560" cy="411480"/>
+          </a:xfrm>
+          <a:prstGeom prst="rect">
+            <a:avLst/>
+          </a:prstGeom>
+          <a:noFill/>
+          <a:ln/>
+        </p:spPr>
+        <p:txBody>
+          <a:bodyPr wrap="square" lIns="0" tIns="0" rIns="0" bIns="0" rtlCol="0" anchor="ctr"/>
+          <a:lstStyle/>
+          <a:p>
+            <a:pPr indent="0" marL="0">
+              <a:buNone/>
+            </a:pPr>
+            <a:r>
+              <a:rPr lang="en-US" sz="1300" dirty="0">
+                <a:solidFill>
+                  <a:srgbClr val="5C6B68"/>
+                </a:solidFill>
+                <a:latin typeface="Yu Gothic" pitchFamily="34" charset="0"/>
+                <a:ea typeface="Yu Gothic" pitchFamily="34" charset="-122"/>
+                <a:cs typeface="Yu Gothic" pitchFamily="34" charset="-120"/>
+              </a:rPr>
+              <a:t>薬の登録・変更、相談対応</a:t>
             </a:r>
             <a:endParaRPr lang="en-US" sz="1300" dirty="0"/>
           </a:p>
@@ -17929,8 +17732,8 @@
         </p:nvSpPr>
         <p:spPr>
           <a:xfrm>
-            <a:off x="3664458" y="4764024"/>
-            <a:ext cx="2183130" cy="347472"/>
+            <a:off x="4526280" y="5029200"/>
+            <a:ext cx="3291840" cy="320040"/>
           </a:xfrm>
           <a:prstGeom prst="rect">
             <a:avLst/>
@@ -17948,13 +17751,13 @@
             <a:r>
               <a:rPr lang="en-US" sz="1500" b="1" dirty="0">
                 <a:solidFill>
-                  <a:srgbClr val="14504B"/>
-                </a:solidFill>
-                <a:latin typeface="Yu Gothic" pitchFamily="34" charset="0"/>
-                <a:ea typeface="Yu Gothic" pitchFamily="34" charset="-122"/>
-                <a:cs typeface="Yu Gothic" pitchFamily="34" charset="-120"/>
-              </a:rPr>
-              <a:t>症状トリアージ</a:t>
+                  <a:srgbClr val="3E8E84"/>
+                </a:solidFill>
+                <a:latin typeface="Yu Gothic" pitchFamily="34" charset="0"/>
+                <a:ea typeface="Yu Gothic" pitchFamily="34" charset="-122"/>
+                <a:cs typeface="Yu Gothic" pitchFamily="34" charset="-120"/>
+              </a:rPr>
+              <a:t>介護士・看護師</a:t>
             </a:r>
             <a:endParaRPr lang="en-US" sz="1500" dirty="0"/>
           </a:p>
@@ -17968,27 +17771,24 @@
         </p:nvSpPr>
         <p:spPr>
           <a:xfrm>
-            <a:off x="3664458" y="5148072"/>
-            <a:ext cx="2228850" cy="777240"/>
-          </a:xfrm>
-          <a:prstGeom prst="rect">
-            <a:avLst/>
-          </a:prstGeom>
-          <a:noFill/>
-          <a:ln/>
-        </p:spPr>
-        <p:txBody>
-          <a:bodyPr wrap="square" lIns="0" tIns="0" rIns="0" bIns="0" rtlCol="0" anchor="ctr"/>
-          <a:lstStyle/>
-          <a:p>
-            <a:pPr indent="0" marL="0">
-              <a:lnSpc>
-                <a:spcPct val="120000"/>
-              </a:lnSpc>
-              <a:buNone/>
-            </a:pPr>
-            <a:r>
-              <a:rPr lang="en-US" sz="1200" dirty="0">
+            <a:off x="4526280" y="5394960"/>
+            <a:ext cx="3337560" cy="411480"/>
+          </a:xfrm>
+          <a:prstGeom prst="rect">
+            <a:avLst/>
+          </a:prstGeom>
+          <a:noFill/>
+          <a:ln/>
+        </p:spPr>
+        <p:txBody>
+          <a:bodyPr wrap="square" lIns="0" tIns="0" rIns="0" bIns="0" rtlCol="0" anchor="ctr"/>
+          <a:lstStyle/>
+          <a:p>
+            <a:pPr indent="0" marL="0">
+              <a:buNone/>
+            </a:pPr>
+            <a:r>
+              <a:rPr lang="en-US" sz="1300" dirty="0">
                 <a:solidFill>
                   <a:srgbClr val="5C6B68"/>
                 </a:solidFill>
@@ -17996,19 +17796,77 @@
                 <a:ea typeface="Yu Gothic" pitchFamily="34" charset="-122"/>
                 <a:cs typeface="Yu Gothic" pitchFamily="34" charset="-120"/>
               </a:rPr>
-              <a:t>体調不良時の対応の目安を</a:t>
-            </a:r>
-            <a:endParaRPr lang="en-US" sz="1200" dirty="0"/>
-          </a:p>
-          <a:p>
-            <a:pPr indent="0" marL="0">
-              <a:lnSpc>
-                <a:spcPct val="120000"/>
-              </a:lnSpc>
-              <a:buNone/>
-            </a:pPr>
-            <a:r>
-              <a:rPr lang="en-US" sz="1200" dirty="0">
+              <a:t>服薬記録、バイタル、症状相談</a:t>
+            </a:r>
+            <a:endParaRPr lang="en-US" sz="1300" dirty="0"/>
+          </a:p>
+        </p:txBody>
+      </p:sp>
+      <p:sp>
+        <p:nvSpPr>
+          <p:cNvPr id="34" name="Text 32"/>
+          <p:cNvSpPr/>
+          <p:nvPr/>
+        </p:nvSpPr>
+        <p:spPr>
+          <a:xfrm>
+            <a:off x="8001000" y="5029200"/>
+            <a:ext cx="3291840" cy="320040"/>
+          </a:xfrm>
+          <a:prstGeom prst="rect">
+            <a:avLst/>
+          </a:prstGeom>
+          <a:noFill/>
+          <a:ln/>
+        </p:spPr>
+        <p:txBody>
+          <a:bodyPr wrap="square" lIns="0" tIns="0" rIns="0" bIns="0" rtlCol="0" anchor="ctr"/>
+          <a:lstStyle/>
+          <a:p>
+            <a:pPr indent="0" marL="0">
+              <a:buNone/>
+            </a:pPr>
+            <a:r>
+              <a:rPr lang="en-US" sz="1500" b="1" dirty="0">
+                <a:solidFill>
+                  <a:srgbClr val="3E8E84"/>
+                </a:solidFill>
+                <a:latin typeface="Yu Gothic" pitchFamily="34" charset="0"/>
+                <a:ea typeface="Yu Gothic" pitchFamily="34" charset="-122"/>
+                <a:cs typeface="Yu Gothic" pitchFamily="34" charset="-120"/>
+              </a:rPr>
+              <a:t>家族</a:t>
+            </a:r>
+            <a:endParaRPr lang="en-US" sz="1500" dirty="0"/>
+          </a:p>
+        </p:txBody>
+      </p:sp>
+      <p:sp>
+        <p:nvSpPr>
+          <p:cNvPr id="35" name="Text 33"/>
+          <p:cNvSpPr/>
+          <p:nvPr/>
+        </p:nvSpPr>
+        <p:spPr>
+          <a:xfrm>
+            <a:off x="8001000" y="5394960"/>
+            <a:ext cx="3337560" cy="411480"/>
+          </a:xfrm>
+          <a:prstGeom prst="rect">
+            <a:avLst/>
+          </a:prstGeom>
+          <a:noFill/>
+          <a:ln/>
+        </p:spPr>
+        <p:txBody>
+          <a:bodyPr wrap="square" lIns="0" tIns="0" rIns="0" bIns="0" rtlCol="0" anchor="ctr"/>
+          <a:lstStyle/>
+          <a:p>
+            <a:pPr indent="0" marL="0">
+              <a:buNone/>
+            </a:pPr>
+            <a:r>
+              <a:rPr lang="en-US" sz="1300" dirty="0">
                 <a:solidFill>
                   <a:srgbClr val="5C6B68"/>
                 </a:solidFill>
@@ -18016,63 +17874,11 @@
                 <a:ea typeface="Yu Gothic" pitchFamily="34" charset="-122"/>
                 <a:cs typeface="Yu Gothic" pitchFamily="34" charset="-120"/>
               </a:rPr>
-              <a:t>3段階で提示</a:t>
-            </a:r>
-            <a:endParaRPr lang="en-US" sz="1200" dirty="0"/>
-          </a:p>
-        </p:txBody>
-      </p:sp>
-      <p:sp>
-        <p:nvSpPr>
-          <p:cNvPr id="34" name="Shape 32"/>
-          <p:cNvSpPr/>
-          <p:nvPr/>
-        </p:nvSpPr>
-        <p:spPr>
-          <a:xfrm>
-            <a:off x="6195060" y="4069080"/>
-            <a:ext cx="2503170" cy="1965960"/>
-          </a:xfrm>
-          <a:prstGeom prst="roundRect">
-            <a:avLst>
-              <a:gd name="adj" fmla="val 3721"/>
-            </a:avLst>
-          </a:prstGeom>
-          <a:solidFill>
-            <a:srgbClr val="F1F6F5"/>
-          </a:solidFill>
-          <a:ln w="12700">
-            <a:solidFill>
-              <a:srgbClr val="F1F6F5"/>
-            </a:solidFill>
-            <a:prstDash val="solid"/>
-          </a:ln>
-        </p:spPr>
-      </p:sp>
-      <p:sp>
-        <p:nvSpPr>
-          <p:cNvPr id="35" name="Shape 33"/>
-          <p:cNvSpPr/>
-          <p:nvPr/>
-        </p:nvSpPr>
-        <p:spPr>
-          <a:xfrm>
-            <a:off x="6414516" y="4270248"/>
-            <a:ext cx="402336" cy="402336"/>
-          </a:xfrm>
-          <a:prstGeom prst="ellipse">
-            <a:avLst/>
-          </a:prstGeom>
-          <a:solidFill>
-            <a:srgbClr val="3E8E84"/>
-          </a:solidFill>
-          <a:ln w="12700">
-            <a:solidFill>
-              <a:srgbClr val="3E8E84"/>
-            </a:solidFill>
-            <a:prstDash val="solid"/>
-          </a:ln>
-        </p:spPr>
+              <a:t>処方とバイタルの閲覧のみ</a:t>
+            </a:r>
+            <a:endParaRPr lang="en-US" sz="1300" dirty="0"/>
+          </a:p>
+        </p:txBody>
       </p:sp>
       <p:sp>
         <p:nvSpPr>
@@ -18082,379 +17888,8 @@
         </p:nvSpPr>
         <p:spPr>
           <a:xfrm>
-            <a:off x="6414516" y="4270248"/>
-            <a:ext cx="402336" cy="402336"/>
-          </a:xfrm>
-          <a:prstGeom prst="rect">
-            <a:avLst/>
-          </a:prstGeom>
-          <a:noFill/>
-          <a:ln/>
-        </p:spPr>
-        <p:txBody>
-          <a:bodyPr wrap="square" lIns="0" tIns="0" rIns="0" bIns="0" rtlCol="0" anchor="ctr"/>
-          <a:lstStyle/>
-          <a:p>
-            <a:pPr algn="ctr" indent="0" marL="0">
-              <a:buNone/>
-            </a:pPr>
-            <a:r>
-              <a:rPr lang="en-US" sz="1300" b="1" dirty="0">
-                <a:solidFill>
-                  <a:srgbClr val="FFFFFF"/>
-                </a:solidFill>
-                <a:latin typeface="Yu Gothic" pitchFamily="34" charset="0"/>
-                <a:ea typeface="Yu Gothic" pitchFamily="34" charset="-122"/>
-                <a:cs typeface="Yu Gothic" pitchFamily="34" charset="-120"/>
-              </a:rPr>
-              <a:t>7</a:t>
-            </a:r>
-            <a:endParaRPr lang="en-US" sz="1300" dirty="0"/>
-          </a:p>
-        </p:txBody>
-      </p:sp>
-      <p:sp>
-        <p:nvSpPr>
-          <p:cNvPr id="37" name="Text 35"/>
-          <p:cNvSpPr/>
-          <p:nvPr/>
-        </p:nvSpPr>
-        <p:spPr>
-          <a:xfrm>
-            <a:off x="6396228" y="4764024"/>
-            <a:ext cx="2183130" cy="347472"/>
-          </a:xfrm>
-          <a:prstGeom prst="rect">
-            <a:avLst/>
-          </a:prstGeom>
-          <a:noFill/>
-          <a:ln/>
-        </p:spPr>
-        <p:txBody>
-          <a:bodyPr wrap="square" lIns="0" tIns="0" rIns="0" bIns="0" rtlCol="0" anchor="ctr"/>
-          <a:lstStyle/>
-          <a:p>
-            <a:pPr indent="0" marL="0">
-              <a:buNone/>
-            </a:pPr>
-            <a:r>
-              <a:rPr lang="en-US" sz="1500" b="1" dirty="0">
-                <a:solidFill>
-                  <a:srgbClr val="14504B"/>
-                </a:solidFill>
-                <a:latin typeface="Yu Gothic" pitchFamily="34" charset="0"/>
-                <a:ea typeface="Yu Gothic" pitchFamily="34" charset="-122"/>
-                <a:cs typeface="Yu Gothic" pitchFamily="34" charset="-120"/>
-              </a:rPr>
-              <a:t>家族への共有</a:t>
-            </a:r>
-            <a:endParaRPr lang="en-US" sz="1500" dirty="0"/>
-          </a:p>
-        </p:txBody>
-      </p:sp>
-      <p:sp>
-        <p:nvSpPr>
-          <p:cNvPr id="38" name="Text 36"/>
-          <p:cNvSpPr/>
-          <p:nvPr/>
-        </p:nvSpPr>
-        <p:spPr>
-          <a:xfrm>
-            <a:off x="6396228" y="5148072"/>
-            <a:ext cx="2228850" cy="777240"/>
-          </a:xfrm>
-          <a:prstGeom prst="rect">
-            <a:avLst/>
-          </a:prstGeom>
-          <a:noFill/>
-          <a:ln/>
-        </p:spPr>
-        <p:txBody>
-          <a:bodyPr wrap="square" lIns="0" tIns="0" rIns="0" bIns="0" rtlCol="0" anchor="ctr"/>
-          <a:lstStyle/>
-          <a:p>
-            <a:pPr indent="0" marL="0">
-              <a:lnSpc>
-                <a:spcPct val="120000"/>
-              </a:lnSpc>
-              <a:buNone/>
-            </a:pPr>
-            <a:r>
-              <a:rPr lang="en-US" sz="1200" dirty="0">
-                <a:solidFill>
-                  <a:srgbClr val="5C6B68"/>
-                </a:solidFill>
-                <a:latin typeface="Yu Gothic" pitchFamily="34" charset="0"/>
-                <a:ea typeface="Yu Gothic" pitchFamily="34" charset="-122"/>
-                <a:cs typeface="Yu Gothic" pitchFamily="34" charset="-120"/>
-              </a:rPr>
-              <a:t>処方とバイタルを</a:t>
-            </a:r>
-            <a:endParaRPr lang="en-US" sz="1200" dirty="0"/>
-          </a:p>
-          <a:p>
-            <a:pPr indent="0" marL="0">
-              <a:lnSpc>
-                <a:spcPct val="120000"/>
-              </a:lnSpc>
-              <a:buNone/>
-            </a:pPr>
-            <a:r>
-              <a:rPr lang="en-US" sz="1200" dirty="0">
-                <a:solidFill>
-                  <a:srgbClr val="5C6B68"/>
-                </a:solidFill>
-                <a:latin typeface="Yu Gothic" pitchFamily="34" charset="0"/>
-                <a:ea typeface="Yu Gothic" pitchFamily="34" charset="-122"/>
-                <a:cs typeface="Yu Gothic" pitchFamily="34" charset="-120"/>
-              </a:rPr>
-              <a:t>ご家族が閲覧できる</a:t>
-            </a:r>
-            <a:endParaRPr lang="en-US" sz="1200" dirty="0"/>
-          </a:p>
-        </p:txBody>
-      </p:sp>
-      <p:sp>
-        <p:nvSpPr>
-          <p:cNvPr id="39" name="Shape 37"/>
-          <p:cNvSpPr/>
-          <p:nvPr/>
-        </p:nvSpPr>
-        <p:spPr>
-          <a:xfrm>
-            <a:off x="8926830" y="4069080"/>
-            <a:ext cx="2503170" cy="1965960"/>
-          </a:xfrm>
-          <a:prstGeom prst="roundRect">
-            <a:avLst>
-              <a:gd name="adj" fmla="val 3721"/>
-            </a:avLst>
-          </a:prstGeom>
-          <a:solidFill>
-            <a:srgbClr val="F1F6F5"/>
-          </a:solidFill>
-          <a:ln w="12700">
-            <a:solidFill>
-              <a:srgbClr val="F1F6F5"/>
-            </a:solidFill>
-            <a:prstDash val="solid"/>
-          </a:ln>
-        </p:spPr>
-      </p:sp>
-      <p:sp>
-        <p:nvSpPr>
-          <p:cNvPr id="40" name="Shape 38"/>
-          <p:cNvSpPr/>
-          <p:nvPr/>
-        </p:nvSpPr>
-        <p:spPr>
-          <a:xfrm>
-            <a:off x="9146286" y="4270248"/>
-            <a:ext cx="402336" cy="402336"/>
-          </a:xfrm>
-          <a:prstGeom prst="ellipse">
-            <a:avLst/>
-          </a:prstGeom>
-          <a:solidFill>
-            <a:srgbClr val="3E8E84"/>
-          </a:solidFill>
-          <a:ln w="12700">
-            <a:solidFill>
-              <a:srgbClr val="3E8E84"/>
-            </a:solidFill>
-            <a:prstDash val="solid"/>
-          </a:ln>
-        </p:spPr>
-      </p:sp>
-      <p:sp>
-        <p:nvSpPr>
-          <p:cNvPr id="41" name="Text 39"/>
-          <p:cNvSpPr/>
-          <p:nvPr/>
-        </p:nvSpPr>
-        <p:spPr>
-          <a:xfrm>
-            <a:off x="9146286" y="4270248"/>
-            <a:ext cx="402336" cy="402336"/>
-          </a:xfrm>
-          <a:prstGeom prst="rect">
-            <a:avLst/>
-          </a:prstGeom>
-          <a:noFill/>
-          <a:ln/>
-        </p:spPr>
-        <p:txBody>
-          <a:bodyPr wrap="square" lIns="0" tIns="0" rIns="0" bIns="0" rtlCol="0" anchor="ctr"/>
-          <a:lstStyle/>
-          <a:p>
-            <a:pPr algn="ctr" indent="0" marL="0">
-              <a:buNone/>
-            </a:pPr>
-            <a:r>
-              <a:rPr lang="en-US" sz="1300" b="1" dirty="0">
-                <a:solidFill>
-                  <a:srgbClr val="FFFFFF"/>
-                </a:solidFill>
-                <a:latin typeface="Yu Gothic" pitchFamily="34" charset="0"/>
-                <a:ea typeface="Yu Gothic" pitchFamily="34" charset="-122"/>
-                <a:cs typeface="Yu Gothic" pitchFamily="34" charset="-120"/>
-              </a:rPr>
-              <a:t>8</a:t>
-            </a:r>
-            <a:endParaRPr lang="en-US" sz="1300" dirty="0"/>
-          </a:p>
-        </p:txBody>
-      </p:sp>
-      <p:sp>
-        <p:nvSpPr>
-          <p:cNvPr id="42" name="Text 40"/>
-          <p:cNvSpPr/>
-          <p:nvPr/>
-        </p:nvSpPr>
-        <p:spPr>
-          <a:xfrm>
-            <a:off x="9127998" y="4764024"/>
-            <a:ext cx="2183130" cy="347472"/>
-          </a:xfrm>
-          <a:prstGeom prst="rect">
-            <a:avLst/>
-          </a:prstGeom>
-          <a:noFill/>
-          <a:ln/>
-        </p:spPr>
-        <p:txBody>
-          <a:bodyPr wrap="square" lIns="0" tIns="0" rIns="0" bIns="0" rtlCol="0" anchor="ctr"/>
-          <a:lstStyle/>
-          <a:p>
-            <a:pPr indent="0" marL="0">
-              <a:buNone/>
-            </a:pPr>
-            <a:r>
-              <a:rPr lang="en-US" sz="1500" b="1" dirty="0">
-                <a:solidFill>
-                  <a:srgbClr val="14504B"/>
-                </a:solidFill>
-                <a:latin typeface="Yu Gothic" pitchFamily="34" charset="0"/>
-                <a:ea typeface="Yu Gothic" pitchFamily="34" charset="-122"/>
-                <a:cs typeface="Yu Gothic" pitchFamily="34" charset="-120"/>
-              </a:rPr>
-              <a:t>記録の書面出力</a:t>
-            </a:r>
-            <a:endParaRPr lang="en-US" sz="1500" dirty="0"/>
-          </a:p>
-        </p:txBody>
-      </p:sp>
-      <p:sp>
-        <p:nvSpPr>
-          <p:cNvPr id="43" name="Text 41"/>
-          <p:cNvSpPr/>
-          <p:nvPr/>
-        </p:nvSpPr>
-        <p:spPr>
-          <a:xfrm>
-            <a:off x="9127998" y="5148072"/>
-            <a:ext cx="2228850" cy="777240"/>
-          </a:xfrm>
-          <a:prstGeom prst="rect">
-            <a:avLst/>
-          </a:prstGeom>
-          <a:noFill/>
-          <a:ln/>
-        </p:spPr>
-        <p:txBody>
-          <a:bodyPr wrap="square" lIns="0" tIns="0" rIns="0" bIns="0" rtlCol="0" anchor="ctr"/>
-          <a:lstStyle/>
-          <a:p>
-            <a:pPr indent="0" marL="0">
-              <a:lnSpc>
-                <a:spcPct val="120000"/>
-              </a:lnSpc>
-              <a:buNone/>
-            </a:pPr>
-            <a:r>
-              <a:rPr lang="en-US" sz="1200" dirty="0">
-                <a:solidFill>
-                  <a:srgbClr val="5C6B68"/>
-                </a:solidFill>
-                <a:latin typeface="Yu Gothic" pitchFamily="34" charset="0"/>
-                <a:ea typeface="Yu Gothic" pitchFamily="34" charset="-122"/>
-                <a:cs typeface="Yu Gothic" pitchFamily="34" charset="-120"/>
-              </a:rPr>
-              <a:t>保管中の記録を</a:t>
-            </a:r>
-            <a:endParaRPr lang="en-US" sz="1200" dirty="0"/>
-          </a:p>
-          <a:p>
-            <a:pPr indent="0" marL="0">
-              <a:lnSpc>
-                <a:spcPct val="120000"/>
-              </a:lnSpc>
-              <a:buNone/>
-            </a:pPr>
-            <a:r>
-              <a:rPr lang="en-US" sz="1200" dirty="0">
-                <a:solidFill>
-                  <a:srgbClr val="5C6B68"/>
-                </a:solidFill>
-                <a:latin typeface="Yu Gothic" pitchFamily="34" charset="0"/>
-                <a:ea typeface="Yu Gothic" pitchFamily="34" charset="-122"/>
-                <a:cs typeface="Yu Gothic" pitchFamily="34" charset="-120"/>
-              </a:rPr>
-              <a:t>そのまま印刷できる</a:t>
-            </a:r>
-            <a:endParaRPr lang="en-US" sz="1200" dirty="0"/>
-          </a:p>
-        </p:txBody>
-      </p:sp>
-      <p:sp>
-        <p:nvSpPr>
-          <p:cNvPr id="44" name="Text 42"/>
-          <p:cNvSpPr/>
-          <p:nvPr/>
-        </p:nvSpPr>
-        <p:spPr>
-          <a:xfrm>
-            <a:off x="731520" y="6108192"/>
-            <a:ext cx="5486400" cy="292608"/>
-          </a:xfrm>
-          <a:prstGeom prst="rect">
-            <a:avLst/>
-          </a:prstGeom>
-          <a:noFill/>
-          <a:ln/>
-        </p:spPr>
-        <p:txBody>
-          <a:bodyPr wrap="square" lIns="0" tIns="0" rIns="0" bIns="0" rtlCol="0" anchor="ctr"/>
-          <a:lstStyle/>
-          <a:p>
-            <a:pPr indent="0" marL="0">
-              <a:buNone/>
-            </a:pPr>
-            <a:r>
-              <a:rPr lang="en-US" sz="1300" b="1" dirty="0">
-                <a:solidFill>
-                  <a:srgbClr val="D98A2B"/>
-                </a:solidFill>
-                <a:latin typeface="Yu Gothic" pitchFamily="34" charset="0"/>
-                <a:ea typeface="Yu Gothic" pitchFamily="34" charset="-122"/>
-                <a:cs typeface="Yu Gothic" pitchFamily="34" charset="-120"/>
-              </a:rPr>
-              <a:t>⑤⑥はAIを使う機能</a:t>
-            </a:r>
-            <a:endParaRPr lang="en-US" sz="1300" dirty="0"/>
-          </a:p>
-        </p:txBody>
-      </p:sp>
-      <p:sp>
-        <p:nvSpPr>
-          <p:cNvPr id="45" name="Text 43"/>
-          <p:cNvSpPr/>
-          <p:nvPr/>
-        </p:nvSpPr>
-        <p:spPr>
-          <a:xfrm>
-            <a:off x="731520" y="6400800"/>
-            <a:ext cx="10698480" cy="320040"/>
+            <a:off x="731520" y="6144768"/>
+            <a:ext cx="10698480" cy="365760"/>
           </a:xfrm>
           <a:prstGeom prst="rect">
             <a:avLst/>
@@ -18478,7 +17913,7 @@
                 <a:ea typeface="Yu Gothic" pitchFamily="34" charset="-122"/>
                 <a:cs typeface="Yu Gothic" pitchFamily="34" charset="-120"/>
               </a:rPr>
-              <a:t>②と⑤がつながっているのがこのアプリの要。「血圧が下がってきたので降圧薬を見直しては」という相談が、数字を見ながらできます。</a:t>
+              <a:t>Webブラウザだけで使えます。専用アプリのインストールは要りません。施設の共用パソコンでも、タブレットでも同じ画面です。</a:t>
             </a:r>
             <a:endParaRPr lang="en-US" sz="1300" dirty="0"/>
           </a:p>
@@ -18549,7 +17984,7 @@
                 <a:ea typeface="Yu Gothic" pitchFamily="34" charset="-122"/>
                 <a:cs typeface="Yu Gothic" pitchFamily="34" charset="-120"/>
               </a:rPr>
-              <a:t>施設をつくり、招待コードでつながる</a:t>
+              <a:t>日々の記録から、判断の支援まで</a:t>
             </a:r>
             <a:endParaRPr lang="en-US" sz="3600" dirty="0"/>
           </a:p>
@@ -18557,18 +17992,57 @@
       </p:sp>
       <p:sp>
         <p:nvSpPr>
-          <p:cNvPr id="3" name="Shape 1"/>
-          <p:cNvSpPr/>
-          <p:nvPr/>
-        </p:nvSpPr>
-        <p:spPr>
-          <a:xfrm>
-            <a:off x="731520" y="2057400"/>
-            <a:ext cx="1920240" cy="1828800"/>
+          <p:cNvPr id="3" name="Text 1"/>
+          <p:cNvSpPr/>
+          <p:nvPr/>
+        </p:nvSpPr>
+        <p:spPr>
+          <a:xfrm>
+            <a:off x="731520" y="1225296"/>
+            <a:ext cx="10698480" cy="411480"/>
+          </a:xfrm>
+          <a:prstGeom prst="rect">
+            <a:avLst/>
+          </a:prstGeom>
+          <a:noFill/>
+          <a:ln/>
+        </p:spPr>
+        <p:txBody>
+          <a:bodyPr wrap="square" lIns="0" tIns="0" rIns="0" bIns="0" rtlCol="0" anchor="ctr"/>
+          <a:lstStyle/>
+          <a:p>
+            <a:pPr indent="0" marL="0">
+              <a:buNone/>
+            </a:pPr>
+            <a:r>
+              <a:rPr lang="en-US" sz="1600" dirty="0">
+                <a:solidFill>
+                  <a:srgbClr val="5C6B68"/>
+                </a:solidFill>
+                <a:latin typeface="Yu Gothic" pitchFamily="34" charset="0"/>
+                <a:ea typeface="Yu Gothic" pitchFamily="34" charset="-122"/>
+                <a:cs typeface="Yu Gothic" pitchFamily="34" charset="-120"/>
+              </a:rPr>
+              <a:t>記録する・相談する・判断を助ける。ばらばらだったものが、ひとつの画面の中でつながります</a:t>
+            </a:r>
+            <a:endParaRPr lang="en-US" sz="1600" dirty="0"/>
+          </a:p>
+        </p:txBody>
+      </p:sp>
+      <p:sp>
+        <p:nvSpPr>
+          <p:cNvPr id="4" name="Shape 2"/>
+          <p:cNvSpPr/>
+          <p:nvPr/>
+        </p:nvSpPr>
+        <p:spPr>
+          <a:xfrm>
+            <a:off x="731520" y="1920240"/>
+            <a:ext cx="2503170" cy="1965960"/>
           </a:xfrm>
           <a:prstGeom prst="roundRect">
             <a:avLst>
-              <a:gd name="adj" fmla="val 4000"/>
+              <a:gd name="adj" fmla="val 3721"/>
             </a:avLst>
           </a:prstGeom>
           <a:solidFill>
@@ -18584,24 +18058,24 @@
       </p:sp>
       <p:sp>
         <p:nvSpPr>
-          <p:cNvPr id="4" name="Shape 2"/>
-          <p:cNvSpPr/>
-          <p:nvPr/>
-        </p:nvSpPr>
-        <p:spPr>
-          <a:xfrm>
-            <a:off x="1417320" y="2286000"/>
-            <a:ext cx="566928" cy="566928"/>
+          <p:cNvPr id="5" name="Shape 3"/>
+          <p:cNvSpPr/>
+          <p:nvPr/>
+        </p:nvSpPr>
+        <p:spPr>
+          <a:xfrm>
+            <a:off x="950976" y="2121408"/>
+            <a:ext cx="402336" cy="402336"/>
           </a:xfrm>
           <a:prstGeom prst="ellipse">
             <a:avLst/>
           </a:prstGeom>
           <a:solidFill>
-            <a:srgbClr val="14504B"/>
+            <a:srgbClr val="3E8E84"/>
           </a:solidFill>
           <a:ln w="12700">
             <a:solidFill>
-              <a:srgbClr val="14504B"/>
+              <a:srgbClr val="3E8E84"/>
             </a:solidFill>
             <a:prstDash val="solid"/>
           </a:ln>
@@ -18609,14 +18083,14 @@
       </p:sp>
       <p:sp>
         <p:nvSpPr>
-          <p:cNvPr id="5" name="Text 3"/>
-          <p:cNvSpPr/>
-          <p:nvPr/>
-        </p:nvSpPr>
-        <p:spPr>
-          <a:xfrm>
-            <a:off x="1417320" y="2286000"/>
-            <a:ext cx="566928" cy="566928"/>
+          <p:cNvPr id="6" name="Text 4"/>
+          <p:cNvSpPr/>
+          <p:nvPr/>
+        </p:nvSpPr>
+        <p:spPr>
+          <a:xfrm>
+            <a:off x="950976" y="2121408"/>
+            <a:ext cx="402336" cy="402336"/>
           </a:xfrm>
           <a:prstGeom prst="rect">
             <a:avLst/>
@@ -18632,7 +18106,7 @@
               <a:buNone/>
             </a:pPr>
             <a:r>
-              <a:rPr lang="en-US" sz="2000" b="1" dirty="0">
+              <a:rPr lang="en-US" sz="1300" b="1" dirty="0">
                 <a:solidFill>
                   <a:srgbClr val="FFFFFF"/>
                 </a:solidFill>
@@ -18642,32 +18116,32 @@
               </a:rPr>
               <a:t>1</a:t>
             </a:r>
-            <a:endParaRPr lang="en-US" sz="2000" dirty="0"/>
-          </a:p>
-        </p:txBody>
-      </p:sp>
-      <p:sp>
-        <p:nvSpPr>
-          <p:cNvPr id="6" name="Text 4"/>
-          <p:cNvSpPr/>
-          <p:nvPr/>
-        </p:nvSpPr>
-        <p:spPr>
-          <a:xfrm>
-            <a:off x="749808" y="3063240"/>
-            <a:ext cx="1883664" cy="685800"/>
-          </a:xfrm>
-          <a:prstGeom prst="rect">
-            <a:avLst/>
-          </a:prstGeom>
-          <a:noFill/>
-          <a:ln/>
-        </p:spPr>
-        <p:txBody>
-          <a:bodyPr wrap="square" lIns="0" tIns="0" rIns="0" bIns="0" rtlCol="0" anchor="ctr"/>
-          <a:lstStyle/>
-          <a:p>
-            <a:pPr algn="ctr" indent="0" marL="0">
+            <a:endParaRPr lang="en-US" sz="1300" dirty="0"/>
+          </a:p>
+        </p:txBody>
+      </p:sp>
+      <p:sp>
+        <p:nvSpPr>
+          <p:cNvPr id="7" name="Text 5"/>
+          <p:cNvSpPr/>
+          <p:nvPr/>
+        </p:nvSpPr>
+        <p:spPr>
+          <a:xfrm>
+            <a:off x="932688" y="2615184"/>
+            <a:ext cx="2183130" cy="347472"/>
+          </a:xfrm>
+          <a:prstGeom prst="rect">
+            <a:avLst/>
+          </a:prstGeom>
+          <a:noFill/>
+          <a:ln/>
+        </p:spPr>
+        <p:txBody>
+          <a:bodyPr wrap="square" lIns="0" tIns="0" rIns="0" bIns="0" rtlCol="0" anchor="ctr"/>
+          <a:lstStyle/>
+          <a:p>
+            <a:pPr indent="0" marL="0">
               <a:buNone/>
             </a:pPr>
             <a:r>
@@ -18679,7 +18153,7 @@
                 <a:ea typeface="Yu Gothic" pitchFamily="34" charset="-122"/>
                 <a:cs typeface="Yu Gothic" pitchFamily="34" charset="-120"/>
               </a:rPr>
-              <a:t>施設をつくる</a:t>
+              <a:t>お薬手帳</a:t>
             </a:r>
             <a:endParaRPr lang="en-US" sz="1500" dirty="0"/>
           </a:p>
@@ -18687,43 +18161,80 @@
       </p:sp>
       <p:sp>
         <p:nvSpPr>
-          <p:cNvPr id="7" name="Shape 5"/>
-          <p:cNvSpPr/>
-          <p:nvPr/>
-        </p:nvSpPr>
-        <p:spPr>
-          <a:xfrm>
-            <a:off x="2688336" y="2880360"/>
-            <a:ext cx="219456" cy="237744"/>
-          </a:xfrm>
-          <a:prstGeom prst="rightArrow">
-            <a:avLst/>
-          </a:prstGeom>
-          <a:solidFill>
-            <a:srgbClr val="A8CFC9"/>
-          </a:solidFill>
-          <a:ln w="12700">
-            <a:solidFill>
-              <a:srgbClr val="A8CFC9"/>
-            </a:solidFill>
-            <a:prstDash val="solid"/>
-          </a:ln>
-        </p:spPr>
-      </p:sp>
-      <p:sp>
-        <p:nvSpPr>
-          <p:cNvPr id="8" name="Shape 6"/>
-          <p:cNvSpPr/>
-          <p:nvPr/>
-        </p:nvSpPr>
-        <p:spPr>
-          <a:xfrm>
-            <a:off x="2971800" y="2057400"/>
-            <a:ext cx="1920240" cy="1828800"/>
+          <p:cNvPr id="8" name="Text 6"/>
+          <p:cNvSpPr/>
+          <p:nvPr/>
+        </p:nvSpPr>
+        <p:spPr>
+          <a:xfrm>
+            <a:off x="932688" y="2999232"/>
+            <a:ext cx="2228850" cy="777240"/>
+          </a:xfrm>
+          <a:prstGeom prst="rect">
+            <a:avLst/>
+          </a:prstGeom>
+          <a:noFill/>
+          <a:ln/>
+        </p:spPr>
+        <p:txBody>
+          <a:bodyPr wrap="square" lIns="0" tIns="0" rIns="0" bIns="0" rtlCol="0" anchor="ctr"/>
+          <a:lstStyle/>
+          <a:p>
+            <a:pPr indent="0" marL="0">
+              <a:lnSpc>
+                <a:spcPct val="120000"/>
+              </a:lnSpc>
+              <a:buNone/>
+            </a:pPr>
+            <a:r>
+              <a:rPr lang="en-US" sz="1200" dirty="0">
+                <a:solidFill>
+                  <a:srgbClr val="5C6B68"/>
+                </a:solidFill>
+                <a:latin typeface="Yu Gothic" pitchFamily="34" charset="0"/>
+                <a:ea typeface="Yu Gothic" pitchFamily="34" charset="-122"/>
+                <a:cs typeface="Yu Gothic" pitchFamily="34" charset="-120"/>
+              </a:rPr>
+              <a:t>QRコードで5秒登録。</a:t>
+            </a:r>
+            <a:endParaRPr lang="en-US" sz="1200" dirty="0"/>
+          </a:p>
+          <a:p>
+            <a:pPr indent="0" marL="0">
+              <a:lnSpc>
+                <a:spcPct val="120000"/>
+              </a:lnSpc>
+              <a:buNone/>
+            </a:pPr>
+            <a:r>
+              <a:rPr lang="en-US" sz="1200" dirty="0">
+                <a:solidFill>
+                  <a:srgbClr val="5C6B68"/>
+                </a:solidFill>
+                <a:latin typeface="Yu Gothic" pitchFamily="34" charset="0"/>
+                <a:ea typeface="Yu Gothic" pitchFamily="34" charset="-122"/>
+                <a:cs typeface="Yu Gothic" pitchFamily="34" charset="-120"/>
+              </a:rPr>
+              <a:t>変更履歴も自動で残る</a:t>
+            </a:r>
+            <a:endParaRPr lang="en-US" sz="1200" dirty="0"/>
+          </a:p>
+        </p:txBody>
+      </p:sp>
+      <p:sp>
+        <p:nvSpPr>
+          <p:cNvPr id="9" name="Shape 7"/>
+          <p:cNvSpPr/>
+          <p:nvPr/>
+        </p:nvSpPr>
+        <p:spPr>
+          <a:xfrm>
+            <a:off x="3463290" y="1920240"/>
+            <a:ext cx="2503170" cy="1965960"/>
           </a:xfrm>
           <a:prstGeom prst="roundRect">
             <a:avLst>
-              <a:gd name="adj" fmla="val 4000"/>
+              <a:gd name="adj" fmla="val 3721"/>
             </a:avLst>
           </a:prstGeom>
           <a:solidFill>
@@ -18739,14 +18250,14 @@
       </p:sp>
       <p:sp>
         <p:nvSpPr>
-          <p:cNvPr id="9" name="Shape 7"/>
-          <p:cNvSpPr/>
-          <p:nvPr/>
-        </p:nvSpPr>
-        <p:spPr>
-          <a:xfrm>
-            <a:off x="3657600" y="2286000"/>
-            <a:ext cx="566928" cy="566928"/>
+          <p:cNvPr id="10" name="Shape 8"/>
+          <p:cNvSpPr/>
+          <p:nvPr/>
+        </p:nvSpPr>
+        <p:spPr>
+          <a:xfrm>
+            <a:off x="3682746" y="2121408"/>
+            <a:ext cx="402336" cy="402336"/>
           </a:xfrm>
           <a:prstGeom prst="ellipse">
             <a:avLst/>
@@ -18764,14 +18275,14 @@
       </p:sp>
       <p:sp>
         <p:nvSpPr>
-          <p:cNvPr id="10" name="Text 8"/>
-          <p:cNvSpPr/>
-          <p:nvPr/>
-        </p:nvSpPr>
-        <p:spPr>
-          <a:xfrm>
-            <a:off x="3657600" y="2286000"/>
-            <a:ext cx="566928" cy="566928"/>
+          <p:cNvPr id="11" name="Text 9"/>
+          <p:cNvSpPr/>
+          <p:nvPr/>
+        </p:nvSpPr>
+        <p:spPr>
+          <a:xfrm>
+            <a:off x="3682746" y="2121408"/>
+            <a:ext cx="402336" cy="402336"/>
           </a:xfrm>
           <a:prstGeom prst="rect">
             <a:avLst/>
@@ -18787,7 +18298,7 @@
               <a:buNone/>
             </a:pPr>
             <a:r>
-              <a:rPr lang="en-US" sz="2000" b="1" dirty="0">
+              <a:rPr lang="en-US" sz="1300" b="1" dirty="0">
                 <a:solidFill>
                   <a:srgbClr val="FFFFFF"/>
                 </a:solidFill>
@@ -18797,32 +18308,32 @@
               </a:rPr>
               <a:t>2</a:t>
             </a:r>
-            <a:endParaRPr lang="en-US" sz="2000" dirty="0"/>
-          </a:p>
-        </p:txBody>
-      </p:sp>
-      <p:sp>
-        <p:nvSpPr>
-          <p:cNvPr id="11" name="Text 9"/>
-          <p:cNvSpPr/>
-          <p:nvPr/>
-        </p:nvSpPr>
-        <p:spPr>
-          <a:xfrm>
-            <a:off x="2990088" y="3063240"/>
-            <a:ext cx="1883664" cy="685800"/>
-          </a:xfrm>
-          <a:prstGeom prst="rect">
-            <a:avLst/>
-          </a:prstGeom>
-          <a:noFill/>
-          <a:ln/>
-        </p:spPr>
-        <p:txBody>
-          <a:bodyPr wrap="square" lIns="0" tIns="0" rIns="0" bIns="0" rtlCol="0" anchor="ctr"/>
-          <a:lstStyle/>
-          <a:p>
-            <a:pPr algn="ctr" indent="0" marL="0">
+            <a:endParaRPr lang="en-US" sz="1300" dirty="0"/>
+          </a:p>
+        </p:txBody>
+      </p:sp>
+      <p:sp>
+        <p:nvSpPr>
+          <p:cNvPr id="12" name="Text 10"/>
+          <p:cNvSpPr/>
+          <p:nvPr/>
+        </p:nvSpPr>
+        <p:spPr>
+          <a:xfrm>
+            <a:off x="3664458" y="2615184"/>
+            <a:ext cx="2183130" cy="347472"/>
+          </a:xfrm>
+          <a:prstGeom prst="rect">
+            <a:avLst/>
+          </a:prstGeom>
+          <a:noFill/>
+          <a:ln/>
+        </p:spPr>
+        <p:txBody>
+          <a:bodyPr wrap="square" lIns="0" tIns="0" rIns="0" bIns="0" rtlCol="0" anchor="ctr"/>
+          <a:lstStyle/>
+          <a:p>
+            <a:pPr indent="0" marL="0">
               <a:buNone/>
             </a:pPr>
             <a:r>
@@ -18834,7 +18345,7 @@
                 <a:ea typeface="Yu Gothic" pitchFamily="34" charset="-122"/>
                 <a:cs typeface="Yu Gothic" pitchFamily="34" charset="-120"/>
               </a:rPr>
-              <a:t>招待コード発行</a:t>
+              <a:t>服薬記録・バイタル</a:t>
             </a:r>
             <a:endParaRPr lang="en-US" sz="1500" dirty="0"/>
           </a:p>
@@ -18842,43 +18353,80 @@
       </p:sp>
       <p:sp>
         <p:nvSpPr>
-          <p:cNvPr id="12" name="Shape 10"/>
-          <p:cNvSpPr/>
-          <p:nvPr/>
-        </p:nvSpPr>
-        <p:spPr>
-          <a:xfrm>
-            <a:off x="4928616" y="2880360"/>
-            <a:ext cx="219456" cy="237744"/>
-          </a:xfrm>
-          <a:prstGeom prst="rightArrow">
-            <a:avLst/>
-          </a:prstGeom>
-          <a:solidFill>
-            <a:srgbClr val="A8CFC9"/>
-          </a:solidFill>
-          <a:ln w="12700">
-            <a:solidFill>
-              <a:srgbClr val="A8CFC9"/>
-            </a:solidFill>
-            <a:prstDash val="solid"/>
-          </a:ln>
-        </p:spPr>
-      </p:sp>
-      <p:sp>
-        <p:nvSpPr>
-          <p:cNvPr id="13" name="Shape 11"/>
-          <p:cNvSpPr/>
-          <p:nvPr/>
-        </p:nvSpPr>
-        <p:spPr>
-          <a:xfrm>
-            <a:off x="5212080" y="2057400"/>
-            <a:ext cx="1920240" cy="1828800"/>
+          <p:cNvPr id="13" name="Text 11"/>
+          <p:cNvSpPr/>
+          <p:nvPr/>
+        </p:nvSpPr>
+        <p:spPr>
+          <a:xfrm>
+            <a:off x="3664458" y="2999232"/>
+            <a:ext cx="2228850" cy="777240"/>
+          </a:xfrm>
+          <a:prstGeom prst="rect">
+            <a:avLst/>
+          </a:prstGeom>
+          <a:noFill/>
+          <a:ln/>
+        </p:spPr>
+        <p:txBody>
+          <a:bodyPr wrap="square" lIns="0" tIns="0" rIns="0" bIns="0" rtlCol="0" anchor="ctr"/>
+          <a:lstStyle/>
+          <a:p>
+            <a:pPr indent="0" marL="0">
+              <a:lnSpc>
+                <a:spcPct val="120000"/>
+              </a:lnSpc>
+              <a:buNone/>
+            </a:pPr>
+            <a:r>
+              <a:rPr lang="en-US" sz="1200" dirty="0">
+                <a:solidFill>
+                  <a:srgbClr val="5C6B68"/>
+                </a:solidFill>
+                <a:latin typeface="Yu Gothic" pitchFamily="34" charset="0"/>
+                <a:ea typeface="Yu Gothic" pitchFamily="34" charset="-122"/>
+                <a:cs typeface="Yu Gothic" pitchFamily="34" charset="-120"/>
+              </a:rPr>
+              <a:t>服薬の実施、血圧・体温・</a:t>
+            </a:r>
+            <a:endParaRPr lang="en-US" sz="1200" dirty="0"/>
+          </a:p>
+          <a:p>
+            <a:pPr indent="0" marL="0">
+              <a:lnSpc>
+                <a:spcPct val="120000"/>
+              </a:lnSpc>
+              <a:buNone/>
+            </a:pPr>
+            <a:r>
+              <a:rPr lang="en-US" sz="1200" dirty="0">
+                <a:solidFill>
+                  <a:srgbClr val="5C6B68"/>
+                </a:solidFill>
+                <a:latin typeface="Yu Gothic" pitchFamily="34" charset="0"/>
+                <a:ea typeface="Yu Gothic" pitchFamily="34" charset="-122"/>
+                <a:cs typeface="Yu Gothic" pitchFamily="34" charset="-120"/>
+              </a:rPr>
+              <a:t>SpO₂を日々の記録として</a:t>
+            </a:r>
+            <a:endParaRPr lang="en-US" sz="1200" dirty="0"/>
+          </a:p>
+        </p:txBody>
+      </p:sp>
+      <p:sp>
+        <p:nvSpPr>
+          <p:cNvPr id="14" name="Shape 12"/>
+          <p:cNvSpPr/>
+          <p:nvPr/>
+        </p:nvSpPr>
+        <p:spPr>
+          <a:xfrm>
+            <a:off x="6195060" y="1920240"/>
+            <a:ext cx="2503170" cy="1965960"/>
           </a:xfrm>
           <a:prstGeom prst="roundRect">
             <a:avLst>
-              <a:gd name="adj" fmla="val 4000"/>
+              <a:gd name="adj" fmla="val 3721"/>
             </a:avLst>
           </a:prstGeom>
           <a:solidFill>
@@ -18894,14 +18442,14 @@
       </p:sp>
       <p:sp>
         <p:nvSpPr>
-          <p:cNvPr id="14" name="Shape 12"/>
-          <p:cNvSpPr/>
-          <p:nvPr/>
-        </p:nvSpPr>
-        <p:spPr>
-          <a:xfrm>
-            <a:off x="5897880" y="2286000"/>
-            <a:ext cx="566928" cy="566928"/>
+          <p:cNvPr id="15" name="Shape 13"/>
+          <p:cNvSpPr/>
+          <p:nvPr/>
+        </p:nvSpPr>
+        <p:spPr>
+          <a:xfrm>
+            <a:off x="6414516" y="2121408"/>
+            <a:ext cx="402336" cy="402336"/>
           </a:xfrm>
           <a:prstGeom prst="ellipse">
             <a:avLst/>
@@ -18919,14 +18467,14 @@
       </p:sp>
       <p:sp>
         <p:nvSpPr>
-          <p:cNvPr id="15" name="Text 13"/>
-          <p:cNvSpPr/>
-          <p:nvPr/>
-        </p:nvSpPr>
-        <p:spPr>
-          <a:xfrm>
-            <a:off x="5897880" y="2286000"/>
-            <a:ext cx="566928" cy="566928"/>
+          <p:cNvPr id="16" name="Text 14"/>
+          <p:cNvSpPr/>
+          <p:nvPr/>
+        </p:nvSpPr>
+        <p:spPr>
+          <a:xfrm>
+            <a:off x="6414516" y="2121408"/>
+            <a:ext cx="402336" cy="402336"/>
           </a:xfrm>
           <a:prstGeom prst="rect">
             <a:avLst/>
@@ -18942,7 +18490,7 @@
               <a:buNone/>
             </a:pPr>
             <a:r>
-              <a:rPr lang="en-US" sz="2000" b="1" dirty="0">
+              <a:rPr lang="en-US" sz="1300" b="1" dirty="0">
                 <a:solidFill>
                   <a:srgbClr val="FFFFFF"/>
                 </a:solidFill>
@@ -18952,32 +18500,32 @@
               </a:rPr>
               <a:t>3</a:t>
             </a:r>
-            <a:endParaRPr lang="en-US" sz="2000" dirty="0"/>
-          </a:p>
-        </p:txBody>
-      </p:sp>
-      <p:sp>
-        <p:nvSpPr>
-          <p:cNvPr id="16" name="Text 14"/>
-          <p:cNvSpPr/>
-          <p:nvPr/>
-        </p:nvSpPr>
-        <p:spPr>
-          <a:xfrm>
-            <a:off x="5230368" y="3063240"/>
-            <a:ext cx="1883664" cy="685800"/>
-          </a:xfrm>
-          <a:prstGeom prst="rect">
-            <a:avLst/>
-          </a:prstGeom>
-          <a:noFill/>
-          <a:ln/>
-        </p:spPr>
-        <p:txBody>
-          <a:bodyPr wrap="square" lIns="0" tIns="0" rIns="0" bIns="0" rtlCol="0" anchor="ctr"/>
-          <a:lstStyle/>
-          <a:p>
-            <a:pPr algn="ctr" indent="0" marL="0">
+            <a:endParaRPr lang="en-US" sz="1300" dirty="0"/>
+          </a:p>
+        </p:txBody>
+      </p:sp>
+      <p:sp>
+        <p:nvSpPr>
+          <p:cNvPr id="17" name="Text 15"/>
+          <p:cNvSpPr/>
+          <p:nvPr/>
+        </p:nvSpPr>
+        <p:spPr>
+          <a:xfrm>
+            <a:off x="6396228" y="2615184"/>
+            <a:ext cx="2183130" cy="347472"/>
+          </a:xfrm>
+          <a:prstGeom prst="rect">
+            <a:avLst/>
+          </a:prstGeom>
+          <a:noFill/>
+          <a:ln/>
+        </p:spPr>
+        <p:txBody>
+          <a:bodyPr wrap="square" lIns="0" tIns="0" rIns="0" bIns="0" rtlCol="0" anchor="ctr"/>
+          <a:lstStyle/>
+          <a:p>
+            <a:pPr indent="0" marL="0">
               <a:buNone/>
             </a:pPr>
             <a:r>
@@ -18989,7 +18537,7 @@
                 <a:ea typeface="Yu Gothic" pitchFamily="34" charset="-122"/>
                 <a:cs typeface="Yu Gothic" pitchFamily="34" charset="-120"/>
               </a:rPr>
-              <a:t>職員が参加</a:t>
+              <a:t>チャット</a:t>
             </a:r>
             <a:endParaRPr lang="en-US" sz="1500" dirty="0"/>
           </a:p>
@@ -18997,43 +18545,100 @@
       </p:sp>
       <p:sp>
         <p:nvSpPr>
-          <p:cNvPr id="17" name="Shape 15"/>
-          <p:cNvSpPr/>
-          <p:nvPr/>
-        </p:nvSpPr>
-        <p:spPr>
-          <a:xfrm>
-            <a:off x="7168896" y="2880360"/>
-            <a:ext cx="219456" cy="237744"/>
-          </a:xfrm>
-          <a:prstGeom prst="rightArrow">
-            <a:avLst/>
-          </a:prstGeom>
-          <a:solidFill>
-            <a:srgbClr val="A8CFC9"/>
-          </a:solidFill>
-          <a:ln w="12700">
-            <a:solidFill>
-              <a:srgbClr val="A8CFC9"/>
-            </a:solidFill>
-            <a:prstDash val="solid"/>
-          </a:ln>
-        </p:spPr>
-      </p:sp>
-      <p:sp>
-        <p:nvSpPr>
-          <p:cNvPr id="18" name="Shape 16"/>
-          <p:cNvSpPr/>
-          <p:nvPr/>
-        </p:nvSpPr>
-        <p:spPr>
-          <a:xfrm>
-            <a:off x="7452360" y="2057400"/>
-            <a:ext cx="1920240" cy="1828800"/>
+          <p:cNvPr id="18" name="Text 16"/>
+          <p:cNvSpPr/>
+          <p:nvPr/>
+        </p:nvSpPr>
+        <p:spPr>
+          <a:xfrm>
+            <a:off x="6396228" y="2999232"/>
+            <a:ext cx="2228850" cy="777240"/>
+          </a:xfrm>
+          <a:prstGeom prst="rect">
+            <a:avLst/>
+          </a:prstGeom>
+          <a:noFill/>
+          <a:ln/>
+        </p:spPr>
+        <p:txBody>
+          <a:bodyPr wrap="square" lIns="0" tIns="0" rIns="0" bIns="0" rtlCol="0" anchor="ctr"/>
+          <a:lstStyle/>
+          <a:p>
+            <a:pPr indent="0" marL="0">
+              <a:lnSpc>
+                <a:spcPct val="120000"/>
+              </a:lnSpc>
+              <a:buNone/>
+            </a:pPr>
+            <a:r>
+              <a:rPr lang="en-US" sz="1200" dirty="0">
+                <a:solidFill>
+                  <a:srgbClr val="5C6B68"/>
+                </a:solidFill>
+                <a:latin typeface="Yu Gothic" pitchFamily="34" charset="0"/>
+                <a:ea typeface="Yu Gothic" pitchFamily="34" charset="-122"/>
+                <a:cs typeface="Yu Gothic" pitchFamily="34" charset="-120"/>
+              </a:rPr>
+              <a:t>入居者ごとの相談ルーム。</a:t>
+            </a:r>
+            <a:endParaRPr lang="en-US" sz="1200" dirty="0"/>
+          </a:p>
+          <a:p>
+            <a:pPr indent="0" marL="0">
+              <a:lnSpc>
+                <a:spcPct val="120000"/>
+              </a:lnSpc>
+              <a:buNone/>
+            </a:pPr>
+            <a:r>
+              <a:rPr lang="en-US" sz="1200" dirty="0">
+                <a:solidFill>
+                  <a:srgbClr val="5C6B68"/>
+                </a:solidFill>
+                <a:latin typeface="Yu Gothic" pitchFamily="34" charset="0"/>
+                <a:ea typeface="Yu Gothic" pitchFamily="34" charset="-122"/>
+                <a:cs typeface="Yu Gothic" pitchFamily="34" charset="-120"/>
+              </a:rPr>
+              <a:t>何の薬の話かが</a:t>
+            </a:r>
+            <a:endParaRPr lang="en-US" sz="1200" dirty="0"/>
+          </a:p>
+          <a:p>
+            <a:pPr indent="0" marL="0">
+              <a:lnSpc>
+                <a:spcPct val="120000"/>
+              </a:lnSpc>
+              <a:buNone/>
+            </a:pPr>
+            <a:r>
+              <a:rPr lang="en-US" sz="1200" dirty="0">
+                <a:solidFill>
+                  <a:srgbClr val="5C6B68"/>
+                </a:solidFill>
+                <a:latin typeface="Yu Gothic" pitchFamily="34" charset="0"/>
+                <a:ea typeface="Yu Gothic" pitchFamily="34" charset="-122"/>
+                <a:cs typeface="Yu Gothic" pitchFamily="34" charset="-120"/>
+              </a:rPr>
+              <a:t>最初から共有されている</a:t>
+            </a:r>
+            <a:endParaRPr lang="en-US" sz="1200" dirty="0"/>
+          </a:p>
+        </p:txBody>
+      </p:sp>
+      <p:sp>
+        <p:nvSpPr>
+          <p:cNvPr id="19" name="Shape 17"/>
+          <p:cNvSpPr/>
+          <p:nvPr/>
+        </p:nvSpPr>
+        <p:spPr>
+          <a:xfrm>
+            <a:off x="8926830" y="1920240"/>
+            <a:ext cx="2503170" cy="1965960"/>
           </a:xfrm>
           <a:prstGeom prst="roundRect">
             <a:avLst>
-              <a:gd name="adj" fmla="val 4000"/>
+              <a:gd name="adj" fmla="val 3721"/>
             </a:avLst>
           </a:prstGeom>
           <a:solidFill>
@@ -19049,14 +18654,14 @@
       </p:sp>
       <p:sp>
         <p:nvSpPr>
-          <p:cNvPr id="19" name="Shape 17"/>
-          <p:cNvSpPr/>
-          <p:nvPr/>
-        </p:nvSpPr>
-        <p:spPr>
-          <a:xfrm>
-            <a:off x="8138160" y="2286000"/>
-            <a:ext cx="566928" cy="566928"/>
+          <p:cNvPr id="20" name="Shape 18"/>
+          <p:cNvSpPr/>
+          <p:nvPr/>
+        </p:nvSpPr>
+        <p:spPr>
+          <a:xfrm>
+            <a:off x="9146286" y="2121408"/>
+            <a:ext cx="402336" cy="402336"/>
           </a:xfrm>
           <a:prstGeom prst="ellipse">
             <a:avLst/>
@@ -19074,14 +18679,14 @@
       </p:sp>
       <p:sp>
         <p:nvSpPr>
-          <p:cNvPr id="20" name="Text 18"/>
-          <p:cNvSpPr/>
-          <p:nvPr/>
-        </p:nvSpPr>
-        <p:spPr>
-          <a:xfrm>
-            <a:off x="8138160" y="2286000"/>
-            <a:ext cx="566928" cy="566928"/>
+          <p:cNvPr id="21" name="Text 19"/>
+          <p:cNvSpPr/>
+          <p:nvPr/>
+        </p:nvSpPr>
+        <p:spPr>
+          <a:xfrm>
+            <a:off x="9146286" y="2121408"/>
+            <a:ext cx="402336" cy="402336"/>
           </a:xfrm>
           <a:prstGeom prst="rect">
             <a:avLst/>
@@ -19097,7 +18702,7 @@
               <a:buNone/>
             </a:pPr>
             <a:r>
-              <a:rPr lang="en-US" sz="2000" b="1" dirty="0">
+              <a:rPr lang="en-US" sz="1300" b="1" dirty="0">
                 <a:solidFill>
                   <a:srgbClr val="FFFFFF"/>
                 </a:solidFill>
@@ -19107,32 +18712,32 @@
               </a:rPr>
               <a:t>4</a:t>
             </a:r>
-            <a:endParaRPr lang="en-US" sz="2000" dirty="0"/>
-          </a:p>
-        </p:txBody>
-      </p:sp>
-      <p:sp>
-        <p:nvSpPr>
-          <p:cNvPr id="21" name="Text 19"/>
-          <p:cNvSpPr/>
-          <p:nvPr/>
-        </p:nvSpPr>
-        <p:spPr>
-          <a:xfrm>
-            <a:off x="7470648" y="3063240"/>
-            <a:ext cx="1883664" cy="685800"/>
-          </a:xfrm>
-          <a:prstGeom prst="rect">
-            <a:avLst/>
-          </a:prstGeom>
-          <a:noFill/>
-          <a:ln/>
-        </p:spPr>
-        <p:txBody>
-          <a:bodyPr wrap="square" lIns="0" tIns="0" rIns="0" bIns="0" rtlCol="0" anchor="ctr"/>
-          <a:lstStyle/>
-          <a:p>
-            <a:pPr algn="ctr" indent="0" marL="0">
+            <a:endParaRPr lang="en-US" sz="1300" dirty="0"/>
+          </a:p>
+        </p:txBody>
+      </p:sp>
+      <p:sp>
+        <p:nvSpPr>
+          <p:cNvPr id="22" name="Text 20"/>
+          <p:cNvSpPr/>
+          <p:nvPr/>
+        </p:nvSpPr>
+        <p:spPr>
+          <a:xfrm>
+            <a:off x="9127998" y="2615184"/>
+            <a:ext cx="2183130" cy="347472"/>
+          </a:xfrm>
+          <a:prstGeom prst="rect">
+            <a:avLst/>
+          </a:prstGeom>
+          <a:noFill/>
+          <a:ln/>
+        </p:spPr>
+        <p:txBody>
+          <a:bodyPr wrap="square" lIns="0" tIns="0" rIns="0" bIns="0" rtlCol="0" anchor="ctr"/>
+          <a:lstStyle/>
+          <a:p>
+            <a:pPr indent="0" marL="0">
               <a:buNone/>
             </a:pPr>
             <a:r>
@@ -19144,7 +18749,7 @@
                 <a:ea typeface="Yu Gothic" pitchFamily="34" charset="-122"/>
                 <a:cs typeface="Yu Gothic" pitchFamily="34" charset="-120"/>
               </a:rPr>
-              <a:t>入居者を登録</a:t>
+              <a:t>カレンダー</a:t>
             </a:r>
             <a:endParaRPr lang="en-US" sz="1500" dirty="0"/>
           </a:p>
@@ -19152,43 +18757,80 @@
       </p:sp>
       <p:sp>
         <p:nvSpPr>
-          <p:cNvPr id="22" name="Shape 20"/>
-          <p:cNvSpPr/>
-          <p:nvPr/>
-        </p:nvSpPr>
-        <p:spPr>
-          <a:xfrm>
-            <a:off x="9409176" y="2880360"/>
-            <a:ext cx="219456" cy="237744"/>
-          </a:xfrm>
-          <a:prstGeom prst="rightArrow">
-            <a:avLst/>
-          </a:prstGeom>
-          <a:solidFill>
-            <a:srgbClr val="A8CFC9"/>
-          </a:solidFill>
-          <a:ln w="12700">
-            <a:solidFill>
-              <a:srgbClr val="A8CFC9"/>
-            </a:solidFill>
-            <a:prstDash val="solid"/>
-          </a:ln>
-        </p:spPr>
-      </p:sp>
-      <p:sp>
-        <p:nvSpPr>
-          <p:cNvPr id="23" name="Shape 21"/>
-          <p:cNvSpPr/>
-          <p:nvPr/>
-        </p:nvSpPr>
-        <p:spPr>
-          <a:xfrm>
-            <a:off x="9692640" y="2057400"/>
-            <a:ext cx="1920240" cy="1828800"/>
+          <p:cNvPr id="23" name="Text 21"/>
+          <p:cNvSpPr/>
+          <p:nvPr/>
+        </p:nvSpPr>
+        <p:spPr>
+          <a:xfrm>
+            <a:off x="9127998" y="2999232"/>
+            <a:ext cx="2228850" cy="777240"/>
+          </a:xfrm>
+          <a:prstGeom prst="rect">
+            <a:avLst/>
+          </a:prstGeom>
+          <a:noFill/>
+          <a:ln/>
+        </p:spPr>
+        <p:txBody>
+          <a:bodyPr wrap="square" lIns="0" tIns="0" rIns="0" bIns="0" rtlCol="0" anchor="ctr"/>
+          <a:lstStyle/>
+          <a:p>
+            <a:pPr indent="0" marL="0">
+              <a:lnSpc>
+                <a:spcPct val="120000"/>
+              </a:lnSpc>
+              <a:buNone/>
+            </a:pPr>
+            <a:r>
+              <a:rPr lang="en-US" sz="1200" dirty="0">
+                <a:solidFill>
+                  <a:srgbClr val="5C6B68"/>
+                </a:solidFill>
+                <a:latin typeface="Yu Gothic" pitchFamily="34" charset="0"/>
+                <a:ea typeface="Yu Gothic" pitchFamily="34" charset="-122"/>
+                <a:cs typeface="Yu Gothic" pitchFamily="34" charset="-120"/>
+              </a:rPr>
+              <a:t>薬剤師の訪問予定を</a:t>
+            </a:r>
+            <a:endParaRPr lang="en-US" sz="1200" dirty="0"/>
+          </a:p>
+          <a:p>
+            <a:pPr indent="0" marL="0">
+              <a:lnSpc>
+                <a:spcPct val="120000"/>
+              </a:lnSpc>
+              <a:buNone/>
+            </a:pPr>
+            <a:r>
+              <a:rPr lang="en-US" sz="1200" dirty="0">
+                <a:solidFill>
+                  <a:srgbClr val="5C6B68"/>
+                </a:solidFill>
+                <a:latin typeface="Yu Gothic" pitchFamily="34" charset="0"/>
+                <a:ea typeface="Yu Gothic" pitchFamily="34" charset="-122"/>
+                <a:cs typeface="Yu Gothic" pitchFamily="34" charset="-120"/>
+              </a:rPr>
+              <a:t>施設側にも表示</a:t>
+            </a:r>
+            <a:endParaRPr lang="en-US" sz="1200" dirty="0"/>
+          </a:p>
+        </p:txBody>
+      </p:sp>
+      <p:sp>
+        <p:nvSpPr>
+          <p:cNvPr id="24" name="Shape 22"/>
+          <p:cNvSpPr/>
+          <p:nvPr/>
+        </p:nvSpPr>
+        <p:spPr>
+          <a:xfrm>
+            <a:off x="731520" y="4069080"/>
+            <a:ext cx="2503170" cy="1965960"/>
           </a:xfrm>
           <a:prstGeom prst="roundRect">
             <a:avLst>
-              <a:gd name="adj" fmla="val 4000"/>
+              <a:gd name="adj" fmla="val 3721"/>
             </a:avLst>
           </a:prstGeom>
           <a:solidFill>
@@ -19204,14 +18846,14 @@
       </p:sp>
       <p:sp>
         <p:nvSpPr>
-          <p:cNvPr id="24" name="Shape 22"/>
-          <p:cNvSpPr/>
-          <p:nvPr/>
-        </p:nvSpPr>
-        <p:spPr>
-          <a:xfrm>
-            <a:off x="10378440" y="2286000"/>
-            <a:ext cx="566928" cy="566928"/>
+          <p:cNvPr id="25" name="Shape 23"/>
+          <p:cNvSpPr/>
+          <p:nvPr/>
+        </p:nvSpPr>
+        <p:spPr>
+          <a:xfrm>
+            <a:off x="950976" y="4270248"/>
+            <a:ext cx="402336" cy="402336"/>
           </a:xfrm>
           <a:prstGeom prst="ellipse">
             <a:avLst/>
@@ -19229,14 +18871,14 @@
       </p:sp>
       <p:sp>
         <p:nvSpPr>
-          <p:cNvPr id="25" name="Text 23"/>
-          <p:cNvSpPr/>
-          <p:nvPr/>
-        </p:nvSpPr>
-        <p:spPr>
-          <a:xfrm>
-            <a:off x="10378440" y="2286000"/>
-            <a:ext cx="566928" cy="566928"/>
+          <p:cNvPr id="26" name="Text 24"/>
+          <p:cNvSpPr/>
+          <p:nvPr/>
+        </p:nvSpPr>
+        <p:spPr>
+          <a:xfrm>
+            <a:off x="950976" y="4270248"/>
+            <a:ext cx="402336" cy="402336"/>
           </a:xfrm>
           <a:prstGeom prst="rect">
             <a:avLst/>
@@ -19252,7 +18894,7 @@
               <a:buNone/>
             </a:pPr>
             <a:r>
-              <a:rPr lang="en-US" sz="2000" b="1" dirty="0">
+              <a:rPr lang="en-US" sz="1300" b="1" dirty="0">
                 <a:solidFill>
                   <a:srgbClr val="FFFFFF"/>
                 </a:solidFill>
@@ -19262,32 +18904,32 @@
               </a:rPr>
               <a:t>5</a:t>
             </a:r>
-            <a:endParaRPr lang="en-US" sz="2000" dirty="0"/>
-          </a:p>
-        </p:txBody>
-      </p:sp>
-      <p:sp>
-        <p:nvSpPr>
-          <p:cNvPr id="26" name="Text 24"/>
-          <p:cNvSpPr/>
-          <p:nvPr/>
-        </p:nvSpPr>
-        <p:spPr>
-          <a:xfrm>
-            <a:off x="9710928" y="3063240"/>
-            <a:ext cx="1883664" cy="685800"/>
-          </a:xfrm>
-          <a:prstGeom prst="rect">
-            <a:avLst/>
-          </a:prstGeom>
-          <a:noFill/>
-          <a:ln/>
-        </p:spPr>
-        <p:txBody>
-          <a:bodyPr wrap="square" lIns="0" tIns="0" rIns="0" bIns="0" rtlCol="0" anchor="ctr"/>
-          <a:lstStyle/>
-          <a:p>
-            <a:pPr algn="ctr" indent="0" marL="0">
+            <a:endParaRPr lang="en-US" sz="1300" dirty="0"/>
+          </a:p>
+        </p:txBody>
+      </p:sp>
+      <p:sp>
+        <p:nvSpPr>
+          <p:cNvPr id="27" name="Text 25"/>
+          <p:cNvSpPr/>
+          <p:nvPr/>
+        </p:nvSpPr>
+        <p:spPr>
+          <a:xfrm>
+            <a:off x="932688" y="4764024"/>
+            <a:ext cx="2183130" cy="347472"/>
+          </a:xfrm>
+          <a:prstGeom prst="rect">
+            <a:avLst/>
+          </a:prstGeom>
+          <a:noFill/>
+          <a:ln/>
+        </p:spPr>
+        <p:txBody>
+          <a:bodyPr wrap="square" lIns="0" tIns="0" rIns="0" bIns="0" rtlCol="0" anchor="ctr"/>
+          <a:lstStyle/>
+          <a:p>
+            <a:pPr indent="0" marL="0">
               <a:buNone/>
             </a:pPr>
             <a:r>
@@ -19299,7 +18941,7 @@
                 <a:ea typeface="Yu Gothic" pitchFamily="34" charset="-122"/>
                 <a:cs typeface="Yu Gothic" pitchFamily="34" charset="-120"/>
               </a:rPr>
-              <a:t>家族を招待</a:t>
+              <a:t>服薬の注意点</a:t>
             </a:r>
             <a:endParaRPr lang="en-US" sz="1500" dirty="0"/>
           </a:p>
@@ -19307,26 +18949,108 @@
       </p:sp>
       <p:sp>
         <p:nvSpPr>
-          <p:cNvPr id="27" name="Shape 25"/>
-          <p:cNvSpPr/>
-          <p:nvPr/>
-        </p:nvSpPr>
-        <p:spPr>
-          <a:xfrm>
-            <a:off x="731520" y="4343400"/>
-            <a:ext cx="10698480" cy="1645920"/>
+          <p:cNvPr id="28" name="Text 26"/>
+          <p:cNvSpPr/>
+          <p:nvPr/>
+        </p:nvSpPr>
+        <p:spPr>
+          <a:xfrm>
+            <a:off x="932688" y="5148072"/>
+            <a:ext cx="2228850" cy="777240"/>
+          </a:xfrm>
+          <a:prstGeom prst="rect">
+            <a:avLst/>
+          </a:prstGeom>
+          <a:noFill/>
+          <a:ln/>
+        </p:spPr>
+        <p:txBody>
+          <a:bodyPr wrap="square" lIns="0" tIns="0" rIns="0" bIns="0" rtlCol="0" anchor="ctr"/>
+          <a:lstStyle/>
+          <a:p>
+            <a:pPr indent="0" marL="0">
+              <a:lnSpc>
+                <a:spcPct val="120000"/>
+              </a:lnSpc>
+              <a:buNone/>
+            </a:pPr>
+            <a:r>
+              <a:rPr lang="en-US" sz="1200" dirty="0">
+                <a:solidFill>
+                  <a:srgbClr val="5C6B68"/>
+                </a:solidFill>
+                <a:latin typeface="Yu Gothic" pitchFamily="34" charset="0"/>
+                <a:ea typeface="Yu Gothic" pitchFamily="34" charset="-122"/>
+                <a:cs typeface="Yu Gothic" pitchFamily="34" charset="-120"/>
+              </a:rPr>
+              <a:t>添付文書から該当箇所だけ。</a:t>
+            </a:r>
+            <a:endParaRPr lang="en-US" sz="1200" dirty="0"/>
+          </a:p>
+          <a:p>
+            <a:pPr indent="0" marL="0">
+              <a:lnSpc>
+                <a:spcPct val="120000"/>
+              </a:lnSpc>
+              <a:buNone/>
+            </a:pPr>
+            <a:r>
+              <a:rPr lang="en-US" sz="1200" dirty="0">
+                <a:solidFill>
+                  <a:srgbClr val="5C6B68"/>
+                </a:solidFill>
+                <a:latin typeface="Yu Gothic" pitchFamily="34" charset="0"/>
+                <a:ea typeface="Yu Gothic" pitchFamily="34" charset="-122"/>
+                <a:cs typeface="Yu Gothic" pitchFamily="34" charset="-120"/>
+              </a:rPr>
+              <a:t>腎機能・肝機能・年齢に</a:t>
+            </a:r>
+            <a:endParaRPr lang="en-US" sz="1200" dirty="0"/>
+          </a:p>
+          <a:p>
+            <a:pPr indent="0" marL="0">
+              <a:lnSpc>
+                <a:spcPct val="120000"/>
+              </a:lnSpc>
+              <a:buNone/>
+            </a:pPr>
+            <a:r>
+              <a:rPr lang="en-US" sz="1200" dirty="0">
+                <a:solidFill>
+                  <a:srgbClr val="5C6B68"/>
+                </a:solidFill>
+                <a:latin typeface="Yu Gothic" pitchFamily="34" charset="0"/>
+                <a:ea typeface="Yu Gothic" pitchFamily="34" charset="-122"/>
+                <a:cs typeface="Yu Gothic" pitchFamily="34" charset="-120"/>
+              </a:rPr>
+              <a:t>合わせて出し分ける</a:t>
+            </a:r>
+            <a:endParaRPr lang="en-US" sz="1200" dirty="0"/>
+          </a:p>
+        </p:txBody>
+      </p:sp>
+      <p:sp>
+        <p:nvSpPr>
+          <p:cNvPr id="29" name="Shape 27"/>
+          <p:cNvSpPr/>
+          <p:nvPr/>
+        </p:nvSpPr>
+        <p:spPr>
+          <a:xfrm>
+            <a:off x="3463290" y="4069080"/>
+            <a:ext cx="2503170" cy="1965960"/>
           </a:xfrm>
           <a:prstGeom prst="roundRect">
             <a:avLst>
-              <a:gd name="adj" fmla="val 4444"/>
+              <a:gd name="adj" fmla="val 3721"/>
             </a:avLst>
           </a:prstGeom>
           <a:solidFill>
-            <a:srgbClr val="FFFFFF"/>
+            <a:srgbClr val="F1F6F5"/>
           </a:solidFill>
           <a:ln w="12700">
             <a:solidFill>
-              <a:srgbClr val="DCE6E4"/>
+              <a:srgbClr val="F1F6F5"/>
             </a:solidFill>
             <a:prstDash val="solid"/>
           </a:ln>
@@ -19334,30 +19058,94 @@
       </p:sp>
       <p:sp>
         <p:nvSpPr>
-          <p:cNvPr id="28" name="Text 26"/>
-          <p:cNvSpPr/>
-          <p:nvPr/>
-        </p:nvSpPr>
-        <p:spPr>
-          <a:xfrm>
-            <a:off x="1051560" y="4553712"/>
-            <a:ext cx="5486400" cy="365760"/>
-          </a:xfrm>
-          <a:prstGeom prst="rect">
-            <a:avLst/>
-          </a:prstGeom>
-          <a:noFill/>
-          <a:ln/>
-        </p:spPr>
-        <p:txBody>
-          <a:bodyPr wrap="square" lIns="0" tIns="0" rIns="0" bIns="0" rtlCol="0" anchor="ctr"/>
-          <a:lstStyle/>
-          <a:p>
-            <a:pPr indent="0" marL="0">
-              <a:buNone/>
-            </a:pPr>
-            <a:r>
-              <a:rPr lang="en-US" sz="1900" b="1" dirty="0">
+          <p:cNvPr id="30" name="Shape 28"/>
+          <p:cNvSpPr/>
+          <p:nvPr/>
+        </p:nvSpPr>
+        <p:spPr>
+          <a:xfrm>
+            <a:off x="3682746" y="4270248"/>
+            <a:ext cx="402336" cy="402336"/>
+          </a:xfrm>
+          <a:prstGeom prst="ellipse">
+            <a:avLst/>
+          </a:prstGeom>
+          <a:solidFill>
+            <a:srgbClr val="D98A2B"/>
+          </a:solidFill>
+          <a:ln w="12700">
+            <a:solidFill>
+              <a:srgbClr val="D98A2B"/>
+            </a:solidFill>
+            <a:prstDash val="solid"/>
+          </a:ln>
+        </p:spPr>
+      </p:sp>
+      <p:sp>
+        <p:nvSpPr>
+          <p:cNvPr id="31" name="Text 29"/>
+          <p:cNvSpPr/>
+          <p:nvPr/>
+        </p:nvSpPr>
+        <p:spPr>
+          <a:xfrm>
+            <a:off x="3682746" y="4270248"/>
+            <a:ext cx="402336" cy="402336"/>
+          </a:xfrm>
+          <a:prstGeom prst="rect">
+            <a:avLst/>
+          </a:prstGeom>
+          <a:noFill/>
+          <a:ln/>
+        </p:spPr>
+        <p:txBody>
+          <a:bodyPr wrap="square" lIns="0" tIns="0" rIns="0" bIns="0" rtlCol="0" anchor="ctr"/>
+          <a:lstStyle/>
+          <a:p>
+            <a:pPr algn="ctr" indent="0" marL="0">
+              <a:buNone/>
+            </a:pPr>
+            <a:r>
+              <a:rPr lang="en-US" sz="1300" b="1" dirty="0">
+                <a:solidFill>
+                  <a:srgbClr val="FFFFFF"/>
+                </a:solidFill>
+                <a:latin typeface="Yu Gothic" pitchFamily="34" charset="0"/>
+                <a:ea typeface="Yu Gothic" pitchFamily="34" charset="-122"/>
+                <a:cs typeface="Yu Gothic" pitchFamily="34" charset="-120"/>
+              </a:rPr>
+              <a:t>6</a:t>
+            </a:r>
+            <a:endParaRPr lang="en-US" sz="1300" dirty="0"/>
+          </a:p>
+        </p:txBody>
+      </p:sp>
+      <p:sp>
+        <p:nvSpPr>
+          <p:cNvPr id="32" name="Text 30"/>
+          <p:cNvSpPr/>
+          <p:nvPr/>
+        </p:nvSpPr>
+        <p:spPr>
+          <a:xfrm>
+            <a:off x="3664458" y="4764024"/>
+            <a:ext cx="2183130" cy="347472"/>
+          </a:xfrm>
+          <a:prstGeom prst="rect">
+            <a:avLst/>
+          </a:prstGeom>
+          <a:noFill/>
+          <a:ln/>
+        </p:spPr>
+        <p:txBody>
+          <a:bodyPr wrap="square" lIns="0" tIns="0" rIns="0" bIns="0" rtlCol="0" anchor="ctr"/>
+          <a:lstStyle/>
+          <a:p>
+            <a:pPr indent="0" marL="0">
+              <a:buNone/>
+            </a:pPr>
+            <a:r>
+              <a:rPr lang="en-US" sz="1500" b="1" dirty="0">
                 <a:solidFill>
                   <a:srgbClr val="14504B"/>
                 </a:solidFill>
@@ -19365,22 +19153,175 @@
                 <a:ea typeface="Yu Gothic" pitchFamily="34" charset="-122"/>
                 <a:cs typeface="Yu Gothic" pitchFamily="34" charset="-120"/>
               </a:rPr>
-              <a:t>役割ごとに、見えるものが違う</a:t>
-            </a:r>
-            <a:endParaRPr lang="en-US" sz="1900" dirty="0"/>
-          </a:p>
-        </p:txBody>
-      </p:sp>
-      <p:sp>
-        <p:nvSpPr>
-          <p:cNvPr id="29" name="Text 27"/>
-          <p:cNvSpPr/>
-          <p:nvPr/>
-        </p:nvSpPr>
-        <p:spPr>
-          <a:xfrm>
-            <a:off x="1051560" y="5029200"/>
-            <a:ext cx="3291840" cy="320040"/>
+              <a:t>症状トリアージ</a:t>
+            </a:r>
+            <a:endParaRPr lang="en-US" sz="1500" dirty="0"/>
+          </a:p>
+        </p:txBody>
+      </p:sp>
+      <p:sp>
+        <p:nvSpPr>
+          <p:cNvPr id="33" name="Text 31"/>
+          <p:cNvSpPr/>
+          <p:nvPr/>
+        </p:nvSpPr>
+        <p:spPr>
+          <a:xfrm>
+            <a:off x="3664458" y="5148072"/>
+            <a:ext cx="2228850" cy="777240"/>
+          </a:xfrm>
+          <a:prstGeom prst="rect">
+            <a:avLst/>
+          </a:prstGeom>
+          <a:noFill/>
+          <a:ln/>
+        </p:spPr>
+        <p:txBody>
+          <a:bodyPr wrap="square" lIns="0" tIns="0" rIns="0" bIns="0" rtlCol="0" anchor="ctr"/>
+          <a:lstStyle/>
+          <a:p>
+            <a:pPr indent="0" marL="0">
+              <a:lnSpc>
+                <a:spcPct val="120000"/>
+              </a:lnSpc>
+              <a:buNone/>
+            </a:pPr>
+            <a:r>
+              <a:rPr lang="en-US" sz="1200" dirty="0">
+                <a:solidFill>
+                  <a:srgbClr val="5C6B68"/>
+                </a:solidFill>
+                <a:latin typeface="Yu Gothic" pitchFamily="34" charset="0"/>
+                <a:ea typeface="Yu Gothic" pitchFamily="34" charset="-122"/>
+                <a:cs typeface="Yu Gothic" pitchFamily="34" charset="-120"/>
+              </a:rPr>
+              <a:t>体調不良時の対応の目安を</a:t>
+            </a:r>
+            <a:endParaRPr lang="en-US" sz="1200" dirty="0"/>
+          </a:p>
+          <a:p>
+            <a:pPr indent="0" marL="0">
+              <a:lnSpc>
+                <a:spcPct val="120000"/>
+              </a:lnSpc>
+              <a:buNone/>
+            </a:pPr>
+            <a:r>
+              <a:rPr lang="en-US" sz="1200" dirty="0">
+                <a:solidFill>
+                  <a:srgbClr val="5C6B68"/>
+                </a:solidFill>
+                <a:latin typeface="Yu Gothic" pitchFamily="34" charset="0"/>
+                <a:ea typeface="Yu Gothic" pitchFamily="34" charset="-122"/>
+                <a:cs typeface="Yu Gothic" pitchFamily="34" charset="-120"/>
+              </a:rPr>
+              <a:t>3段階で提示</a:t>
+            </a:r>
+            <a:endParaRPr lang="en-US" sz="1200" dirty="0"/>
+          </a:p>
+        </p:txBody>
+      </p:sp>
+      <p:sp>
+        <p:nvSpPr>
+          <p:cNvPr id="34" name="Shape 32"/>
+          <p:cNvSpPr/>
+          <p:nvPr/>
+        </p:nvSpPr>
+        <p:spPr>
+          <a:xfrm>
+            <a:off x="6195060" y="4069080"/>
+            <a:ext cx="2503170" cy="1965960"/>
+          </a:xfrm>
+          <a:prstGeom prst="roundRect">
+            <a:avLst>
+              <a:gd name="adj" fmla="val 3721"/>
+            </a:avLst>
+          </a:prstGeom>
+          <a:solidFill>
+            <a:srgbClr val="F1F6F5"/>
+          </a:solidFill>
+          <a:ln w="12700">
+            <a:solidFill>
+              <a:srgbClr val="F1F6F5"/>
+            </a:solidFill>
+            <a:prstDash val="solid"/>
+          </a:ln>
+        </p:spPr>
+      </p:sp>
+      <p:sp>
+        <p:nvSpPr>
+          <p:cNvPr id="35" name="Shape 33"/>
+          <p:cNvSpPr/>
+          <p:nvPr/>
+        </p:nvSpPr>
+        <p:spPr>
+          <a:xfrm>
+            <a:off x="6414516" y="4270248"/>
+            <a:ext cx="402336" cy="402336"/>
+          </a:xfrm>
+          <a:prstGeom prst="ellipse">
+            <a:avLst/>
+          </a:prstGeom>
+          <a:solidFill>
+            <a:srgbClr val="3E8E84"/>
+          </a:solidFill>
+          <a:ln w="12700">
+            <a:solidFill>
+              <a:srgbClr val="3E8E84"/>
+            </a:solidFill>
+            <a:prstDash val="solid"/>
+          </a:ln>
+        </p:spPr>
+      </p:sp>
+      <p:sp>
+        <p:nvSpPr>
+          <p:cNvPr id="36" name="Text 34"/>
+          <p:cNvSpPr/>
+          <p:nvPr/>
+        </p:nvSpPr>
+        <p:spPr>
+          <a:xfrm>
+            <a:off x="6414516" y="4270248"/>
+            <a:ext cx="402336" cy="402336"/>
+          </a:xfrm>
+          <a:prstGeom prst="rect">
+            <a:avLst/>
+          </a:prstGeom>
+          <a:noFill/>
+          <a:ln/>
+        </p:spPr>
+        <p:txBody>
+          <a:bodyPr wrap="square" lIns="0" tIns="0" rIns="0" bIns="0" rtlCol="0" anchor="ctr"/>
+          <a:lstStyle/>
+          <a:p>
+            <a:pPr algn="ctr" indent="0" marL="0">
+              <a:buNone/>
+            </a:pPr>
+            <a:r>
+              <a:rPr lang="en-US" sz="1300" b="1" dirty="0">
+                <a:solidFill>
+                  <a:srgbClr val="FFFFFF"/>
+                </a:solidFill>
+                <a:latin typeface="Yu Gothic" pitchFamily="34" charset="0"/>
+                <a:ea typeface="Yu Gothic" pitchFamily="34" charset="-122"/>
+                <a:cs typeface="Yu Gothic" pitchFamily="34" charset="-120"/>
+              </a:rPr>
+              <a:t>7</a:t>
+            </a:r>
+            <a:endParaRPr lang="en-US" sz="1300" dirty="0"/>
+          </a:p>
+        </p:txBody>
+      </p:sp>
+      <p:sp>
+        <p:nvSpPr>
+          <p:cNvPr id="37" name="Text 35"/>
+          <p:cNvSpPr/>
+          <p:nvPr/>
+        </p:nvSpPr>
+        <p:spPr>
+          <a:xfrm>
+            <a:off x="6396228" y="4764024"/>
+            <a:ext cx="2183130" cy="347472"/>
           </a:xfrm>
           <a:prstGeom prst="rect">
             <a:avLst/>
@@ -19398,13 +19339,13 @@
             <a:r>
               <a:rPr lang="en-US" sz="1500" b="1" dirty="0">
                 <a:solidFill>
-                  <a:srgbClr val="3E8E84"/>
-                </a:solidFill>
-                <a:latin typeface="Yu Gothic" pitchFamily="34" charset="0"/>
-                <a:ea typeface="Yu Gothic" pitchFamily="34" charset="-122"/>
-                <a:cs typeface="Yu Gothic" pitchFamily="34" charset="-120"/>
-              </a:rPr>
-              <a:t>薬剤師</a:t>
+                  <a:srgbClr val="14504B"/>
+                </a:solidFill>
+                <a:latin typeface="Yu Gothic" pitchFamily="34" charset="0"/>
+                <a:ea typeface="Yu Gothic" pitchFamily="34" charset="-122"/>
+                <a:cs typeface="Yu Gothic" pitchFamily="34" charset="-120"/>
+              </a:rPr>
+              <a:t>家族への共有</a:t>
             </a:r>
             <a:endParaRPr lang="en-US" sz="1500" dirty="0"/>
           </a:p>
@@ -19412,14 +19353,307 @@
       </p:sp>
       <p:sp>
         <p:nvSpPr>
-          <p:cNvPr id="30" name="Text 28"/>
-          <p:cNvSpPr/>
-          <p:nvPr/>
-        </p:nvSpPr>
-        <p:spPr>
-          <a:xfrm>
-            <a:off x="1051560" y="5394960"/>
-            <a:ext cx="3337560" cy="411480"/>
+          <p:cNvPr id="38" name="Text 36"/>
+          <p:cNvSpPr/>
+          <p:nvPr/>
+        </p:nvSpPr>
+        <p:spPr>
+          <a:xfrm>
+            <a:off x="6396228" y="5148072"/>
+            <a:ext cx="2228850" cy="777240"/>
+          </a:xfrm>
+          <a:prstGeom prst="rect">
+            <a:avLst/>
+          </a:prstGeom>
+          <a:noFill/>
+          <a:ln/>
+        </p:spPr>
+        <p:txBody>
+          <a:bodyPr wrap="square" lIns="0" tIns="0" rIns="0" bIns="0" rtlCol="0" anchor="ctr"/>
+          <a:lstStyle/>
+          <a:p>
+            <a:pPr indent="0" marL="0">
+              <a:lnSpc>
+                <a:spcPct val="120000"/>
+              </a:lnSpc>
+              <a:buNone/>
+            </a:pPr>
+            <a:r>
+              <a:rPr lang="en-US" sz="1200" dirty="0">
+                <a:solidFill>
+                  <a:srgbClr val="5C6B68"/>
+                </a:solidFill>
+                <a:latin typeface="Yu Gothic" pitchFamily="34" charset="0"/>
+                <a:ea typeface="Yu Gothic" pitchFamily="34" charset="-122"/>
+                <a:cs typeface="Yu Gothic" pitchFamily="34" charset="-120"/>
+              </a:rPr>
+              <a:t>処方とバイタルを</a:t>
+            </a:r>
+            <a:endParaRPr lang="en-US" sz="1200" dirty="0"/>
+          </a:p>
+          <a:p>
+            <a:pPr indent="0" marL="0">
+              <a:lnSpc>
+                <a:spcPct val="120000"/>
+              </a:lnSpc>
+              <a:buNone/>
+            </a:pPr>
+            <a:r>
+              <a:rPr lang="en-US" sz="1200" dirty="0">
+                <a:solidFill>
+                  <a:srgbClr val="5C6B68"/>
+                </a:solidFill>
+                <a:latin typeface="Yu Gothic" pitchFamily="34" charset="0"/>
+                <a:ea typeface="Yu Gothic" pitchFamily="34" charset="-122"/>
+                <a:cs typeface="Yu Gothic" pitchFamily="34" charset="-120"/>
+              </a:rPr>
+              <a:t>ご家族が閲覧できる</a:t>
+            </a:r>
+            <a:endParaRPr lang="en-US" sz="1200" dirty="0"/>
+          </a:p>
+        </p:txBody>
+      </p:sp>
+      <p:sp>
+        <p:nvSpPr>
+          <p:cNvPr id="39" name="Shape 37"/>
+          <p:cNvSpPr/>
+          <p:nvPr/>
+        </p:nvSpPr>
+        <p:spPr>
+          <a:xfrm>
+            <a:off x="8926830" y="4069080"/>
+            <a:ext cx="2503170" cy="1965960"/>
+          </a:xfrm>
+          <a:prstGeom prst="roundRect">
+            <a:avLst>
+              <a:gd name="adj" fmla="val 3721"/>
+            </a:avLst>
+          </a:prstGeom>
+          <a:solidFill>
+            <a:srgbClr val="F1F6F5"/>
+          </a:solidFill>
+          <a:ln w="12700">
+            <a:solidFill>
+              <a:srgbClr val="F1F6F5"/>
+            </a:solidFill>
+            <a:prstDash val="solid"/>
+          </a:ln>
+        </p:spPr>
+      </p:sp>
+      <p:sp>
+        <p:nvSpPr>
+          <p:cNvPr id="40" name="Shape 38"/>
+          <p:cNvSpPr/>
+          <p:nvPr/>
+        </p:nvSpPr>
+        <p:spPr>
+          <a:xfrm>
+            <a:off x="9146286" y="4270248"/>
+            <a:ext cx="402336" cy="402336"/>
+          </a:xfrm>
+          <a:prstGeom prst="ellipse">
+            <a:avLst/>
+          </a:prstGeom>
+          <a:solidFill>
+            <a:srgbClr val="3E8E84"/>
+          </a:solidFill>
+          <a:ln w="12700">
+            <a:solidFill>
+              <a:srgbClr val="3E8E84"/>
+            </a:solidFill>
+            <a:prstDash val="solid"/>
+          </a:ln>
+        </p:spPr>
+      </p:sp>
+      <p:sp>
+        <p:nvSpPr>
+          <p:cNvPr id="41" name="Text 39"/>
+          <p:cNvSpPr/>
+          <p:nvPr/>
+        </p:nvSpPr>
+        <p:spPr>
+          <a:xfrm>
+            <a:off x="9146286" y="4270248"/>
+            <a:ext cx="402336" cy="402336"/>
+          </a:xfrm>
+          <a:prstGeom prst="rect">
+            <a:avLst/>
+          </a:prstGeom>
+          <a:noFill/>
+          <a:ln/>
+        </p:spPr>
+        <p:txBody>
+          <a:bodyPr wrap="square" lIns="0" tIns="0" rIns="0" bIns="0" rtlCol="0" anchor="ctr"/>
+          <a:lstStyle/>
+          <a:p>
+            <a:pPr algn="ctr" indent="0" marL="0">
+              <a:buNone/>
+            </a:pPr>
+            <a:r>
+              <a:rPr lang="en-US" sz="1300" b="1" dirty="0">
+                <a:solidFill>
+                  <a:srgbClr val="FFFFFF"/>
+                </a:solidFill>
+                <a:latin typeface="Yu Gothic" pitchFamily="34" charset="0"/>
+                <a:ea typeface="Yu Gothic" pitchFamily="34" charset="-122"/>
+                <a:cs typeface="Yu Gothic" pitchFamily="34" charset="-120"/>
+              </a:rPr>
+              <a:t>8</a:t>
+            </a:r>
+            <a:endParaRPr lang="en-US" sz="1300" dirty="0"/>
+          </a:p>
+        </p:txBody>
+      </p:sp>
+      <p:sp>
+        <p:nvSpPr>
+          <p:cNvPr id="42" name="Text 40"/>
+          <p:cNvSpPr/>
+          <p:nvPr/>
+        </p:nvSpPr>
+        <p:spPr>
+          <a:xfrm>
+            <a:off x="9127998" y="4764024"/>
+            <a:ext cx="2183130" cy="347472"/>
+          </a:xfrm>
+          <a:prstGeom prst="rect">
+            <a:avLst/>
+          </a:prstGeom>
+          <a:noFill/>
+          <a:ln/>
+        </p:spPr>
+        <p:txBody>
+          <a:bodyPr wrap="square" lIns="0" tIns="0" rIns="0" bIns="0" rtlCol="0" anchor="ctr"/>
+          <a:lstStyle/>
+          <a:p>
+            <a:pPr indent="0" marL="0">
+              <a:buNone/>
+            </a:pPr>
+            <a:r>
+              <a:rPr lang="en-US" sz="1500" b="1" dirty="0">
+                <a:solidFill>
+                  <a:srgbClr val="14504B"/>
+                </a:solidFill>
+                <a:latin typeface="Yu Gothic" pitchFamily="34" charset="0"/>
+                <a:ea typeface="Yu Gothic" pitchFamily="34" charset="-122"/>
+                <a:cs typeface="Yu Gothic" pitchFamily="34" charset="-120"/>
+              </a:rPr>
+              <a:t>記録の書面出力</a:t>
+            </a:r>
+            <a:endParaRPr lang="en-US" sz="1500" dirty="0"/>
+          </a:p>
+        </p:txBody>
+      </p:sp>
+      <p:sp>
+        <p:nvSpPr>
+          <p:cNvPr id="43" name="Text 41"/>
+          <p:cNvSpPr/>
+          <p:nvPr/>
+        </p:nvSpPr>
+        <p:spPr>
+          <a:xfrm>
+            <a:off x="9127998" y="5148072"/>
+            <a:ext cx="2228850" cy="777240"/>
+          </a:xfrm>
+          <a:prstGeom prst="rect">
+            <a:avLst/>
+          </a:prstGeom>
+          <a:noFill/>
+          <a:ln/>
+        </p:spPr>
+        <p:txBody>
+          <a:bodyPr wrap="square" lIns="0" tIns="0" rIns="0" bIns="0" rtlCol="0" anchor="ctr"/>
+          <a:lstStyle/>
+          <a:p>
+            <a:pPr indent="0" marL="0">
+              <a:lnSpc>
+                <a:spcPct val="120000"/>
+              </a:lnSpc>
+              <a:buNone/>
+            </a:pPr>
+            <a:r>
+              <a:rPr lang="en-US" sz="1200" dirty="0">
+                <a:solidFill>
+                  <a:srgbClr val="5C6B68"/>
+                </a:solidFill>
+                <a:latin typeface="Yu Gothic" pitchFamily="34" charset="0"/>
+                <a:ea typeface="Yu Gothic" pitchFamily="34" charset="-122"/>
+                <a:cs typeface="Yu Gothic" pitchFamily="34" charset="-120"/>
+              </a:rPr>
+              <a:t>保管中の記録を</a:t>
+            </a:r>
+            <a:endParaRPr lang="en-US" sz="1200" dirty="0"/>
+          </a:p>
+          <a:p>
+            <a:pPr indent="0" marL="0">
+              <a:lnSpc>
+                <a:spcPct val="120000"/>
+              </a:lnSpc>
+              <a:buNone/>
+            </a:pPr>
+            <a:r>
+              <a:rPr lang="en-US" sz="1200" dirty="0">
+                <a:solidFill>
+                  <a:srgbClr val="5C6B68"/>
+                </a:solidFill>
+                <a:latin typeface="Yu Gothic" pitchFamily="34" charset="0"/>
+                <a:ea typeface="Yu Gothic" pitchFamily="34" charset="-122"/>
+                <a:cs typeface="Yu Gothic" pitchFamily="34" charset="-120"/>
+              </a:rPr>
+              <a:t>そのまま印刷できる</a:t>
+            </a:r>
+            <a:endParaRPr lang="en-US" sz="1200" dirty="0"/>
+          </a:p>
+        </p:txBody>
+      </p:sp>
+      <p:sp>
+        <p:nvSpPr>
+          <p:cNvPr id="44" name="Text 42"/>
+          <p:cNvSpPr/>
+          <p:nvPr/>
+        </p:nvSpPr>
+        <p:spPr>
+          <a:xfrm>
+            <a:off x="731520" y="6108192"/>
+            <a:ext cx="5486400" cy="292608"/>
+          </a:xfrm>
+          <a:prstGeom prst="rect">
+            <a:avLst/>
+          </a:prstGeom>
+          <a:noFill/>
+          <a:ln/>
+        </p:spPr>
+        <p:txBody>
+          <a:bodyPr wrap="square" lIns="0" tIns="0" rIns="0" bIns="0" rtlCol="0" anchor="ctr"/>
+          <a:lstStyle/>
+          <a:p>
+            <a:pPr indent="0" marL="0">
+              <a:buNone/>
+            </a:pPr>
+            <a:r>
+              <a:rPr lang="en-US" sz="1300" b="1" dirty="0">
+                <a:solidFill>
+                  <a:srgbClr val="D98A2B"/>
+                </a:solidFill>
+                <a:latin typeface="Yu Gothic" pitchFamily="34" charset="0"/>
+                <a:ea typeface="Yu Gothic" pitchFamily="34" charset="-122"/>
+                <a:cs typeface="Yu Gothic" pitchFamily="34" charset="-120"/>
+              </a:rPr>
+              <a:t>⑤⑥はAIを使う機能</a:t>
+            </a:r>
+            <a:endParaRPr lang="en-US" sz="1300" dirty="0"/>
+          </a:p>
+        </p:txBody>
+      </p:sp>
+      <p:sp>
+        <p:nvSpPr>
+          <p:cNvPr id="45" name="Text 43"/>
+          <p:cNvSpPr/>
+          <p:nvPr/>
+        </p:nvSpPr>
+        <p:spPr>
+          <a:xfrm>
+            <a:off x="731520" y="6400800"/>
+            <a:ext cx="10698480" cy="320040"/>
           </a:xfrm>
           <a:prstGeom prst="rect">
             <a:avLst/>
@@ -19437,169 +19671,13 @@
             <a:r>
               <a:rPr lang="en-US" sz="1300" dirty="0">
                 <a:solidFill>
-                  <a:srgbClr val="5C6B68"/>
-                </a:solidFill>
-                <a:latin typeface="Yu Gothic" pitchFamily="34" charset="0"/>
-                <a:ea typeface="Yu Gothic" pitchFamily="34" charset="-122"/>
-                <a:cs typeface="Yu Gothic" pitchFamily="34" charset="-120"/>
-              </a:rPr>
-              <a:t>薬の登録・変更、相談対応</a:t>
-            </a:r>
-            <a:endParaRPr lang="en-US" sz="1300" dirty="0"/>
-          </a:p>
-        </p:txBody>
-      </p:sp>
-      <p:sp>
-        <p:nvSpPr>
-          <p:cNvPr id="31" name="Text 29"/>
-          <p:cNvSpPr/>
-          <p:nvPr/>
-        </p:nvSpPr>
-        <p:spPr>
-          <a:xfrm>
-            <a:off x="4526280" y="5029200"/>
-            <a:ext cx="3291840" cy="320040"/>
-          </a:xfrm>
-          <a:prstGeom prst="rect">
-            <a:avLst/>
-          </a:prstGeom>
-          <a:noFill/>
-          <a:ln/>
-        </p:spPr>
-        <p:txBody>
-          <a:bodyPr wrap="square" lIns="0" tIns="0" rIns="0" bIns="0" rtlCol="0" anchor="ctr"/>
-          <a:lstStyle/>
-          <a:p>
-            <a:pPr indent="0" marL="0">
-              <a:buNone/>
-            </a:pPr>
-            <a:r>
-              <a:rPr lang="en-US" sz="1500" b="1" dirty="0">
-                <a:solidFill>
-                  <a:srgbClr val="3E8E84"/>
-                </a:solidFill>
-                <a:latin typeface="Yu Gothic" pitchFamily="34" charset="0"/>
-                <a:ea typeface="Yu Gothic" pitchFamily="34" charset="-122"/>
-                <a:cs typeface="Yu Gothic" pitchFamily="34" charset="-120"/>
-              </a:rPr>
-              <a:t>介護士・看護師</a:t>
-            </a:r>
-            <a:endParaRPr lang="en-US" sz="1500" dirty="0"/>
-          </a:p>
-        </p:txBody>
-      </p:sp>
-      <p:sp>
-        <p:nvSpPr>
-          <p:cNvPr id="32" name="Text 30"/>
-          <p:cNvSpPr/>
-          <p:nvPr/>
-        </p:nvSpPr>
-        <p:spPr>
-          <a:xfrm>
-            <a:off x="4526280" y="5394960"/>
-            <a:ext cx="3337560" cy="411480"/>
-          </a:xfrm>
-          <a:prstGeom prst="rect">
-            <a:avLst/>
-          </a:prstGeom>
-          <a:noFill/>
-          <a:ln/>
-        </p:spPr>
-        <p:txBody>
-          <a:bodyPr wrap="square" lIns="0" tIns="0" rIns="0" bIns="0" rtlCol="0" anchor="ctr"/>
-          <a:lstStyle/>
-          <a:p>
-            <a:pPr indent="0" marL="0">
-              <a:buNone/>
-            </a:pPr>
-            <a:r>
-              <a:rPr lang="en-US" sz="1300" dirty="0">
-                <a:solidFill>
-                  <a:srgbClr val="5C6B68"/>
-                </a:solidFill>
-                <a:latin typeface="Yu Gothic" pitchFamily="34" charset="0"/>
-                <a:ea typeface="Yu Gothic" pitchFamily="34" charset="-122"/>
-                <a:cs typeface="Yu Gothic" pitchFamily="34" charset="-120"/>
-              </a:rPr>
-              <a:t>服薬記録、バイタル、症状相談</a:t>
-            </a:r>
-            <a:endParaRPr lang="en-US" sz="1300" dirty="0"/>
-          </a:p>
-        </p:txBody>
-      </p:sp>
-      <p:sp>
-        <p:nvSpPr>
-          <p:cNvPr id="33" name="Text 31"/>
-          <p:cNvSpPr/>
-          <p:nvPr/>
-        </p:nvSpPr>
-        <p:spPr>
-          <a:xfrm>
-            <a:off x="8001000" y="5029200"/>
-            <a:ext cx="3291840" cy="320040"/>
-          </a:xfrm>
-          <a:prstGeom prst="rect">
-            <a:avLst/>
-          </a:prstGeom>
-          <a:noFill/>
-          <a:ln/>
-        </p:spPr>
-        <p:txBody>
-          <a:bodyPr wrap="square" lIns="0" tIns="0" rIns="0" bIns="0" rtlCol="0" anchor="ctr"/>
-          <a:lstStyle/>
-          <a:p>
-            <a:pPr indent="0" marL="0">
-              <a:buNone/>
-            </a:pPr>
-            <a:r>
-              <a:rPr lang="en-US" sz="1500" b="1" dirty="0">
-                <a:solidFill>
-                  <a:srgbClr val="3E8E84"/>
-                </a:solidFill>
-                <a:latin typeface="Yu Gothic" pitchFamily="34" charset="0"/>
-                <a:ea typeface="Yu Gothic" pitchFamily="34" charset="-122"/>
-                <a:cs typeface="Yu Gothic" pitchFamily="34" charset="-120"/>
-              </a:rPr>
-              <a:t>家族</a:t>
-            </a:r>
-            <a:endParaRPr lang="en-US" sz="1500" dirty="0"/>
-          </a:p>
-        </p:txBody>
-      </p:sp>
-      <p:sp>
-        <p:nvSpPr>
-          <p:cNvPr id="34" name="Text 32"/>
-          <p:cNvSpPr/>
-          <p:nvPr/>
-        </p:nvSpPr>
-        <p:spPr>
-          <a:xfrm>
-            <a:off x="8001000" y="5394960"/>
-            <a:ext cx="3337560" cy="411480"/>
-          </a:xfrm>
-          <a:prstGeom prst="rect">
-            <a:avLst/>
-          </a:prstGeom>
-          <a:noFill/>
-          <a:ln/>
-        </p:spPr>
-        <p:txBody>
-          <a:bodyPr wrap="square" lIns="0" tIns="0" rIns="0" bIns="0" rtlCol="0" anchor="ctr"/>
-          <a:lstStyle/>
-          <a:p>
-            <a:pPr indent="0" marL="0">
-              <a:buNone/>
-            </a:pPr>
-            <a:r>
-              <a:rPr lang="en-US" sz="1300" dirty="0">
-                <a:solidFill>
-                  <a:srgbClr val="5C6B68"/>
-                </a:solidFill>
-                <a:latin typeface="Yu Gothic" pitchFamily="34" charset="0"/>
-                <a:ea typeface="Yu Gothic" pitchFamily="34" charset="-122"/>
-                <a:cs typeface="Yu Gothic" pitchFamily="34" charset="-120"/>
-              </a:rPr>
-              <a:t>処方とバイタルの閲覧のみ</a:t>
+                  <a:srgbClr val="16211F"/>
+                </a:solidFill>
+                <a:latin typeface="Yu Gothic" pitchFamily="34" charset="0"/>
+                <a:ea typeface="Yu Gothic" pitchFamily="34" charset="-122"/>
+                <a:cs typeface="Yu Gothic" pitchFamily="34" charset="-120"/>
+              </a:rPr>
+              <a:t>②と⑤がつながっているのがこのアプリの要。「血圧が下がってきたので降圧薬を見直しては」という相談が、数字を見ながらできます。</a:t>
             </a:r>
             <a:endParaRPr lang="en-US" sz="1300" dirty="0"/>
           </a:p>

</xml_diff>

<commit_message>
deck: take the two lines cut by hand into the generator
Both were removed in PowerPoint and would have come back on the next build.
Diffed the saved file against a fresh generation to find them rather than
guess.

The guideline opener lost its middle line, which described the deck's own
layout — how many tables and explainers follow. That is writing about the
document instead of the subject, and the band is better as the claim plus
the admission that the gaps are listed later. Closed the hole it left: the
band was sized for three lines and had been showing a gap between the
heading and the amber line.

The AI slide lost its closing note about the app still returning a verdict
when the model is unavailable. Nothing needed re-homing — the right-hand
card already says deciding the triage level is not the model's job, which
is the part that matters. Removed the now-empty footer position.

Co-Authored-By: Claude Opus 5 <noreply@anthropic.com>
</commit_message>
<xml_diff>
--- a/PharmaCare_紹介資料.pptx
+++ b/PharmaCare_紹介資料.pptx
@@ -3801,11 +3801,11 @@
         <p:spPr>
           <a:xfrm>
             <a:off x="731520" y="4160520"/>
-            <a:ext cx="10698480" cy="2011680"/>
+            <a:ext cx="10698480" cy="1463040"/>
           </a:xfrm>
           <a:prstGeom prst="roundRect">
             <a:avLst>
-              <a:gd name="adj" fmla="val 3636"/>
+              <a:gd name="adj" fmla="val 5000"/>
             </a:avLst>
           </a:prstGeom>
           <a:solidFill>
@@ -3827,7 +3827,7 @@
         </p:nvSpPr>
         <p:spPr>
           <a:xfrm>
-            <a:off x="1097280" y="4389120"/>
+            <a:off x="1097280" y="4407408"/>
             <a:ext cx="9601200" cy="411480"/>
           </a:xfrm>
           <a:prstGeom prst="rect">
@@ -3866,46 +3866,7 @@
         </p:nvSpPr>
         <p:spPr>
           <a:xfrm>
-            <a:off x="1097280" y="4846320"/>
-            <a:ext cx="9692640" cy="411480"/>
-          </a:xfrm>
-          <a:prstGeom prst="rect">
-            <a:avLst/>
-          </a:prstGeom>
-          <a:noFill/>
-          <a:ln/>
-        </p:spPr>
-        <p:txBody>
-          <a:bodyPr wrap="square" lIns="0" tIns="0" rIns="0" bIns="0" rtlCol="0" anchor="ctr"/>
-          <a:lstStyle/>
-          <a:p>
-            <a:pPr indent="0" marL="0">
-              <a:buNone/>
-            </a:pPr>
-            <a:r>
-              <a:rPr lang="en-US" sz="1500" dirty="0">
-                <a:solidFill>
-                  <a:srgbClr val="A8CFC9"/>
-                </a:solidFill>
-                <a:latin typeface="Yu Gothic" pitchFamily="34" charset="0"/>
-                <a:ea typeface="Yu Gothic" pitchFamily="34" charset="-122"/>
-                <a:cs typeface="Yu Gothic" pitchFamily="34" charset="-120"/>
-              </a:rPr>
-              <a:t>条文を先に読み、そこから必要な機能を起こしました。ガイドラインごとに、対応表と、その中身をかみ砕いた解説を1枚ずつ置きます。</a:t>
-            </a:r>
-            <a:endParaRPr lang="en-US" sz="1500" dirty="0"/>
-          </a:p>
-        </p:txBody>
-      </p:sp>
-      <p:sp>
-        <p:nvSpPr>
-          <p:cNvPr id="15" name="Text 13"/>
-          <p:cNvSpPr/>
-          <p:nvPr/>
-        </p:nvSpPr>
-        <p:spPr>
-          <a:xfrm>
-            <a:off x="1097280" y="5440680"/>
+            <a:off x="1097280" y="4937760"/>
             <a:ext cx="9692640" cy="411480"/>
           </a:xfrm>
           <a:prstGeom prst="rect">
@@ -22167,45 +22128,6 @@
               <a:t>トリアージの判定を決める</a:t>
             </a:r>
             <a:endParaRPr lang="en-US" sz="1400" dirty="0"/>
-          </a:p>
-        </p:txBody>
-      </p:sp>
-      <p:sp>
-        <p:nvSpPr>
-          <p:cNvPr id="17" name="Text 15"/>
-          <p:cNvSpPr/>
-          <p:nvPr/>
-        </p:nvSpPr>
-        <p:spPr>
-          <a:xfrm>
-            <a:off x="822960" y="5989320"/>
-            <a:ext cx="10515600" cy="411480"/>
-          </a:xfrm>
-          <a:prstGeom prst="rect">
-            <a:avLst/>
-          </a:prstGeom>
-          <a:noFill/>
-          <a:ln/>
-        </p:spPr>
-        <p:txBody>
-          <a:bodyPr wrap="square" lIns="0" tIns="0" rIns="0" bIns="0" rtlCol="0" anchor="ctr"/>
-          <a:lstStyle/>
-          <a:p>
-            <a:pPr indent="0" marL="0">
-              <a:buNone/>
-            </a:pPr>
-            <a:r>
-              <a:rPr lang="en-US" sz="1500" i="1" dirty="0">
-                <a:solidFill>
-                  <a:srgbClr val="FFFFFF"/>
-                </a:solidFill>
-                <a:latin typeface="Yu Gothic" pitchFamily="34" charset="0"/>
-                <a:ea typeface="Yu Gothic" pitchFamily="34" charset="-122"/>
-                <a:cs typeface="Yu Gothic" pitchFamily="34" charset="-120"/>
-              </a:rPr>
-              <a:t>AIが使えない状況でも、判定そのものはアプリだけで返ります。</a:t>
-            </a:r>
-            <a:endParaRPr lang="en-US" sz="1500" dirty="0"/>
           </a:p>
         </p:txBody>
       </p:sp>

</xml_diff>